<commit_message>
combined results need to fix fixed control sim to acount for radiation damping update
</commit_message>
<xml_diff>
--- a/Presentation/wave_energy_presentation.pptx
+++ b/Presentation/wave_energy_presentation.pptx
@@ -4,21 +4,27 @@
   <p:sldMasterIdLst>
     <p:sldMasterId id="2147483708" r:id="rId1"/>
   </p:sldMasterIdLst>
+  <p:notesMasterIdLst>
+    <p:notesMasterId r:id="rId19"/>
+  </p:notesMasterIdLst>
   <p:sldIdLst>
     <p:sldId id="256" r:id="rId2"/>
     <p:sldId id="257" r:id="rId3"/>
     <p:sldId id="258" r:id="rId4"/>
     <p:sldId id="259" r:id="rId5"/>
-    <p:sldId id="261" r:id="rId6"/>
-    <p:sldId id="260" r:id="rId7"/>
-    <p:sldId id="270" r:id="rId8"/>
-    <p:sldId id="271" r:id="rId9"/>
-    <p:sldId id="272" r:id="rId10"/>
-    <p:sldId id="273" r:id="rId11"/>
-    <p:sldId id="274" r:id="rId12"/>
-    <p:sldId id="267" r:id="rId13"/>
-    <p:sldId id="269" r:id="rId14"/>
-    <p:sldId id="268" r:id="rId15"/>
+    <p:sldId id="284" r:id="rId6"/>
+    <p:sldId id="261" r:id="rId7"/>
+    <p:sldId id="260" r:id="rId8"/>
+    <p:sldId id="270" r:id="rId9"/>
+    <p:sldId id="285" r:id="rId10"/>
+    <p:sldId id="271" r:id="rId11"/>
+    <p:sldId id="272" r:id="rId12"/>
+    <p:sldId id="273" r:id="rId13"/>
+    <p:sldId id="274" r:id="rId14"/>
+    <p:sldId id="286" r:id="rId15"/>
+    <p:sldId id="267" r:id="rId16"/>
+    <p:sldId id="269" r:id="rId17"/>
+    <p:sldId id="268" r:id="rId18"/>
   </p:sldIdLst>
   <p:sldSz cx="12192000" cy="6858000"/>
   <p:notesSz cx="6858000" cy="9144000"/>
@@ -134,6 +140,704 @@
     </p:ext>
   </p:extLst>
 </p:presentation>
+</file>
+
+<file path=ppt/revisionInfo.xml><?xml version="1.0" encoding="utf-8"?>
+<p1510:revInfo xmlns:a="http://schemas.openxmlformats.org/drawingml/2006/main" xmlns:r="http://schemas.openxmlformats.org/officeDocument/2006/relationships" xmlns:p1510="http://schemas.microsoft.com/office/powerpoint/2015/10/main">
+  <p1510:revLst>
+    <p1510:client id="{3727D3B2-4173-274F-9A53-F0F97D6C95B1}" v="123" dt="2026-04-15T13:12:53.139"/>
+  </p1510:revLst>
+</p1510:revInfo>
+</file>
+
+<file path=ppt/changesInfos/changesInfo1.xml><?xml version="1.0" encoding="utf-8"?>
+<pc:chgInfo xmlns:a="http://schemas.openxmlformats.org/drawingml/2006/main" xmlns:r="http://schemas.openxmlformats.org/officeDocument/2006/relationships" xmlns:ac="http://schemas.microsoft.com/office/drawing/2013/main/command" xmlns:pc="http://schemas.microsoft.com/office/powerpoint/2013/main/command">
+  <pc:docChgLst>
+    <pc:chgData name="Ollie Mann" userId="S::ay24363@bristol.ac.uk::a0eb56d1-fb22-43c6-a169-5e547426f1b4" providerId="AD" clId="Web-{4350D7C5-0BEE-F6E2-C3E7-64D2A72B256E}"/>
+    <pc:docChg chg="addSld delSld modSld sldOrd">
+      <pc:chgData name="Ollie Mann" userId="S::ay24363@bristol.ac.uk::a0eb56d1-fb22-43c6-a169-5e547426f1b4" providerId="AD" clId="Web-{4350D7C5-0BEE-F6E2-C3E7-64D2A72B256E}" dt="2026-04-13T13:39:07.656" v="245" actId="20577"/>
+      <pc:docMkLst>
+        <pc:docMk/>
+      </pc:docMkLst>
+      <pc:sldChg chg="modSp">
+        <pc:chgData name="Ollie Mann" userId="S::ay24363@bristol.ac.uk::a0eb56d1-fb22-43c6-a169-5e547426f1b4" providerId="AD" clId="Web-{4350D7C5-0BEE-F6E2-C3E7-64D2A72B256E}" dt="2026-04-13T13:14:32.034" v="18" actId="20577"/>
+        <pc:sldMkLst>
+          <pc:docMk/>
+          <pc:sldMk cId="1816702450" sldId="270"/>
+        </pc:sldMkLst>
+        <pc:spChg chg="mod">
+          <ac:chgData name="Ollie Mann" userId="S::ay24363@bristol.ac.uk::a0eb56d1-fb22-43c6-a169-5e547426f1b4" providerId="AD" clId="Web-{4350D7C5-0BEE-F6E2-C3E7-64D2A72B256E}" dt="2026-04-13T13:14:32.034" v="18" actId="20577"/>
+          <ac:spMkLst>
+            <pc:docMk/>
+            <pc:sldMk cId="1816702450" sldId="270"/>
+            <ac:spMk id="3" creationId="{4FA8648E-2CC6-5C90-6D7F-7B4C6B84CEA7}"/>
+          </ac:spMkLst>
+        </pc:spChg>
+      </pc:sldChg>
+      <pc:sldChg chg="modSp new">
+        <pc:chgData name="Ollie Mann" userId="S::ay24363@bristol.ac.uk::a0eb56d1-fb22-43c6-a169-5e547426f1b4" providerId="AD" clId="Web-{4350D7C5-0BEE-F6E2-C3E7-64D2A72B256E}" dt="2026-04-13T13:24:23.506" v="94" actId="20577"/>
+        <pc:sldMkLst>
+          <pc:docMk/>
+          <pc:sldMk cId="772203802" sldId="284"/>
+        </pc:sldMkLst>
+        <pc:spChg chg="mod">
+          <ac:chgData name="Ollie Mann" userId="S::ay24363@bristol.ac.uk::a0eb56d1-fb22-43c6-a169-5e547426f1b4" providerId="AD" clId="Web-{4350D7C5-0BEE-F6E2-C3E7-64D2A72B256E}" dt="2026-04-13T13:24:23.506" v="94" actId="20577"/>
+          <ac:spMkLst>
+            <pc:docMk/>
+            <pc:sldMk cId="772203802" sldId="284"/>
+            <ac:spMk id="2" creationId="{3C8CAC2E-D5A4-E351-1066-B4F8249862B8}"/>
+          </ac:spMkLst>
+        </pc:spChg>
+      </pc:sldChg>
+      <pc:sldChg chg="addSp delSp modSp new mod ord modClrScheme chgLayout">
+        <pc:chgData name="Ollie Mann" userId="S::ay24363@bristol.ac.uk::a0eb56d1-fb22-43c6-a169-5e547426f1b4" providerId="AD" clId="Web-{4350D7C5-0BEE-F6E2-C3E7-64D2A72B256E}" dt="2026-04-13T13:39:07.656" v="245" actId="20577"/>
+        <pc:sldMkLst>
+          <pc:docMk/>
+          <pc:sldMk cId="2286299515" sldId="285"/>
+        </pc:sldMkLst>
+        <pc:spChg chg="mod ord">
+          <ac:chgData name="Ollie Mann" userId="S::ay24363@bristol.ac.uk::a0eb56d1-fb22-43c6-a169-5e547426f1b4" providerId="AD" clId="Web-{4350D7C5-0BEE-F6E2-C3E7-64D2A72B256E}" dt="2026-04-13T13:32:29.288" v="213" actId="20577"/>
+          <ac:spMkLst>
+            <pc:docMk/>
+            <pc:sldMk cId="2286299515" sldId="285"/>
+            <ac:spMk id="2" creationId="{85A3875A-E3A2-19F7-F16F-24C2AB831E1C}"/>
+          </ac:spMkLst>
+        </pc:spChg>
+        <pc:spChg chg="mod ord">
+          <ac:chgData name="Ollie Mann" userId="S::ay24363@bristol.ac.uk::a0eb56d1-fb22-43c6-a169-5e547426f1b4" providerId="AD" clId="Web-{4350D7C5-0BEE-F6E2-C3E7-64D2A72B256E}" dt="2026-04-13T13:39:07.656" v="245" actId="20577"/>
+          <ac:spMkLst>
+            <pc:docMk/>
+            <pc:sldMk cId="2286299515" sldId="285"/>
+            <ac:spMk id="3" creationId="{B797F24D-CDB9-F700-E7E1-F9FA956E9D86}"/>
+          </ac:spMkLst>
+        </pc:spChg>
+        <pc:spChg chg="add mod ord">
+          <ac:chgData name="Ollie Mann" userId="S::ay24363@bristol.ac.uk::a0eb56d1-fb22-43c6-a169-5e547426f1b4" providerId="AD" clId="Web-{4350D7C5-0BEE-F6E2-C3E7-64D2A72B256E}" dt="2026-04-13T13:29:51.816" v="157" actId="14100"/>
+          <ac:spMkLst>
+            <pc:docMk/>
+            <pc:sldMk cId="2286299515" sldId="285"/>
+            <ac:spMk id="4" creationId="{1DAC204E-F5D6-0C39-43C7-D92A65662698}"/>
+          </ac:spMkLst>
+        </pc:spChg>
+        <pc:spChg chg="add mod">
+          <ac:chgData name="Ollie Mann" userId="S::ay24363@bristol.ac.uk::a0eb56d1-fb22-43c6-a169-5e547426f1b4" providerId="AD" clId="Web-{4350D7C5-0BEE-F6E2-C3E7-64D2A72B256E}" dt="2026-04-13T13:33:29.326" v="237" actId="20577"/>
+          <ac:spMkLst>
+            <pc:docMk/>
+            <pc:sldMk cId="2286299515" sldId="285"/>
+            <ac:spMk id="8" creationId="{58985922-472D-B16A-7835-A1E728AFC3E8}"/>
+          </ac:spMkLst>
+        </pc:spChg>
+        <pc:spChg chg="add mod">
+          <ac:chgData name="Ollie Mann" userId="S::ay24363@bristol.ac.uk::a0eb56d1-fb22-43c6-a169-5e547426f1b4" providerId="AD" clId="Web-{4350D7C5-0BEE-F6E2-C3E7-64D2A72B256E}" dt="2026-04-13T13:30:08.394" v="164" actId="1076"/>
+          <ac:spMkLst>
+            <pc:docMk/>
+            <pc:sldMk cId="2286299515" sldId="285"/>
+            <ac:spMk id="10" creationId="{A306D060-8843-8859-9D15-CA50FFDA67DE}"/>
+          </ac:spMkLst>
+        </pc:spChg>
+        <pc:spChg chg="add mod">
+          <ac:chgData name="Ollie Mann" userId="S::ay24363@bristol.ac.uk::a0eb56d1-fb22-43c6-a169-5e547426f1b4" providerId="AD" clId="Web-{4350D7C5-0BEE-F6E2-C3E7-64D2A72B256E}" dt="2026-04-13T13:30:28.192" v="166" actId="1076"/>
+          <ac:spMkLst>
+            <pc:docMk/>
+            <pc:sldMk cId="2286299515" sldId="285"/>
+            <ac:spMk id="14" creationId="{937B966B-77AE-B788-C527-146DBD98B8AC}"/>
+          </ac:spMkLst>
+        </pc:spChg>
+        <pc:spChg chg="add mod">
+          <ac:chgData name="Ollie Mann" userId="S::ay24363@bristol.ac.uk::a0eb56d1-fb22-43c6-a169-5e547426f1b4" providerId="AD" clId="Web-{4350D7C5-0BEE-F6E2-C3E7-64D2A72B256E}" dt="2026-04-13T13:33:32.842" v="239" actId="20577"/>
+          <ac:spMkLst>
+            <pc:docMk/>
+            <pc:sldMk cId="2286299515" sldId="285"/>
+            <ac:spMk id="19" creationId="{5256D2AB-7736-2765-FD19-892AE06456E0}"/>
+          </ac:spMkLst>
+        </pc:spChg>
+      </pc:sldChg>
+    </pc:docChg>
+  </pc:docChgLst>
+  <pc:docChgLst>
+    <pc:chgData name="Ollie Mann" userId="a0eb56d1-fb22-43c6-a169-5e547426f1b4" providerId="ADAL" clId="{203428FF-DFBC-548F-AEEE-93FB93E67FB2}"/>
+    <pc:docChg chg="undo custSel modSld">
+      <pc:chgData name="Ollie Mann" userId="a0eb56d1-fb22-43c6-a169-5e547426f1b4" providerId="ADAL" clId="{203428FF-DFBC-548F-AEEE-93FB93E67FB2}" dt="2026-04-15T13:12:53.135" v="1516" actId="20577"/>
+      <pc:docMkLst>
+        <pc:docMk/>
+      </pc:docMkLst>
+      <pc:sldChg chg="addSp delSp modSp mod">
+        <pc:chgData name="Ollie Mann" userId="a0eb56d1-fb22-43c6-a169-5e547426f1b4" providerId="ADAL" clId="{203428FF-DFBC-548F-AEEE-93FB93E67FB2}" dt="2026-04-15T13:06:36.679" v="1457"/>
+        <pc:sldMkLst>
+          <pc:docMk/>
+          <pc:sldMk cId="0" sldId="256"/>
+        </pc:sldMkLst>
+        <pc:spChg chg="add del mod">
+          <ac:chgData name="Ollie Mann" userId="a0eb56d1-fb22-43c6-a169-5e547426f1b4" providerId="ADAL" clId="{203428FF-DFBC-548F-AEEE-93FB93E67FB2}" dt="2026-04-15T13:06:36.679" v="1457"/>
+          <ac:spMkLst>
+            <pc:docMk/>
+            <pc:sldMk cId="0" sldId="256"/>
+            <ac:spMk id="4" creationId="{2E1AD07F-896A-7F7A-9E46-B11587ACE534}"/>
+          </ac:spMkLst>
+        </pc:spChg>
+      </pc:sldChg>
+      <pc:sldChg chg="modSp mod">
+        <pc:chgData name="Ollie Mann" userId="a0eb56d1-fb22-43c6-a169-5e547426f1b4" providerId="ADAL" clId="{203428FF-DFBC-548F-AEEE-93FB93E67FB2}" dt="2026-04-15T13:12:53.135" v="1516" actId="20577"/>
+        <pc:sldMkLst>
+          <pc:docMk/>
+          <pc:sldMk cId="772203802" sldId="284"/>
+        </pc:sldMkLst>
+        <pc:spChg chg="mod">
+          <ac:chgData name="Ollie Mann" userId="a0eb56d1-fb22-43c6-a169-5e547426f1b4" providerId="ADAL" clId="{203428FF-DFBC-548F-AEEE-93FB93E67FB2}" dt="2026-04-15T13:12:53.135" v="1516" actId="20577"/>
+          <ac:spMkLst>
+            <pc:docMk/>
+            <pc:sldMk cId="772203802" sldId="284"/>
+            <ac:spMk id="3" creationId="{BB244909-EFB2-E390-DF7C-016465B37DEA}"/>
+          </ac:spMkLst>
+        </pc:spChg>
+      </pc:sldChg>
+      <pc:sldChg chg="addSp delSp modSp mod modNotesTx">
+        <pc:chgData name="Ollie Mann" userId="a0eb56d1-fb22-43c6-a169-5e547426f1b4" providerId="ADAL" clId="{203428FF-DFBC-548F-AEEE-93FB93E67FB2}" dt="2026-04-14T11:34:37.600" v="646" actId="20577"/>
+        <pc:sldMkLst>
+          <pc:docMk/>
+          <pc:sldMk cId="2286299515" sldId="285"/>
+        </pc:sldMkLst>
+        <pc:spChg chg="mod">
+          <ac:chgData name="Ollie Mann" userId="a0eb56d1-fb22-43c6-a169-5e547426f1b4" providerId="ADAL" clId="{203428FF-DFBC-548F-AEEE-93FB93E67FB2}" dt="2026-04-13T13:48:34.700" v="78" actId="14100"/>
+          <ac:spMkLst>
+            <pc:docMk/>
+            <pc:sldMk cId="2286299515" sldId="285"/>
+            <ac:spMk id="2" creationId="{85A3875A-E3A2-19F7-F16F-24C2AB831E1C}"/>
+          </ac:spMkLst>
+        </pc:spChg>
+        <pc:spChg chg="mod">
+          <ac:chgData name="Ollie Mann" userId="a0eb56d1-fb22-43c6-a169-5e547426f1b4" providerId="ADAL" clId="{203428FF-DFBC-548F-AEEE-93FB93E67FB2}" dt="2026-04-14T11:34:37.600" v="646" actId="20577"/>
+          <ac:spMkLst>
+            <pc:docMk/>
+            <pc:sldMk cId="2286299515" sldId="285"/>
+            <ac:spMk id="3" creationId="{B797F24D-CDB9-F700-E7E1-F9FA956E9D86}"/>
+          </ac:spMkLst>
+        </pc:spChg>
+        <pc:spChg chg="mod">
+          <ac:chgData name="Ollie Mann" userId="a0eb56d1-fb22-43c6-a169-5e547426f1b4" providerId="ADAL" clId="{203428FF-DFBC-548F-AEEE-93FB93E67FB2}" dt="2026-04-13T14:27:54.586" v="396" actId="1037"/>
+          <ac:spMkLst>
+            <pc:docMk/>
+            <pc:sldMk cId="2286299515" sldId="285"/>
+            <ac:spMk id="4" creationId="{1DAC204E-F5D6-0C39-43C7-D92A65662698}"/>
+          </ac:spMkLst>
+        </pc:spChg>
+        <pc:spChg chg="mod">
+          <ac:chgData name="Ollie Mann" userId="a0eb56d1-fb22-43c6-a169-5e547426f1b4" providerId="ADAL" clId="{203428FF-DFBC-548F-AEEE-93FB93E67FB2}" dt="2026-04-13T14:27:54.586" v="396" actId="1037"/>
+          <ac:spMkLst>
+            <pc:docMk/>
+            <pc:sldMk cId="2286299515" sldId="285"/>
+            <ac:spMk id="8" creationId="{58985922-472D-B16A-7835-A1E728AFC3E8}"/>
+          </ac:spMkLst>
+        </pc:spChg>
+        <pc:spChg chg="mod">
+          <ac:chgData name="Ollie Mann" userId="a0eb56d1-fb22-43c6-a169-5e547426f1b4" providerId="ADAL" clId="{203428FF-DFBC-548F-AEEE-93FB93E67FB2}" dt="2026-04-13T14:27:54.586" v="396" actId="1037"/>
+          <ac:spMkLst>
+            <pc:docMk/>
+            <pc:sldMk cId="2286299515" sldId="285"/>
+            <ac:spMk id="10" creationId="{A306D060-8843-8859-9D15-CA50FFDA67DE}"/>
+          </ac:spMkLst>
+        </pc:spChg>
+        <pc:spChg chg="mod">
+          <ac:chgData name="Ollie Mann" userId="a0eb56d1-fb22-43c6-a169-5e547426f1b4" providerId="ADAL" clId="{203428FF-DFBC-548F-AEEE-93FB93E67FB2}" dt="2026-04-13T14:27:54.586" v="396" actId="1037"/>
+          <ac:spMkLst>
+            <pc:docMk/>
+            <pc:sldMk cId="2286299515" sldId="285"/>
+            <ac:spMk id="14" creationId="{937B966B-77AE-B788-C527-146DBD98B8AC}"/>
+          </ac:spMkLst>
+        </pc:spChg>
+        <pc:spChg chg="mod">
+          <ac:chgData name="Ollie Mann" userId="a0eb56d1-fb22-43c6-a169-5e547426f1b4" providerId="ADAL" clId="{203428FF-DFBC-548F-AEEE-93FB93E67FB2}" dt="2026-04-13T14:27:54.586" v="396" actId="1037"/>
+          <ac:spMkLst>
+            <pc:docMk/>
+            <pc:sldMk cId="2286299515" sldId="285"/>
+            <ac:spMk id="19" creationId="{5256D2AB-7736-2765-FD19-892AE06456E0}"/>
+          </ac:spMkLst>
+        </pc:spChg>
+      </pc:sldChg>
+    </pc:docChg>
+  </pc:docChgLst>
+  <pc:docChgLst>
+    <pc:chgData name="Ed Schuster Bruce" userId="c42289d1-a3e5-485c-a3fe-df854c552fdb" providerId="ADAL" clId="{9A8B4455-0AA2-47B2-AC41-2D20ECF78631}"/>
+    <pc:docChg chg="undo custSel addSld modSld">
+      <pc:chgData name="Ed Schuster Bruce" userId="c42289d1-a3e5-485c-a3fe-df854c552fdb" providerId="ADAL" clId="{9A8B4455-0AA2-47B2-AC41-2D20ECF78631}" dt="2026-04-13T13:39:47.749" v="6776" actId="20577"/>
+      <pc:docMkLst>
+        <pc:docMk/>
+      </pc:docMkLst>
+      <pc:sldChg chg="addSp delSp modSp mod setBg">
+        <pc:chgData name="Ed Schuster Bruce" userId="c42289d1-a3e5-485c-a3fe-df854c552fdb" providerId="ADAL" clId="{9A8B4455-0AA2-47B2-AC41-2D20ECF78631}" dt="2026-04-13T08:15:06.621" v="36" actId="20577"/>
+        <pc:sldMkLst>
+          <pc:docMk/>
+          <pc:sldMk cId="0" sldId="256"/>
+        </pc:sldMkLst>
+        <pc:spChg chg="mod">
+          <ac:chgData name="Ed Schuster Bruce" userId="c42289d1-a3e5-485c-a3fe-df854c552fdb" providerId="ADAL" clId="{9A8B4455-0AA2-47B2-AC41-2D20ECF78631}" dt="2026-04-13T08:14:47.456" v="26" actId="20577"/>
+          <ac:spMkLst>
+            <pc:docMk/>
+            <pc:sldMk cId="0" sldId="256"/>
+            <ac:spMk id="2" creationId="{00000000-0000-0000-0000-000000000000}"/>
+          </ac:spMkLst>
+        </pc:spChg>
+        <pc:spChg chg="mod">
+          <ac:chgData name="Ed Schuster Bruce" userId="c42289d1-a3e5-485c-a3fe-df854c552fdb" providerId="ADAL" clId="{9A8B4455-0AA2-47B2-AC41-2D20ECF78631}" dt="2026-04-13T08:15:06.621" v="36" actId="20577"/>
+          <ac:spMkLst>
+            <pc:docMk/>
+            <pc:sldMk cId="0" sldId="256"/>
+            <ac:spMk id="3" creationId="{00000000-0000-0000-0000-000000000000}"/>
+          </ac:spMkLst>
+        </pc:spChg>
+        <pc:spChg chg="add">
+          <ac:chgData name="Ed Schuster Bruce" userId="c42289d1-a3e5-485c-a3fe-df854c552fdb" providerId="ADAL" clId="{9A8B4455-0AA2-47B2-AC41-2D20ECF78631}" dt="2026-04-13T08:14:13.247" v="9" actId="26606"/>
+          <ac:spMkLst>
+            <pc:docMk/>
+            <pc:sldMk cId="0" sldId="256"/>
+            <ac:spMk id="1038" creationId="{04812C46-200A-4DEB-A05E-3ED6C68C2387}"/>
+          </ac:spMkLst>
+        </pc:spChg>
+        <pc:spChg chg="add">
+          <ac:chgData name="Ed Schuster Bruce" userId="c42289d1-a3e5-485c-a3fe-df854c552fdb" providerId="ADAL" clId="{9A8B4455-0AA2-47B2-AC41-2D20ECF78631}" dt="2026-04-13T08:14:13.247" v="9" actId="26606"/>
+          <ac:spMkLst>
+            <pc:docMk/>
+            <pc:sldMk cId="0" sldId="256"/>
+            <ac:spMk id="1040" creationId="{D1EA859B-E555-4109-94F3-6700E046E008}"/>
+          </ac:spMkLst>
+        </pc:spChg>
+        <pc:picChg chg="add mod ord">
+          <ac:chgData name="Ed Schuster Bruce" userId="c42289d1-a3e5-485c-a3fe-df854c552fdb" providerId="ADAL" clId="{9A8B4455-0AA2-47B2-AC41-2D20ECF78631}" dt="2026-04-13T08:14:20.257" v="10" actId="14100"/>
+          <ac:picMkLst>
+            <pc:docMk/>
+            <pc:sldMk cId="0" sldId="256"/>
+            <ac:picMk id="1026" creationId="{2FDBE68B-5119-D897-6F2C-BD8F5942FAF1}"/>
+          </ac:picMkLst>
+        </pc:picChg>
+      </pc:sldChg>
+      <pc:sldChg chg="addSp delSp modSp mod setBg">
+        <pc:chgData name="Ed Schuster Bruce" userId="c42289d1-a3e5-485c-a3fe-df854c552fdb" providerId="ADAL" clId="{9A8B4455-0AA2-47B2-AC41-2D20ECF78631}" dt="2026-04-13T08:15:32.632" v="37" actId="26606"/>
+        <pc:sldMkLst>
+          <pc:docMk/>
+          <pc:sldMk cId="0" sldId="257"/>
+        </pc:sldMkLst>
+        <pc:spChg chg="mod">
+          <ac:chgData name="Ed Schuster Bruce" userId="c42289d1-a3e5-485c-a3fe-df854c552fdb" providerId="ADAL" clId="{9A8B4455-0AA2-47B2-AC41-2D20ECF78631}" dt="2026-04-13T08:15:32.632" v="37" actId="26606"/>
+          <ac:spMkLst>
+            <pc:docMk/>
+            <pc:sldMk cId="0" sldId="257"/>
+            <ac:spMk id="2" creationId="{00000000-0000-0000-0000-000000000000}"/>
+          </ac:spMkLst>
+        </pc:spChg>
+        <pc:spChg chg="add">
+          <ac:chgData name="Ed Schuster Bruce" userId="c42289d1-a3e5-485c-a3fe-df854c552fdb" providerId="ADAL" clId="{9A8B4455-0AA2-47B2-AC41-2D20ECF78631}" dt="2026-04-13T08:15:32.632" v="37" actId="26606"/>
+          <ac:spMkLst>
+            <pc:docMk/>
+            <pc:sldMk cId="0" sldId="257"/>
+            <ac:spMk id="16" creationId="{BACC6370-2D7E-4714-9D71-7542949D7D5D}"/>
+          </ac:spMkLst>
+        </pc:spChg>
+        <pc:spChg chg="add">
+          <ac:chgData name="Ed Schuster Bruce" userId="c42289d1-a3e5-485c-a3fe-df854c552fdb" providerId="ADAL" clId="{9A8B4455-0AA2-47B2-AC41-2D20ECF78631}" dt="2026-04-13T08:15:32.632" v="37" actId="26606"/>
+          <ac:spMkLst>
+            <pc:docMk/>
+            <pc:sldMk cId="0" sldId="257"/>
+            <ac:spMk id="18" creationId="{F68B3F68-107C-434F-AA38-110D5EA91B85}"/>
+          </ac:spMkLst>
+        </pc:spChg>
+        <pc:spChg chg="add">
+          <ac:chgData name="Ed Schuster Bruce" userId="c42289d1-a3e5-485c-a3fe-df854c552fdb" providerId="ADAL" clId="{9A8B4455-0AA2-47B2-AC41-2D20ECF78631}" dt="2026-04-13T08:15:32.632" v="37" actId="26606"/>
+          <ac:spMkLst>
+            <pc:docMk/>
+            <pc:sldMk cId="0" sldId="257"/>
+            <ac:spMk id="20" creationId="{AAD0DBB9-1A4B-4391-81D4-CB19F9AB918A}"/>
+          </ac:spMkLst>
+        </pc:spChg>
+        <pc:spChg chg="add">
+          <ac:chgData name="Ed Schuster Bruce" userId="c42289d1-a3e5-485c-a3fe-df854c552fdb" providerId="ADAL" clId="{9A8B4455-0AA2-47B2-AC41-2D20ECF78631}" dt="2026-04-13T08:15:32.632" v="37" actId="26606"/>
+          <ac:spMkLst>
+            <pc:docMk/>
+            <pc:sldMk cId="0" sldId="257"/>
+            <ac:spMk id="22" creationId="{063BBA22-50EA-4C4D-BE05-F1CE4E63AA56}"/>
+          </ac:spMkLst>
+        </pc:spChg>
+        <pc:graphicFrameChg chg="mod modGraphic">
+          <ac:chgData name="Ed Schuster Bruce" userId="c42289d1-a3e5-485c-a3fe-df854c552fdb" providerId="ADAL" clId="{9A8B4455-0AA2-47B2-AC41-2D20ECF78631}" dt="2026-04-13T08:15:32.632" v="37" actId="26606"/>
+          <ac:graphicFrameMkLst>
+            <pc:docMk/>
+            <pc:sldMk cId="0" sldId="257"/>
+            <ac:graphicFrameMk id="5" creationId="{30A69008-4E8A-DA04-EA9B-385EF1C0B0FE}"/>
+          </ac:graphicFrameMkLst>
+        </pc:graphicFrameChg>
+      </pc:sldChg>
+      <pc:sldChg chg="modSp mod">
+        <pc:chgData name="Ed Schuster Bruce" userId="c42289d1-a3e5-485c-a3fe-df854c552fdb" providerId="ADAL" clId="{9A8B4455-0AA2-47B2-AC41-2D20ECF78631}" dt="2026-04-13T08:17:02.938" v="54" actId="20577"/>
+        <pc:sldMkLst>
+          <pc:docMk/>
+          <pc:sldMk cId="0" sldId="258"/>
+        </pc:sldMkLst>
+        <pc:spChg chg="mod">
+          <ac:chgData name="Ed Schuster Bruce" userId="c42289d1-a3e5-485c-a3fe-df854c552fdb" providerId="ADAL" clId="{9A8B4455-0AA2-47B2-AC41-2D20ECF78631}" dt="2026-04-13T08:17:02.938" v="54" actId="20577"/>
+          <ac:spMkLst>
+            <pc:docMk/>
+            <pc:sldMk cId="0" sldId="258"/>
+            <ac:spMk id="2" creationId="{00000000-0000-0000-0000-000000000000}"/>
+          </ac:spMkLst>
+        </pc:spChg>
+      </pc:sldChg>
+      <pc:sldChg chg="modSp mod">
+        <pc:chgData name="Ed Schuster Bruce" userId="c42289d1-a3e5-485c-a3fe-df854c552fdb" providerId="ADAL" clId="{9A8B4455-0AA2-47B2-AC41-2D20ECF78631}" dt="2026-04-13T08:55:08.641" v="1801" actId="20577"/>
+        <pc:sldMkLst>
+          <pc:docMk/>
+          <pc:sldMk cId="0" sldId="261"/>
+        </pc:sldMkLst>
+        <pc:spChg chg="mod">
+          <ac:chgData name="Ed Schuster Bruce" userId="c42289d1-a3e5-485c-a3fe-df854c552fdb" providerId="ADAL" clId="{9A8B4455-0AA2-47B2-AC41-2D20ECF78631}" dt="2026-04-13T08:35:49.662" v="745" actId="20577"/>
+          <ac:spMkLst>
+            <pc:docMk/>
+            <pc:sldMk cId="0" sldId="261"/>
+            <ac:spMk id="2" creationId="{00000000-0000-0000-0000-000000000000}"/>
+          </ac:spMkLst>
+        </pc:spChg>
+        <pc:spChg chg="mod">
+          <ac:chgData name="Ed Schuster Bruce" userId="c42289d1-a3e5-485c-a3fe-df854c552fdb" providerId="ADAL" clId="{9A8B4455-0AA2-47B2-AC41-2D20ECF78631}" dt="2026-04-13T08:55:08.641" v="1801" actId="20577"/>
+          <ac:spMkLst>
+            <pc:docMk/>
+            <pc:sldMk cId="0" sldId="261"/>
+            <ac:spMk id="3" creationId="{00000000-0000-0000-0000-000000000000}"/>
+          </ac:spMkLst>
+        </pc:spChg>
+      </pc:sldChg>
+      <pc:sldChg chg="modSp mod">
+        <pc:chgData name="Ed Schuster Bruce" userId="c42289d1-a3e5-485c-a3fe-df854c552fdb" providerId="ADAL" clId="{9A8B4455-0AA2-47B2-AC41-2D20ECF78631}" dt="2026-04-13T10:08:10.305" v="5400" actId="20577"/>
+        <pc:sldMkLst>
+          <pc:docMk/>
+          <pc:sldMk cId="1816702450" sldId="270"/>
+        </pc:sldMkLst>
+        <pc:spChg chg="mod">
+          <ac:chgData name="Ed Schuster Bruce" userId="c42289d1-a3e5-485c-a3fe-df854c552fdb" providerId="ADAL" clId="{9A8B4455-0AA2-47B2-AC41-2D20ECF78631}" dt="2026-04-13T10:07:19.578" v="5354" actId="20577"/>
+          <ac:spMkLst>
+            <pc:docMk/>
+            <pc:sldMk cId="1816702450" sldId="270"/>
+            <ac:spMk id="2" creationId="{9F9BECB5-292C-0FAC-BE94-DB7EA28D3F39}"/>
+          </ac:spMkLst>
+        </pc:spChg>
+        <pc:spChg chg="mod">
+          <ac:chgData name="Ed Schuster Bruce" userId="c42289d1-a3e5-485c-a3fe-df854c552fdb" providerId="ADAL" clId="{9A8B4455-0AA2-47B2-AC41-2D20ECF78631}" dt="2026-04-13T10:08:10.305" v="5400" actId="20577"/>
+          <ac:spMkLst>
+            <pc:docMk/>
+            <pc:sldMk cId="1816702450" sldId="270"/>
+            <ac:spMk id="3" creationId="{4FA8648E-2CC6-5C90-6D7F-7B4C6B84CEA7}"/>
+          </ac:spMkLst>
+        </pc:spChg>
+      </pc:sldChg>
+      <pc:sldChg chg="modSp mod">
+        <pc:chgData name="Ed Schuster Bruce" userId="c42289d1-a3e5-485c-a3fe-df854c552fdb" providerId="ADAL" clId="{9A8B4455-0AA2-47B2-AC41-2D20ECF78631}" dt="2026-04-13T13:37:02.979" v="6775" actId="20577"/>
+        <pc:sldMkLst>
+          <pc:docMk/>
+          <pc:sldMk cId="1666967590" sldId="271"/>
+        </pc:sldMkLst>
+        <pc:spChg chg="mod">
+          <ac:chgData name="Ed Schuster Bruce" userId="c42289d1-a3e5-485c-a3fe-df854c552fdb" providerId="ADAL" clId="{9A8B4455-0AA2-47B2-AC41-2D20ECF78631}" dt="2026-04-13T13:37:02.979" v="6775" actId="20577"/>
+          <ac:spMkLst>
+            <pc:docMk/>
+            <pc:sldMk cId="1666967590" sldId="271"/>
+            <ac:spMk id="3" creationId="{58711827-53E6-D470-9DB2-DD5BC63D6AA5}"/>
+          </ac:spMkLst>
+        </pc:spChg>
+      </pc:sldChg>
+      <pc:sldChg chg="modSp mod">
+        <pc:chgData name="Ed Schuster Bruce" userId="c42289d1-a3e5-485c-a3fe-df854c552fdb" providerId="ADAL" clId="{9A8B4455-0AA2-47B2-AC41-2D20ECF78631}" dt="2026-04-13T13:39:47.749" v="6776" actId="20577"/>
+        <pc:sldMkLst>
+          <pc:docMk/>
+          <pc:sldMk cId="2769188522" sldId="273"/>
+        </pc:sldMkLst>
+        <pc:spChg chg="mod">
+          <ac:chgData name="Ed Schuster Bruce" userId="c42289d1-a3e5-485c-a3fe-df854c552fdb" providerId="ADAL" clId="{9A8B4455-0AA2-47B2-AC41-2D20ECF78631}" dt="2026-04-13T13:39:47.749" v="6776" actId="20577"/>
+          <ac:spMkLst>
+            <pc:docMk/>
+            <pc:sldMk cId="2769188522" sldId="273"/>
+            <ac:spMk id="3" creationId="{5B5564A4-2AD2-8026-4B1C-E389C8A601E7}"/>
+          </ac:spMkLst>
+        </pc:spChg>
+      </pc:sldChg>
+      <pc:sldChg chg="modSp new mod">
+        <pc:chgData name="Ed Schuster Bruce" userId="c42289d1-a3e5-485c-a3fe-df854c552fdb" providerId="ADAL" clId="{9A8B4455-0AA2-47B2-AC41-2D20ECF78631}" dt="2026-04-13T09:27:34.083" v="3050" actId="113"/>
+        <pc:sldMkLst>
+          <pc:docMk/>
+          <pc:sldMk cId="2399991856" sldId="275"/>
+        </pc:sldMkLst>
+        <pc:spChg chg="mod">
+          <ac:chgData name="Ed Schuster Bruce" userId="c42289d1-a3e5-485c-a3fe-df854c552fdb" providerId="ADAL" clId="{9A8B4455-0AA2-47B2-AC41-2D20ECF78631}" dt="2026-04-13T08:40:41.645" v="961" actId="20577"/>
+          <ac:spMkLst>
+            <pc:docMk/>
+            <pc:sldMk cId="2399991856" sldId="275"/>
+            <ac:spMk id="2" creationId="{AFBAC6E9-EFD2-E372-4AD7-70E95781A38C}"/>
+          </ac:spMkLst>
+        </pc:spChg>
+        <pc:spChg chg="mod">
+          <ac:chgData name="Ed Schuster Bruce" userId="c42289d1-a3e5-485c-a3fe-df854c552fdb" providerId="ADAL" clId="{9A8B4455-0AA2-47B2-AC41-2D20ECF78631}" dt="2026-04-13T09:27:34.083" v="3050" actId="113"/>
+          <ac:spMkLst>
+            <pc:docMk/>
+            <pc:sldMk cId="2399991856" sldId="275"/>
+            <ac:spMk id="3" creationId="{AA15FFDA-3E56-7CCC-A10C-878192ABC545}"/>
+          </ac:spMkLst>
+        </pc:spChg>
+      </pc:sldChg>
+      <pc:sldChg chg="modSp add mod">
+        <pc:chgData name="Ed Schuster Bruce" userId="c42289d1-a3e5-485c-a3fe-df854c552fdb" providerId="ADAL" clId="{9A8B4455-0AA2-47B2-AC41-2D20ECF78631}" dt="2026-04-13T09:27:17.484" v="3047" actId="113"/>
+        <pc:sldMkLst>
+          <pc:docMk/>
+          <pc:sldMk cId="3205175469" sldId="276"/>
+        </pc:sldMkLst>
+        <pc:spChg chg="mod">
+          <ac:chgData name="Ed Schuster Bruce" userId="c42289d1-a3e5-485c-a3fe-df854c552fdb" providerId="ADAL" clId="{9A8B4455-0AA2-47B2-AC41-2D20ECF78631}" dt="2026-04-13T09:27:17.484" v="3047" actId="113"/>
+          <ac:spMkLst>
+            <pc:docMk/>
+            <pc:sldMk cId="3205175469" sldId="276"/>
+            <ac:spMk id="3" creationId="{2E2E419C-ED51-E0EC-C3DA-266863473B4C}"/>
+          </ac:spMkLst>
+        </pc:spChg>
+      </pc:sldChg>
+      <pc:sldChg chg="modSp add mod">
+        <pc:chgData name="Ed Schuster Bruce" userId="c42289d1-a3e5-485c-a3fe-df854c552fdb" providerId="ADAL" clId="{9A8B4455-0AA2-47B2-AC41-2D20ECF78631}" dt="2026-04-13T09:35:52.711" v="3544" actId="27636"/>
+        <pc:sldMkLst>
+          <pc:docMk/>
+          <pc:sldMk cId="2467392672" sldId="277"/>
+        </pc:sldMkLst>
+        <pc:spChg chg="mod">
+          <ac:chgData name="Ed Schuster Bruce" userId="c42289d1-a3e5-485c-a3fe-df854c552fdb" providerId="ADAL" clId="{9A8B4455-0AA2-47B2-AC41-2D20ECF78631}" dt="2026-04-13T09:35:52.711" v="3544" actId="27636"/>
+          <ac:spMkLst>
+            <pc:docMk/>
+            <pc:sldMk cId="2467392672" sldId="277"/>
+            <ac:spMk id="3" creationId="{D7C5537E-8148-2F3E-E6F1-389620C2CB35}"/>
+          </ac:spMkLst>
+        </pc:spChg>
+      </pc:sldChg>
+      <pc:sldChg chg="modSp add mod">
+        <pc:chgData name="Ed Schuster Bruce" userId="c42289d1-a3e5-485c-a3fe-df854c552fdb" providerId="ADAL" clId="{9A8B4455-0AA2-47B2-AC41-2D20ECF78631}" dt="2026-04-13T10:05:06.172" v="5204" actId="20577"/>
+        <pc:sldMkLst>
+          <pc:docMk/>
+          <pc:sldMk cId="1952117880" sldId="278"/>
+        </pc:sldMkLst>
+        <pc:spChg chg="mod">
+          <ac:chgData name="Ed Schuster Bruce" userId="c42289d1-a3e5-485c-a3fe-df854c552fdb" providerId="ADAL" clId="{9A8B4455-0AA2-47B2-AC41-2D20ECF78631}" dt="2026-04-13T10:05:06.172" v="5204" actId="20577"/>
+          <ac:spMkLst>
+            <pc:docMk/>
+            <pc:sldMk cId="1952117880" sldId="278"/>
+            <ac:spMk id="3" creationId="{88E1B830-1F0A-07A5-500D-A72F0B4B54EA}"/>
+          </ac:spMkLst>
+        </pc:spChg>
+      </pc:sldChg>
+      <pc:sldChg chg="modSp add mod">
+        <pc:chgData name="Ed Schuster Bruce" userId="c42289d1-a3e5-485c-a3fe-df854c552fdb" providerId="ADAL" clId="{9A8B4455-0AA2-47B2-AC41-2D20ECF78631}" dt="2026-04-13T10:03:08.907" v="5129" actId="20577"/>
+        <pc:sldMkLst>
+          <pc:docMk/>
+          <pc:sldMk cId="1616180076" sldId="279"/>
+        </pc:sldMkLst>
+        <pc:spChg chg="mod">
+          <ac:chgData name="Ed Schuster Bruce" userId="c42289d1-a3e5-485c-a3fe-df854c552fdb" providerId="ADAL" clId="{9A8B4455-0AA2-47B2-AC41-2D20ECF78631}" dt="2026-04-13T09:45:52.273" v="3869" actId="20577"/>
+          <ac:spMkLst>
+            <pc:docMk/>
+            <pc:sldMk cId="1616180076" sldId="279"/>
+            <ac:spMk id="2" creationId="{589D0DAE-CF73-A2AF-4C05-F3575666884A}"/>
+          </ac:spMkLst>
+        </pc:spChg>
+        <pc:spChg chg="mod">
+          <ac:chgData name="Ed Schuster Bruce" userId="c42289d1-a3e5-485c-a3fe-df854c552fdb" providerId="ADAL" clId="{9A8B4455-0AA2-47B2-AC41-2D20ECF78631}" dt="2026-04-13T10:03:08.907" v="5129" actId="20577"/>
+          <ac:spMkLst>
+            <pc:docMk/>
+            <pc:sldMk cId="1616180076" sldId="279"/>
+            <ac:spMk id="3" creationId="{DA49D694-DDFC-EF08-2C7D-EFE4BE2BA302}"/>
+          </ac:spMkLst>
+        </pc:spChg>
+      </pc:sldChg>
+      <pc:sldChg chg="modSp add mod">
+        <pc:chgData name="Ed Schuster Bruce" userId="c42289d1-a3e5-485c-a3fe-df854c552fdb" providerId="ADAL" clId="{9A8B4455-0AA2-47B2-AC41-2D20ECF78631}" dt="2026-04-13T10:06:54.104" v="5343" actId="20577"/>
+        <pc:sldMkLst>
+          <pc:docMk/>
+          <pc:sldMk cId="916908673" sldId="280"/>
+        </pc:sldMkLst>
+        <pc:spChg chg="mod">
+          <ac:chgData name="Ed Schuster Bruce" userId="c42289d1-a3e5-485c-a3fe-df854c552fdb" providerId="ADAL" clId="{9A8B4455-0AA2-47B2-AC41-2D20ECF78631}" dt="2026-04-13T10:06:54.104" v="5343" actId="20577"/>
+          <ac:spMkLst>
+            <pc:docMk/>
+            <pc:sldMk cId="916908673" sldId="280"/>
+            <ac:spMk id="2" creationId="{6FCD2CEF-9C1E-73FB-4ECB-2AF4041CF115}"/>
+          </ac:spMkLst>
+        </pc:spChg>
+        <pc:spChg chg="mod">
+          <ac:chgData name="Ed Schuster Bruce" userId="c42289d1-a3e5-485c-a3fe-df854c552fdb" providerId="ADAL" clId="{9A8B4455-0AA2-47B2-AC41-2D20ECF78631}" dt="2026-04-13T10:06:39.196" v="5284" actId="5793"/>
+          <ac:spMkLst>
+            <pc:docMk/>
+            <pc:sldMk cId="916908673" sldId="280"/>
+            <ac:spMk id="3" creationId="{620804E2-91EA-7C7A-A212-0571D409163C}"/>
+          </ac:spMkLst>
+        </pc:spChg>
+      </pc:sldChg>
+      <pc:sldChg chg="modSp new mod">
+        <pc:chgData name="Ed Schuster Bruce" userId="c42289d1-a3e5-485c-a3fe-df854c552fdb" providerId="ADAL" clId="{9A8B4455-0AA2-47B2-AC41-2D20ECF78631}" dt="2026-04-13T12:31:28.416" v="6746" actId="2710"/>
+        <pc:sldMkLst>
+          <pc:docMk/>
+          <pc:sldMk cId="1924820731" sldId="281"/>
+        </pc:sldMkLst>
+        <pc:spChg chg="mod">
+          <ac:chgData name="Ed Schuster Bruce" userId="c42289d1-a3e5-485c-a3fe-df854c552fdb" providerId="ADAL" clId="{9A8B4455-0AA2-47B2-AC41-2D20ECF78631}" dt="2026-04-13T10:08:53.723" v="5433" actId="20577"/>
+          <ac:spMkLst>
+            <pc:docMk/>
+            <pc:sldMk cId="1924820731" sldId="281"/>
+            <ac:spMk id="2" creationId="{2F48F694-A675-7A1B-EF42-1777B5AD5CF4}"/>
+          </ac:spMkLst>
+        </pc:spChg>
+        <pc:spChg chg="mod">
+          <ac:chgData name="Ed Schuster Bruce" userId="c42289d1-a3e5-485c-a3fe-df854c552fdb" providerId="ADAL" clId="{9A8B4455-0AA2-47B2-AC41-2D20ECF78631}" dt="2026-04-13T12:31:28.416" v="6746" actId="2710"/>
+          <ac:spMkLst>
+            <pc:docMk/>
+            <pc:sldMk cId="1924820731" sldId="281"/>
+            <ac:spMk id="3" creationId="{E43ABCDB-266D-FA2D-0597-4877C3C4309D}"/>
+          </ac:spMkLst>
+        </pc:spChg>
+      </pc:sldChg>
+      <pc:sldChg chg="modSp new mod">
+        <pc:chgData name="Ed Schuster Bruce" userId="c42289d1-a3e5-485c-a3fe-df854c552fdb" providerId="ADAL" clId="{9A8B4455-0AA2-47B2-AC41-2D20ECF78631}" dt="2026-04-13T12:15:45.408" v="6020" actId="20577"/>
+        <pc:sldMkLst>
+          <pc:docMk/>
+          <pc:sldMk cId="3534305087" sldId="282"/>
+        </pc:sldMkLst>
+      </pc:sldChg>
+    </pc:docChg>
+  </pc:docChgLst>
+  <pc:docChgLst>
+    <pc:chgData name="Andrew Seymour" userId="S::pp24256@bristol.ac.uk::24ecbd37-a641-49b2-9c88-311bafa3a1fd" providerId="AD" clId="Web-{746C17BB-2E47-A7AA-F615-E028861F00F3}"/>
+    <pc:docChg chg="addSld modSld">
+      <pc:chgData name="Andrew Seymour" userId="S::pp24256@bristol.ac.uk::24ecbd37-a641-49b2-9c88-311bafa3a1fd" providerId="AD" clId="Web-{746C17BB-2E47-A7AA-F615-E028861F00F3}" dt="2026-04-13T14:49:09.313" v="1123" actId="1076"/>
+      <pc:docMkLst>
+        <pc:docMk/>
+      </pc:docMkLst>
+      <pc:sldChg chg="addSp delSp modSp addAnim delAnim modAnim">
+        <pc:chgData name="Andrew Seymour" userId="S::pp24256@bristol.ac.uk::24ecbd37-a641-49b2-9c88-311bafa3a1fd" providerId="AD" clId="Web-{746C17BB-2E47-A7AA-F615-E028861F00F3}" dt="2026-04-13T14:49:09.313" v="1123" actId="1076"/>
+        <pc:sldMkLst>
+          <pc:docMk/>
+          <pc:sldMk cId="3534305087" sldId="282"/>
+        </pc:sldMkLst>
+        <pc:spChg chg="add mod">
+          <ac:chgData name="Andrew Seymour" userId="S::pp24256@bristol.ac.uk::24ecbd37-a641-49b2-9c88-311bafa3a1fd" providerId="AD" clId="Web-{746C17BB-2E47-A7AA-F615-E028861F00F3}" dt="2026-04-13T13:17:26.721" v="35" actId="14100"/>
+          <ac:spMkLst>
+            <pc:docMk/>
+            <pc:sldMk cId="3534305087" sldId="282"/>
+            <ac:spMk id="5" creationId="{F0E06967-49D3-C383-28EE-99B49064C4D0}"/>
+          </ac:spMkLst>
+        </pc:spChg>
+        <pc:spChg chg="add mod">
+          <ac:chgData name="Andrew Seymour" userId="S::pp24256@bristol.ac.uk::24ecbd37-a641-49b2-9c88-311bafa3a1fd" providerId="AD" clId="Web-{746C17BB-2E47-A7AA-F615-E028861F00F3}" dt="2026-04-13T13:52:21.016" v="549" actId="20577"/>
+          <ac:spMkLst>
+            <pc:docMk/>
+            <pc:sldMk cId="3534305087" sldId="282"/>
+            <ac:spMk id="8" creationId="{D51843E6-37C1-11E8-4035-0F79B019263E}"/>
+          </ac:spMkLst>
+        </pc:spChg>
+        <pc:spChg chg="add mod">
+          <ac:chgData name="Andrew Seymour" userId="S::pp24256@bristol.ac.uk::24ecbd37-a641-49b2-9c88-311bafa3a1fd" providerId="AD" clId="Web-{746C17BB-2E47-A7AA-F615-E028861F00F3}" dt="2026-04-13T13:50:51.837" v="484" actId="20577"/>
+          <ac:spMkLst>
+            <pc:docMk/>
+            <pc:sldMk cId="3534305087" sldId="282"/>
+            <ac:spMk id="10" creationId="{DB11CAFB-EC90-831D-4554-AB8164CCDDF9}"/>
+          </ac:spMkLst>
+        </pc:spChg>
+        <pc:spChg chg="add mod">
+          <ac:chgData name="Andrew Seymour" userId="S::pp24256@bristol.ac.uk::24ecbd37-a641-49b2-9c88-311bafa3a1fd" providerId="AD" clId="Web-{746C17BB-2E47-A7AA-F615-E028861F00F3}" dt="2026-04-13T14:45:10.820" v="1084" actId="20577"/>
+          <ac:spMkLst>
+            <pc:docMk/>
+            <pc:sldMk cId="3534305087" sldId="282"/>
+            <ac:spMk id="16" creationId="{CDFD5141-F2ED-F0BE-4EE3-888987B09425}"/>
+          </ac:spMkLst>
+        </pc:spChg>
+        <pc:spChg chg="add mod">
+          <ac:chgData name="Andrew Seymour" userId="S::pp24256@bristol.ac.uk::24ecbd37-a641-49b2-9c88-311bafa3a1fd" providerId="AD" clId="Web-{746C17BB-2E47-A7AA-F615-E028861F00F3}" dt="2026-04-13T14:46:14.495" v="1096" actId="1076"/>
+          <ac:spMkLst>
+            <pc:docMk/>
+            <pc:sldMk cId="3534305087" sldId="282"/>
+            <ac:spMk id="20" creationId="{44D2629D-BBE2-3256-64D1-18F1D224E1AB}"/>
+          </ac:spMkLst>
+        </pc:spChg>
+        <pc:spChg chg="add mod">
+          <ac:chgData name="Andrew Seymour" userId="S::pp24256@bristol.ac.uk::24ecbd37-a641-49b2-9c88-311bafa3a1fd" providerId="AD" clId="Web-{746C17BB-2E47-A7AA-F615-E028861F00F3}" dt="2026-04-13T14:46:14.510" v="1097" actId="1076"/>
+          <ac:spMkLst>
+            <pc:docMk/>
+            <pc:sldMk cId="3534305087" sldId="282"/>
+            <ac:spMk id="21" creationId="{C808E74A-1A17-B3C4-6D14-353B39DE0AA5}"/>
+          </ac:spMkLst>
+        </pc:spChg>
+        <pc:spChg chg="add mod">
+          <ac:chgData name="Andrew Seymour" userId="S::pp24256@bristol.ac.uk::24ecbd37-a641-49b2-9c88-311bafa3a1fd" providerId="AD" clId="Web-{746C17BB-2E47-A7AA-F615-E028861F00F3}" dt="2026-04-13T14:47:48.108" v="1117" actId="20577"/>
+          <ac:spMkLst>
+            <pc:docMk/>
+            <pc:sldMk cId="3534305087" sldId="282"/>
+            <ac:spMk id="23" creationId="{E71AA451-9F0A-A1AF-C180-7B2A320B1ECC}"/>
+          </ac:spMkLst>
+        </pc:spChg>
+        <pc:picChg chg="add mod">
+          <ac:chgData name="Andrew Seymour" userId="S::pp24256@bristol.ac.uk::24ecbd37-a641-49b2-9c88-311bafa3a1fd" providerId="AD" clId="Web-{746C17BB-2E47-A7AA-F615-E028861F00F3}" dt="2026-04-13T14:46:14.464" v="1095" actId="1076"/>
+          <ac:picMkLst>
+            <pc:docMk/>
+            <pc:sldMk cId="3534305087" sldId="282"/>
+            <ac:picMk id="15" creationId="{732F5E2A-04BE-CD30-92C3-306E0B89DF06}"/>
+          </ac:picMkLst>
+        </pc:picChg>
+        <pc:picChg chg="add mod">
+          <ac:chgData name="Andrew Seymour" userId="S::pp24256@bristol.ac.uk::24ecbd37-a641-49b2-9c88-311bafa3a1fd" providerId="AD" clId="Web-{746C17BB-2E47-A7AA-F615-E028861F00F3}" dt="2026-04-13T14:04:55.680" v="607" actId="1076"/>
+          <ac:picMkLst>
+            <pc:docMk/>
+            <pc:sldMk cId="3534305087" sldId="282"/>
+            <ac:picMk id="19" creationId="{F08EA54E-24E4-BE4D-6A6D-9D268A501410}"/>
+          </ac:picMkLst>
+        </pc:picChg>
+        <pc:picChg chg="add mod">
+          <ac:chgData name="Andrew Seymour" userId="S::pp24256@bristol.ac.uk::24ecbd37-a641-49b2-9c88-311bafa3a1fd" providerId="AD" clId="Web-{746C17BB-2E47-A7AA-F615-E028861F00F3}" dt="2026-04-13T14:49:09.313" v="1123" actId="1076"/>
+          <ac:picMkLst>
+            <pc:docMk/>
+            <pc:sldMk cId="3534305087" sldId="282"/>
+            <ac:picMk id="24" creationId="{546A0CF2-5ADA-96A4-171B-739C4272928C}"/>
+          </ac:picMkLst>
+        </pc:picChg>
+      </pc:sldChg>
+      <pc:sldChg chg="addSp delSp modSp new">
+        <pc:chgData name="Andrew Seymour" userId="S::pp24256@bristol.ac.uk::24ecbd37-a641-49b2-9c88-311bafa3a1fd" providerId="AD" clId="Web-{746C17BB-2E47-A7AA-F615-E028861F00F3}" dt="2026-04-13T13:32:04.279" v="83"/>
+        <pc:sldMkLst>
+          <pc:docMk/>
+          <pc:sldMk cId="2638567684" sldId="286"/>
+        </pc:sldMkLst>
+        <pc:spChg chg="add mod">
+          <ac:chgData name="Andrew Seymour" userId="S::pp24256@bristol.ac.uk::24ecbd37-a641-49b2-9c88-311bafa3a1fd" providerId="AD" clId="Web-{746C17BB-2E47-A7AA-F615-E028861F00F3}" dt="2026-04-13T13:31:49.357" v="81" actId="1076"/>
+          <ac:spMkLst>
+            <pc:docMk/>
+            <pc:sldMk cId="2638567684" sldId="286"/>
+            <ac:spMk id="4" creationId="{ED064F4B-DC88-C716-87CB-96D582994A94}"/>
+          </ac:spMkLst>
+        </pc:spChg>
+      </pc:sldChg>
+    </pc:docChg>
+  </pc:docChgLst>
+  <pc:docChgLst>
+    <pc:chgData name="Lucas Buckley" userId="S::oq24361@bristol.ac.uk::eebbafdb-68f0-4a16-98f4-f51f26e98521" providerId="AD" clId="Web-{A85BAADD-4EA2-B3D2-5C18-76BCC8F0CED9}"/>
+    <pc:docChg chg="modSld">
+      <pc:chgData name="Lucas Buckley" userId="S::oq24361@bristol.ac.uk::eebbafdb-68f0-4a16-98f4-f51f26e98521" providerId="AD" clId="Web-{A85BAADD-4EA2-B3D2-5C18-76BCC8F0CED9}" dt="2026-04-13T14:36:29.335" v="392" actId="20577"/>
+      <pc:docMkLst>
+        <pc:docMk/>
+      </pc:docMkLst>
+      <pc:sldChg chg="modSp">
+        <pc:chgData name="Lucas Buckley" userId="S::oq24361@bristol.ac.uk::eebbafdb-68f0-4a16-98f4-f51f26e98521" providerId="AD" clId="Web-{A85BAADD-4EA2-B3D2-5C18-76BCC8F0CED9}" dt="2026-04-13T14:36:29.335" v="392" actId="20577"/>
+        <pc:sldMkLst>
+          <pc:docMk/>
+          <pc:sldMk cId="1390358288" sldId="274"/>
+        </pc:sldMkLst>
+        <pc:spChg chg="mod">
+          <ac:chgData name="Lucas Buckley" userId="S::oq24361@bristol.ac.uk::eebbafdb-68f0-4a16-98f4-f51f26e98521" providerId="AD" clId="Web-{A85BAADD-4EA2-B3D2-5C18-76BCC8F0CED9}" dt="2026-04-13T14:36:29.335" v="392" actId="20577"/>
+          <ac:spMkLst>
+            <pc:docMk/>
+            <pc:sldMk cId="1390358288" sldId="274"/>
+            <ac:spMk id="3" creationId="{CA470841-EF9D-69F5-6A03-FE25ABCCF6B6}"/>
+          </ac:spMkLst>
+        </pc:spChg>
+      </pc:sldChg>
+    </pc:docChg>
+  </pc:docChgLst>
+</pc:chgInfo>
 </file>
 
 <file path=ppt/diagrams/colors1.xml><?xml version="1.0" encoding="utf-8"?>
@@ -947,7 +1651,7 @@
             </a:lnSpc>
           </a:pPr>
           <a:r>
-            <a:rPr lang="en-US" dirty="0"/>
+            <a:rPr lang="en-US"/>
             <a:t>Wave energy is a renewable energy source</a:t>
           </a:r>
         </a:p>
@@ -1074,13 +1778,13 @@
       <dgm:prSet presAssocID="{0DAD73FB-7B7A-440A-83B3-4D08618354D7}" presName="iconRect" presStyleLbl="node1" presStyleIdx="0" presStyleCnt="3"/>
       <dgm:spPr>
         <a:blipFill>
-          <a:blip xmlns:r="http://schemas.openxmlformats.org/officeDocument/2006/relationships" r:embed="rId1">
+          <a:blip xmlns:r="http://schemas.openxmlformats.org/officeDocument/2006/relationships">
             <a:extLst>
               <a:ext uri="{28A0092B-C50C-407E-A947-70E740481C1C}">
                 <a14:useLocalDpi xmlns:a14="http://schemas.microsoft.com/office/drawing/2010/main" val="0"/>
               </a:ext>
               <a:ext uri="{96DAC541-7B7A-43D3-8B79-37D633B846F1}">
-                <asvg:svgBlip xmlns:asvg="http://schemas.microsoft.com/office/drawing/2016/SVG/main" r:embed="rId2"/>
+                <asvg:svgBlip xmlns:asvg="http://schemas.microsoft.com/office/drawing/2016/SVG/main" r:embed="rId1"/>
               </a:ext>
             </a:extLst>
           </a:blip>
@@ -1123,13 +1827,13 @@
       <dgm:prSet presAssocID="{4FAB08B4-A2B5-42A3-9AF0-BCAB3DD6BBC3}" presName="iconRect" presStyleLbl="node1" presStyleIdx="1" presStyleCnt="3"/>
       <dgm:spPr>
         <a:blipFill>
-          <a:blip xmlns:r="http://schemas.openxmlformats.org/officeDocument/2006/relationships" r:embed="rId3">
+          <a:blip xmlns:r="http://schemas.openxmlformats.org/officeDocument/2006/relationships">
             <a:extLst>
               <a:ext uri="{28A0092B-C50C-407E-A947-70E740481C1C}">
                 <a14:useLocalDpi xmlns:a14="http://schemas.microsoft.com/office/drawing/2010/main" val="0"/>
               </a:ext>
               <a:ext uri="{96DAC541-7B7A-43D3-8B79-37D633B846F1}">
-                <asvg:svgBlip xmlns:asvg="http://schemas.microsoft.com/office/drawing/2016/SVG/main" r:embed="rId4"/>
+                <asvg:svgBlip xmlns:asvg="http://schemas.microsoft.com/office/drawing/2016/SVG/main" r:embed="rId2"/>
               </a:ext>
             </a:extLst>
           </a:blip>
@@ -1172,13 +1876,13 @@
       <dgm:prSet presAssocID="{2D37665E-0832-4640-82A3-88676C774A17}" presName="iconRect" presStyleLbl="node1" presStyleIdx="2" presStyleCnt="3"/>
       <dgm:spPr>
         <a:blipFill>
-          <a:blip xmlns:r="http://schemas.openxmlformats.org/officeDocument/2006/relationships" r:embed="rId5">
+          <a:blip xmlns:r="http://schemas.openxmlformats.org/officeDocument/2006/relationships">
             <a:extLst>
               <a:ext uri="{28A0092B-C50C-407E-A947-70E740481C1C}">
                 <a14:useLocalDpi xmlns:a14="http://schemas.microsoft.com/office/drawing/2010/main" val="0"/>
               </a:ext>
               <a:ext uri="{96DAC541-7B7A-43D3-8B79-37D633B846F1}">
-                <asvg:svgBlip xmlns:asvg="http://schemas.microsoft.com/office/drawing/2016/SVG/main" r:embed="rId6"/>
+                <asvg:svgBlip xmlns:asvg="http://schemas.microsoft.com/office/drawing/2016/SVG/main" r:embed="rId3"/>
               </a:ext>
             </a:extLst>
           </a:blip>
@@ -1212,26 +1916,26 @@
   </dgm:ptLst>
   <dgm:cxnLst>
     <dgm:cxn modelId="{652E7008-501C-48CD-BD31-58DFB8DCCD02}" srcId="{65ED64C0-D682-489D-88B8-4C5E3C41C7B8}" destId="{4FAB08B4-A2B5-42A3-9AF0-BCAB3DD6BBC3}" srcOrd="1" destOrd="0" parTransId="{77806253-567F-492C-A547-A0A24C3781BA}" sibTransId="{2E714303-B63C-4048-8892-4DC8E784998D}"/>
+    <dgm:cxn modelId="{C8052610-C6FC-AC4C-BF28-64D5EA796B31}" type="presOf" srcId="{0DAD73FB-7B7A-440A-83B3-4D08618354D7}" destId="{0E84C71E-D582-40F1-ABB2-44DBDA25D422}" srcOrd="0" destOrd="0" presId="urn:microsoft.com/office/officeart/2018/2/layout/IconLabelList"/>
     <dgm:cxn modelId="{6E3AED5E-BA0F-484A-AFC0-B150466CD1AC}" srcId="{65ED64C0-D682-489D-88B8-4C5E3C41C7B8}" destId="{0DAD73FB-7B7A-440A-83B3-4D08618354D7}" srcOrd="0" destOrd="0" parTransId="{9908CCE6-195F-4FD8-88D5-E836601C17CC}" sibTransId="{5007F55C-4D41-4B31-BAAB-6DF16C98402C}"/>
     <dgm:cxn modelId="{F8A61770-B487-4660-8689-931CFC57615B}" srcId="{65ED64C0-D682-489D-88B8-4C5E3C41C7B8}" destId="{2D37665E-0832-4640-82A3-88676C774A17}" srcOrd="2" destOrd="0" parTransId="{CDF49519-3392-4C21-9D97-6AD16A713735}" sibTransId="{9DA0D4C4-EB56-40CB-A8C6-D56041ABBAB2}"/>
-    <dgm:cxn modelId="{3AAE0675-B64D-459F-AD65-1B15FC98A3AD}" type="presOf" srcId="{4FAB08B4-A2B5-42A3-9AF0-BCAB3DD6BBC3}" destId="{1F06EFA1-D441-4E6B-B9A2-B7E327E18A35}" srcOrd="0" destOrd="0" presId="urn:microsoft.com/office/officeart/2018/2/layout/IconLabelList"/>
-    <dgm:cxn modelId="{1466B694-B2B4-44E4-BAB3-72FB88FCA41E}" type="presOf" srcId="{65ED64C0-D682-489D-88B8-4C5E3C41C7B8}" destId="{FC738DC8-217A-4625-AC58-1A88F6BC8704}" srcOrd="0" destOrd="0" presId="urn:microsoft.com/office/officeart/2018/2/layout/IconLabelList"/>
-    <dgm:cxn modelId="{9303D8A3-9F96-42E6-91B6-D538D582D057}" type="presOf" srcId="{0DAD73FB-7B7A-440A-83B3-4D08618354D7}" destId="{0E84C71E-D582-40F1-ABB2-44DBDA25D422}" srcOrd="0" destOrd="0" presId="urn:microsoft.com/office/officeart/2018/2/layout/IconLabelList"/>
-    <dgm:cxn modelId="{C2A2EFB9-B103-4F46-AB76-7478168BBF1D}" type="presOf" srcId="{2D37665E-0832-4640-82A3-88676C774A17}" destId="{0155CC82-E0E3-468B-B6E1-575B0D96137F}" srcOrd="0" destOrd="0" presId="urn:microsoft.com/office/officeart/2018/2/layout/IconLabelList"/>
-    <dgm:cxn modelId="{5FB24A6F-0E58-4540-92DA-D3F78B46B1EB}" type="presParOf" srcId="{FC738DC8-217A-4625-AC58-1A88F6BC8704}" destId="{68FFE5D0-FB95-4DCC-96FA-1AD9AFD3D706}" srcOrd="0" destOrd="0" presId="urn:microsoft.com/office/officeart/2018/2/layout/IconLabelList"/>
-    <dgm:cxn modelId="{5D591DFE-06A9-4E1D-9E1F-03426B94DB73}" type="presParOf" srcId="{68FFE5D0-FB95-4DCC-96FA-1AD9AFD3D706}" destId="{15623AA1-C2D3-49E4-9916-DC5AEE524E9A}" srcOrd="0" destOrd="0" presId="urn:microsoft.com/office/officeart/2018/2/layout/IconLabelList"/>
-    <dgm:cxn modelId="{467DF418-13AC-47B9-BDD6-EE98AC7AB142}" type="presParOf" srcId="{68FFE5D0-FB95-4DCC-96FA-1AD9AFD3D706}" destId="{4C60BD36-5E41-4454-99AC-8F775EC1D774}" srcOrd="1" destOrd="0" presId="urn:microsoft.com/office/officeart/2018/2/layout/IconLabelList"/>
-    <dgm:cxn modelId="{25FEF692-63D4-4CE2-946C-2C8486AF056E}" type="presParOf" srcId="{68FFE5D0-FB95-4DCC-96FA-1AD9AFD3D706}" destId="{0E84C71E-D582-40F1-ABB2-44DBDA25D422}" srcOrd="2" destOrd="0" presId="urn:microsoft.com/office/officeart/2018/2/layout/IconLabelList"/>
-    <dgm:cxn modelId="{1D72BD99-1AF4-4967-8FB5-1D3A311D1F0C}" type="presParOf" srcId="{FC738DC8-217A-4625-AC58-1A88F6BC8704}" destId="{B06A7EDB-5D25-43AB-B323-F11E154020BD}" srcOrd="1" destOrd="0" presId="urn:microsoft.com/office/officeart/2018/2/layout/IconLabelList"/>
-    <dgm:cxn modelId="{E393F973-3AEF-4BD4-BE08-7DAECC8DADF3}" type="presParOf" srcId="{FC738DC8-217A-4625-AC58-1A88F6BC8704}" destId="{20835792-7B56-4917-BAE8-B22896FABDA0}" srcOrd="2" destOrd="0" presId="urn:microsoft.com/office/officeart/2018/2/layout/IconLabelList"/>
-    <dgm:cxn modelId="{C92B29FB-15BD-4E44-875C-6D3EC2058F13}" type="presParOf" srcId="{20835792-7B56-4917-BAE8-B22896FABDA0}" destId="{8B7EEFC6-389B-494F-A87D-0EA0884D215E}" srcOrd="0" destOrd="0" presId="urn:microsoft.com/office/officeart/2018/2/layout/IconLabelList"/>
-    <dgm:cxn modelId="{EC45E543-B925-4F6B-8EAC-9D60DDC9AD66}" type="presParOf" srcId="{20835792-7B56-4917-BAE8-B22896FABDA0}" destId="{AD66D55F-D5AA-4DBF-A651-1CD34518346F}" srcOrd="1" destOrd="0" presId="urn:microsoft.com/office/officeart/2018/2/layout/IconLabelList"/>
-    <dgm:cxn modelId="{2BD57C07-13F1-4923-9BC3-145953261A54}" type="presParOf" srcId="{20835792-7B56-4917-BAE8-B22896FABDA0}" destId="{1F06EFA1-D441-4E6B-B9A2-B7E327E18A35}" srcOrd="2" destOrd="0" presId="urn:microsoft.com/office/officeart/2018/2/layout/IconLabelList"/>
-    <dgm:cxn modelId="{60DFCB16-5A74-436F-8C37-28189D26C2D6}" type="presParOf" srcId="{FC738DC8-217A-4625-AC58-1A88F6BC8704}" destId="{3E785E4C-E547-4625-B886-42DD96C4298C}" srcOrd="3" destOrd="0" presId="urn:microsoft.com/office/officeart/2018/2/layout/IconLabelList"/>
-    <dgm:cxn modelId="{7F31831B-F171-43DF-9DD1-F3A8822A9EB5}" type="presParOf" srcId="{FC738DC8-217A-4625-AC58-1A88F6BC8704}" destId="{EE79EFE0-69BA-4496-B4C3-0E2FEEC76584}" srcOrd="4" destOrd="0" presId="urn:microsoft.com/office/officeart/2018/2/layout/IconLabelList"/>
-    <dgm:cxn modelId="{C63664D5-37F8-4200-9B75-A518C382F09B}" type="presParOf" srcId="{EE79EFE0-69BA-4496-B4C3-0E2FEEC76584}" destId="{EC3B2A4B-87F7-4492-BD0E-9CF56885BC16}" srcOrd="0" destOrd="0" presId="urn:microsoft.com/office/officeart/2018/2/layout/IconLabelList"/>
-    <dgm:cxn modelId="{6ECBD7F0-D91F-4F80-8B89-4DB1F484A3D8}" type="presParOf" srcId="{EE79EFE0-69BA-4496-B4C3-0E2FEEC76584}" destId="{0004287C-C44E-4C1A-B5CC-BA2E1E2A384B}" srcOrd="1" destOrd="0" presId="urn:microsoft.com/office/officeart/2018/2/layout/IconLabelList"/>
-    <dgm:cxn modelId="{8282BD48-8F42-43CF-9B76-4CB93B23378F}" type="presParOf" srcId="{EE79EFE0-69BA-4496-B4C3-0E2FEEC76584}" destId="{0155CC82-E0E3-468B-B6E1-575B0D96137F}" srcOrd="2" destOrd="0" presId="urn:microsoft.com/office/officeart/2018/2/layout/IconLabelList"/>
+    <dgm:cxn modelId="{4693E8A3-886C-2E4E-B00D-E4D9931961CA}" type="presOf" srcId="{2D37665E-0832-4640-82A3-88676C774A17}" destId="{0155CC82-E0E3-468B-B6E1-575B0D96137F}" srcOrd="0" destOrd="0" presId="urn:microsoft.com/office/officeart/2018/2/layout/IconLabelList"/>
+    <dgm:cxn modelId="{D82782AB-B026-D445-B743-2122E2BBDFCE}" type="presOf" srcId="{65ED64C0-D682-489D-88B8-4C5E3C41C7B8}" destId="{FC738DC8-217A-4625-AC58-1A88F6BC8704}" srcOrd="0" destOrd="0" presId="urn:microsoft.com/office/officeart/2018/2/layout/IconLabelList"/>
+    <dgm:cxn modelId="{BF5695D7-5093-614A-B59F-3B8EBB859550}" type="presOf" srcId="{4FAB08B4-A2B5-42A3-9AF0-BCAB3DD6BBC3}" destId="{1F06EFA1-D441-4E6B-B9A2-B7E327E18A35}" srcOrd="0" destOrd="0" presId="urn:microsoft.com/office/officeart/2018/2/layout/IconLabelList"/>
+    <dgm:cxn modelId="{83B69E3F-B170-6A49-AD13-558C3CAC31D4}" type="presParOf" srcId="{FC738DC8-217A-4625-AC58-1A88F6BC8704}" destId="{68FFE5D0-FB95-4DCC-96FA-1AD9AFD3D706}" srcOrd="0" destOrd="0" presId="urn:microsoft.com/office/officeart/2018/2/layout/IconLabelList"/>
+    <dgm:cxn modelId="{6CA1D085-9620-464C-93D0-3C3A279133F1}" type="presParOf" srcId="{68FFE5D0-FB95-4DCC-96FA-1AD9AFD3D706}" destId="{15623AA1-C2D3-49E4-9916-DC5AEE524E9A}" srcOrd="0" destOrd="0" presId="urn:microsoft.com/office/officeart/2018/2/layout/IconLabelList"/>
+    <dgm:cxn modelId="{5A616075-B8E5-EF48-9391-B065DBEE3767}" type="presParOf" srcId="{68FFE5D0-FB95-4DCC-96FA-1AD9AFD3D706}" destId="{4C60BD36-5E41-4454-99AC-8F775EC1D774}" srcOrd="1" destOrd="0" presId="urn:microsoft.com/office/officeart/2018/2/layout/IconLabelList"/>
+    <dgm:cxn modelId="{3D81F637-F976-6748-AA1B-650A391C1FB9}" type="presParOf" srcId="{68FFE5D0-FB95-4DCC-96FA-1AD9AFD3D706}" destId="{0E84C71E-D582-40F1-ABB2-44DBDA25D422}" srcOrd="2" destOrd="0" presId="urn:microsoft.com/office/officeart/2018/2/layout/IconLabelList"/>
+    <dgm:cxn modelId="{0472EA65-FFEA-BA41-A8FC-78C545E452CA}" type="presParOf" srcId="{FC738DC8-217A-4625-AC58-1A88F6BC8704}" destId="{B06A7EDB-5D25-43AB-B323-F11E154020BD}" srcOrd="1" destOrd="0" presId="urn:microsoft.com/office/officeart/2018/2/layout/IconLabelList"/>
+    <dgm:cxn modelId="{40738BF6-296D-6A4C-A2DD-EB490E86C86B}" type="presParOf" srcId="{FC738DC8-217A-4625-AC58-1A88F6BC8704}" destId="{20835792-7B56-4917-BAE8-B22896FABDA0}" srcOrd="2" destOrd="0" presId="urn:microsoft.com/office/officeart/2018/2/layout/IconLabelList"/>
+    <dgm:cxn modelId="{C4636BD8-464B-7647-8CC4-ABB3222A561D}" type="presParOf" srcId="{20835792-7B56-4917-BAE8-B22896FABDA0}" destId="{8B7EEFC6-389B-494F-A87D-0EA0884D215E}" srcOrd="0" destOrd="0" presId="urn:microsoft.com/office/officeart/2018/2/layout/IconLabelList"/>
+    <dgm:cxn modelId="{7E105E86-E224-F645-8F5B-1DBC9B9CA252}" type="presParOf" srcId="{20835792-7B56-4917-BAE8-B22896FABDA0}" destId="{AD66D55F-D5AA-4DBF-A651-1CD34518346F}" srcOrd="1" destOrd="0" presId="urn:microsoft.com/office/officeart/2018/2/layout/IconLabelList"/>
+    <dgm:cxn modelId="{0747C1E3-168E-064B-88D3-C395B6796490}" type="presParOf" srcId="{20835792-7B56-4917-BAE8-B22896FABDA0}" destId="{1F06EFA1-D441-4E6B-B9A2-B7E327E18A35}" srcOrd="2" destOrd="0" presId="urn:microsoft.com/office/officeart/2018/2/layout/IconLabelList"/>
+    <dgm:cxn modelId="{2D9478BC-6303-AE47-8FA9-B6723CFA79A3}" type="presParOf" srcId="{FC738DC8-217A-4625-AC58-1A88F6BC8704}" destId="{3E785E4C-E547-4625-B886-42DD96C4298C}" srcOrd="3" destOrd="0" presId="urn:microsoft.com/office/officeart/2018/2/layout/IconLabelList"/>
+    <dgm:cxn modelId="{D76AD724-C727-6143-BC5D-76CBF9B18B19}" type="presParOf" srcId="{FC738DC8-217A-4625-AC58-1A88F6BC8704}" destId="{EE79EFE0-69BA-4496-B4C3-0E2FEEC76584}" srcOrd="4" destOrd="0" presId="urn:microsoft.com/office/officeart/2018/2/layout/IconLabelList"/>
+    <dgm:cxn modelId="{27A89FDB-C93A-D744-9D00-DE0BC6A4FF79}" type="presParOf" srcId="{EE79EFE0-69BA-4496-B4C3-0E2FEEC76584}" destId="{EC3B2A4B-87F7-4492-BD0E-9CF56885BC16}" srcOrd="0" destOrd="0" presId="urn:microsoft.com/office/officeart/2018/2/layout/IconLabelList"/>
+    <dgm:cxn modelId="{4EE0D80A-A23B-1848-8130-BF2012F6CDB7}" type="presParOf" srcId="{EE79EFE0-69BA-4496-B4C3-0E2FEEC76584}" destId="{0004287C-C44E-4C1A-B5CC-BA2E1E2A384B}" srcOrd="1" destOrd="0" presId="urn:microsoft.com/office/officeart/2018/2/layout/IconLabelList"/>
+    <dgm:cxn modelId="{C96F9263-D460-424A-8C9A-43D99C7DB712}" type="presParOf" srcId="{EE79EFE0-69BA-4496-B4C3-0E2FEEC76584}" destId="{0155CC82-E0E3-468B-B6E1-575B0D96137F}" srcOrd="2" destOrd="0" presId="urn:microsoft.com/office/officeart/2018/2/layout/IconLabelList"/>
   </dgm:cxnLst>
   <dgm:bg/>
   <dgm:whole/>
@@ -1265,13 +1969,13 @@
           <a:avLst/>
         </a:prstGeom>
         <a:blipFill>
-          <a:blip xmlns:r="http://schemas.openxmlformats.org/officeDocument/2006/relationships" r:embed="rId1">
+          <a:blip xmlns:r="http://schemas.openxmlformats.org/officeDocument/2006/relationships">
             <a:extLst>
               <a:ext uri="{28A0092B-C50C-407E-A947-70E740481C1C}">
                 <a14:useLocalDpi xmlns:a14="http://schemas.microsoft.com/office/drawing/2010/main" val="0"/>
               </a:ext>
               <a:ext uri="{96DAC541-7B7A-43D3-8B79-37D633B846F1}">
-                <asvg:svgBlip xmlns:asvg="http://schemas.microsoft.com/office/drawing/2016/SVG/main" r:embed="rId2"/>
+                <asvg:svgBlip xmlns:asvg="http://schemas.microsoft.com/office/drawing/2016/SVG/main" r:embed="rId1"/>
               </a:ext>
             </a:extLst>
           </a:blip>
@@ -1351,7 +2055,7 @@
             <a:buNone/>
           </a:pPr>
           <a:r>
-            <a:rPr lang="en-US" sz="1900" kern="1200" dirty="0"/>
+            <a:rPr lang="en-US" sz="1900" kern="1200"/>
             <a:t>Wave energy is a renewable energy source</a:t>
           </a:r>
         </a:p>
@@ -1375,13 +2079,13 @@
           <a:avLst/>
         </a:prstGeom>
         <a:blipFill>
-          <a:blip xmlns:r="http://schemas.openxmlformats.org/officeDocument/2006/relationships" r:embed="rId3">
+          <a:blip xmlns:r="http://schemas.openxmlformats.org/officeDocument/2006/relationships">
             <a:extLst>
               <a:ext uri="{28A0092B-C50C-407E-A947-70E740481C1C}">
                 <a14:useLocalDpi xmlns:a14="http://schemas.microsoft.com/office/drawing/2010/main" val="0"/>
               </a:ext>
               <a:ext uri="{96DAC541-7B7A-43D3-8B79-37D633B846F1}">
-                <asvg:svgBlip xmlns:asvg="http://schemas.microsoft.com/office/drawing/2016/SVG/main" r:embed="rId4"/>
+                <asvg:svgBlip xmlns:asvg="http://schemas.microsoft.com/office/drawing/2016/SVG/main" r:embed="rId2"/>
               </a:ext>
             </a:extLst>
           </a:blip>
@@ -1485,13 +2189,13 @@
           <a:avLst/>
         </a:prstGeom>
         <a:blipFill>
-          <a:blip xmlns:r="http://schemas.openxmlformats.org/officeDocument/2006/relationships" r:embed="rId5">
+          <a:blip xmlns:r="http://schemas.openxmlformats.org/officeDocument/2006/relationships">
             <a:extLst>
               <a:ext uri="{28A0092B-C50C-407E-A947-70E740481C1C}">
                 <a14:useLocalDpi xmlns:a14="http://schemas.microsoft.com/office/drawing/2010/main" val="0"/>
               </a:ext>
               <a:ext uri="{96DAC541-7B7A-43D3-8B79-37D633B846F1}">
-                <asvg:svgBlip xmlns:asvg="http://schemas.microsoft.com/office/drawing/2016/SVG/main" r:embed="rId6"/>
+                <asvg:svgBlip xmlns:asvg="http://schemas.microsoft.com/office/drawing/2016/SVG/main" r:embed="rId3"/>
               </a:ext>
             </a:extLst>
           </a:blip>
@@ -2809,6 +3513,527 @@
 </dgm:styleDef>
 </file>
 
+<file path=ppt/notesMasters/notesMaster1.xml><?xml version="1.0" encoding="utf-8"?>
+<p:notesMaster xmlns:a="http://schemas.openxmlformats.org/drawingml/2006/main" xmlns:r="http://schemas.openxmlformats.org/officeDocument/2006/relationships" xmlns:p="http://schemas.openxmlformats.org/presentationml/2006/main">
+  <p:cSld>
+    <p:bg>
+      <p:bgRef idx="1001">
+        <a:schemeClr val="bg1"/>
+      </p:bgRef>
+    </p:bg>
+    <p:spTree>
+      <p:nvGrpSpPr>
+        <p:cNvPr id="1" name=""/>
+        <p:cNvGrpSpPr/>
+        <p:nvPr/>
+      </p:nvGrpSpPr>
+      <p:grpSpPr>
+        <a:xfrm>
+          <a:off x="0" y="0"/>
+          <a:ext cx="0" cy="0"/>
+          <a:chOff x="0" y="0"/>
+          <a:chExt cx="0" cy="0"/>
+        </a:xfrm>
+      </p:grpSpPr>
+      <p:sp>
+        <p:nvSpPr>
+          <p:cNvPr id="2" name="Header Placeholder 1"/>
+          <p:cNvSpPr>
+            <a:spLocks noGrp="1"/>
+          </p:cNvSpPr>
+          <p:nvPr>
+            <p:ph type="hdr" sz="quarter"/>
+          </p:nvPr>
+        </p:nvSpPr>
+        <p:spPr>
+          <a:xfrm>
+            <a:off x="0" y="0"/>
+            <a:ext cx="2971800" cy="458788"/>
+          </a:xfrm>
+          <a:prstGeom prst="rect">
+            <a:avLst/>
+          </a:prstGeom>
+        </p:spPr>
+        <p:txBody>
+          <a:bodyPr vert="horz" lIns="91440" tIns="45720" rIns="91440" bIns="45720" rtlCol="0"/>
+          <a:lstStyle>
+            <a:lvl1pPr algn="l">
+              <a:defRPr sz="1200"/>
+            </a:lvl1pPr>
+          </a:lstStyle>
+          <a:p>
+            <a:endParaRPr lang="en-US"/>
+          </a:p>
+        </p:txBody>
+      </p:sp>
+      <p:sp>
+        <p:nvSpPr>
+          <p:cNvPr id="3" name="Date Placeholder 2"/>
+          <p:cNvSpPr>
+            <a:spLocks noGrp="1"/>
+          </p:cNvSpPr>
+          <p:nvPr>
+            <p:ph type="dt" idx="1"/>
+          </p:nvPr>
+        </p:nvSpPr>
+        <p:spPr>
+          <a:xfrm>
+            <a:off x="3884613" y="0"/>
+            <a:ext cx="2971800" cy="458788"/>
+          </a:xfrm>
+          <a:prstGeom prst="rect">
+            <a:avLst/>
+          </a:prstGeom>
+        </p:spPr>
+        <p:txBody>
+          <a:bodyPr vert="horz" lIns="91440" tIns="45720" rIns="91440" bIns="45720" rtlCol="0"/>
+          <a:lstStyle>
+            <a:lvl1pPr algn="r">
+              <a:defRPr sz="1200"/>
+            </a:lvl1pPr>
+          </a:lstStyle>
+          <a:p>
+            <a:fld id="{C20829D5-7707-BB41-8706-F6EFD417B231}" type="datetimeFigureOut">
+              <a:rPr lang="en-US" smtClean="0"/>
+              <a:t>4/15/2026</a:t>
+            </a:fld>
+            <a:endParaRPr lang="en-US"/>
+          </a:p>
+        </p:txBody>
+      </p:sp>
+      <p:sp>
+        <p:nvSpPr>
+          <p:cNvPr id="4" name="Slide Image Placeholder 3"/>
+          <p:cNvSpPr>
+            <a:spLocks noGrp="1" noRot="1" noChangeAspect="1"/>
+          </p:cNvSpPr>
+          <p:nvPr>
+            <p:ph type="sldImg" idx="2"/>
+          </p:nvPr>
+        </p:nvSpPr>
+        <p:spPr>
+          <a:xfrm>
+            <a:off x="685800" y="1143000"/>
+            <a:ext cx="5486400" cy="3086100"/>
+          </a:xfrm>
+          <a:prstGeom prst="rect">
+            <a:avLst/>
+          </a:prstGeom>
+          <a:noFill/>
+          <a:ln w="12700">
+            <a:solidFill>
+              <a:prstClr val="black"/>
+            </a:solidFill>
+          </a:ln>
+        </p:spPr>
+        <p:txBody>
+          <a:bodyPr vert="horz" lIns="91440" tIns="45720" rIns="91440" bIns="45720" rtlCol="0" anchor="ctr"/>
+          <a:lstStyle/>
+          <a:p>
+            <a:endParaRPr lang="en-US"/>
+          </a:p>
+        </p:txBody>
+      </p:sp>
+      <p:sp>
+        <p:nvSpPr>
+          <p:cNvPr id="5" name="Notes Placeholder 4"/>
+          <p:cNvSpPr>
+            <a:spLocks noGrp="1"/>
+          </p:cNvSpPr>
+          <p:nvPr>
+            <p:ph type="body" sz="quarter" idx="3"/>
+          </p:nvPr>
+        </p:nvSpPr>
+        <p:spPr>
+          <a:xfrm>
+            <a:off x="685800" y="4400550"/>
+            <a:ext cx="5486400" cy="3600450"/>
+          </a:xfrm>
+          <a:prstGeom prst="rect">
+            <a:avLst/>
+          </a:prstGeom>
+        </p:spPr>
+        <p:txBody>
+          <a:bodyPr vert="horz" lIns="91440" tIns="45720" rIns="91440" bIns="45720" rtlCol="0"/>
+          <a:lstStyle/>
+          <a:p>
+            <a:pPr lvl="0"/>
+            <a:r>
+              <a:rPr lang="en-GB"/>
+              <a:t>Click to edit Master text styles</a:t>
+            </a:r>
+          </a:p>
+          <a:p>
+            <a:pPr lvl="1"/>
+            <a:r>
+              <a:rPr lang="en-GB"/>
+              <a:t>Second level</a:t>
+            </a:r>
+          </a:p>
+          <a:p>
+            <a:pPr lvl="2"/>
+            <a:r>
+              <a:rPr lang="en-GB"/>
+              <a:t>Third level</a:t>
+            </a:r>
+          </a:p>
+          <a:p>
+            <a:pPr lvl="3"/>
+            <a:r>
+              <a:rPr lang="en-GB"/>
+              <a:t>Fourth level</a:t>
+            </a:r>
+          </a:p>
+          <a:p>
+            <a:pPr lvl="4"/>
+            <a:r>
+              <a:rPr lang="en-GB"/>
+              <a:t>Fifth level</a:t>
+            </a:r>
+            <a:endParaRPr lang="en-US"/>
+          </a:p>
+        </p:txBody>
+      </p:sp>
+      <p:sp>
+        <p:nvSpPr>
+          <p:cNvPr id="6" name="Footer Placeholder 5"/>
+          <p:cNvSpPr>
+            <a:spLocks noGrp="1"/>
+          </p:cNvSpPr>
+          <p:nvPr>
+            <p:ph type="ftr" sz="quarter" idx="4"/>
+          </p:nvPr>
+        </p:nvSpPr>
+        <p:spPr>
+          <a:xfrm>
+            <a:off x="0" y="8685213"/>
+            <a:ext cx="2971800" cy="458787"/>
+          </a:xfrm>
+          <a:prstGeom prst="rect">
+            <a:avLst/>
+          </a:prstGeom>
+        </p:spPr>
+        <p:txBody>
+          <a:bodyPr vert="horz" lIns="91440" tIns="45720" rIns="91440" bIns="45720" rtlCol="0" anchor="b"/>
+          <a:lstStyle>
+            <a:lvl1pPr algn="l">
+              <a:defRPr sz="1200"/>
+            </a:lvl1pPr>
+          </a:lstStyle>
+          <a:p>
+            <a:endParaRPr lang="en-US"/>
+          </a:p>
+        </p:txBody>
+      </p:sp>
+      <p:sp>
+        <p:nvSpPr>
+          <p:cNvPr id="7" name="Slide Number Placeholder 6"/>
+          <p:cNvSpPr>
+            <a:spLocks noGrp="1"/>
+          </p:cNvSpPr>
+          <p:nvPr>
+            <p:ph type="sldNum" sz="quarter" idx="5"/>
+          </p:nvPr>
+        </p:nvSpPr>
+        <p:spPr>
+          <a:xfrm>
+            <a:off x="3884613" y="8685213"/>
+            <a:ext cx="2971800" cy="458787"/>
+          </a:xfrm>
+          <a:prstGeom prst="rect">
+            <a:avLst/>
+          </a:prstGeom>
+        </p:spPr>
+        <p:txBody>
+          <a:bodyPr vert="horz" lIns="91440" tIns="45720" rIns="91440" bIns="45720" rtlCol="0" anchor="b"/>
+          <a:lstStyle>
+            <a:lvl1pPr algn="r">
+              <a:defRPr sz="1200"/>
+            </a:lvl1pPr>
+          </a:lstStyle>
+          <a:p>
+            <a:fld id="{5280EDDE-5A22-6C46-8484-64ED18943D07}" type="slidenum">
+              <a:rPr lang="en-US" smtClean="0"/>
+              <a:t>‹#›</a:t>
+            </a:fld>
+            <a:endParaRPr lang="en-US"/>
+          </a:p>
+        </p:txBody>
+      </p:sp>
+    </p:spTree>
+    <p:extLst>
+      <p:ext uri="{BB962C8B-B14F-4D97-AF65-F5344CB8AC3E}">
+        <p14:creationId xmlns:p14="http://schemas.microsoft.com/office/powerpoint/2010/main" val="751648743"/>
+      </p:ext>
+    </p:extLst>
+  </p:cSld>
+  <p:clrMap bg1="lt1" tx1="dk1" bg2="lt2" tx2="dk2" accent1="accent1" accent2="accent2" accent3="accent3" accent4="accent4" accent5="accent5" accent6="accent6" hlink="hlink" folHlink="folHlink"/>
+  <p:notesStyle>
+    <a:lvl1pPr marL="0" algn="l" defTabSz="914400" rtl="0" eaLnBrk="1" latinLnBrk="0" hangingPunct="1">
+      <a:defRPr sz="1200" kern="1200">
+        <a:solidFill>
+          <a:schemeClr val="tx1"/>
+        </a:solidFill>
+        <a:latin typeface="+mn-lt"/>
+        <a:ea typeface="+mn-ea"/>
+        <a:cs typeface="+mn-cs"/>
+      </a:defRPr>
+    </a:lvl1pPr>
+    <a:lvl2pPr marL="457200" algn="l" defTabSz="914400" rtl="0" eaLnBrk="1" latinLnBrk="0" hangingPunct="1">
+      <a:defRPr sz="1200" kern="1200">
+        <a:solidFill>
+          <a:schemeClr val="tx1"/>
+        </a:solidFill>
+        <a:latin typeface="+mn-lt"/>
+        <a:ea typeface="+mn-ea"/>
+        <a:cs typeface="+mn-cs"/>
+      </a:defRPr>
+    </a:lvl2pPr>
+    <a:lvl3pPr marL="914400" algn="l" defTabSz="914400" rtl="0" eaLnBrk="1" latinLnBrk="0" hangingPunct="1">
+      <a:defRPr sz="1200" kern="1200">
+        <a:solidFill>
+          <a:schemeClr val="tx1"/>
+        </a:solidFill>
+        <a:latin typeface="+mn-lt"/>
+        <a:ea typeface="+mn-ea"/>
+        <a:cs typeface="+mn-cs"/>
+      </a:defRPr>
+    </a:lvl3pPr>
+    <a:lvl4pPr marL="1371600" algn="l" defTabSz="914400" rtl="0" eaLnBrk="1" latinLnBrk="0" hangingPunct="1">
+      <a:defRPr sz="1200" kern="1200">
+        <a:solidFill>
+          <a:schemeClr val="tx1"/>
+        </a:solidFill>
+        <a:latin typeface="+mn-lt"/>
+        <a:ea typeface="+mn-ea"/>
+        <a:cs typeface="+mn-cs"/>
+      </a:defRPr>
+    </a:lvl4pPr>
+    <a:lvl5pPr marL="1828800" algn="l" defTabSz="914400" rtl="0" eaLnBrk="1" latinLnBrk="0" hangingPunct="1">
+      <a:defRPr sz="1200" kern="1200">
+        <a:solidFill>
+          <a:schemeClr val="tx1"/>
+        </a:solidFill>
+        <a:latin typeface="+mn-lt"/>
+        <a:ea typeface="+mn-ea"/>
+        <a:cs typeface="+mn-cs"/>
+      </a:defRPr>
+    </a:lvl5pPr>
+    <a:lvl6pPr marL="2286000" algn="l" defTabSz="914400" rtl="0" eaLnBrk="1" latinLnBrk="0" hangingPunct="1">
+      <a:defRPr sz="1200" kern="1200">
+        <a:solidFill>
+          <a:schemeClr val="tx1"/>
+        </a:solidFill>
+        <a:latin typeface="+mn-lt"/>
+        <a:ea typeface="+mn-ea"/>
+        <a:cs typeface="+mn-cs"/>
+      </a:defRPr>
+    </a:lvl6pPr>
+    <a:lvl7pPr marL="2743200" algn="l" defTabSz="914400" rtl="0" eaLnBrk="1" latinLnBrk="0" hangingPunct="1">
+      <a:defRPr sz="1200" kern="1200">
+        <a:solidFill>
+          <a:schemeClr val="tx1"/>
+        </a:solidFill>
+        <a:latin typeface="+mn-lt"/>
+        <a:ea typeface="+mn-ea"/>
+        <a:cs typeface="+mn-cs"/>
+      </a:defRPr>
+    </a:lvl7pPr>
+    <a:lvl8pPr marL="3200400" algn="l" defTabSz="914400" rtl="0" eaLnBrk="1" latinLnBrk="0" hangingPunct="1">
+      <a:defRPr sz="1200" kern="1200">
+        <a:solidFill>
+          <a:schemeClr val="tx1"/>
+        </a:solidFill>
+        <a:latin typeface="+mn-lt"/>
+        <a:ea typeface="+mn-ea"/>
+        <a:cs typeface="+mn-cs"/>
+      </a:defRPr>
+    </a:lvl8pPr>
+    <a:lvl9pPr marL="3657600" algn="l" defTabSz="914400" rtl="0" eaLnBrk="1" latinLnBrk="0" hangingPunct="1">
+      <a:defRPr sz="1200" kern="1200">
+        <a:solidFill>
+          <a:schemeClr val="tx1"/>
+        </a:solidFill>
+        <a:latin typeface="+mn-lt"/>
+        <a:ea typeface="+mn-ea"/>
+        <a:cs typeface="+mn-cs"/>
+      </a:defRPr>
+    </a:lvl9pPr>
+  </p:notesStyle>
+</p:notesMaster>
+</file>
+
+<file path=ppt/notesSlides/notesSlide1.xml><?xml version="1.0" encoding="utf-8"?>
+<p:notes xmlns:a="http://schemas.openxmlformats.org/drawingml/2006/main" xmlns:r="http://schemas.openxmlformats.org/officeDocument/2006/relationships" xmlns:p="http://schemas.openxmlformats.org/presentationml/2006/main">
+  <p:cSld>
+    <p:spTree>
+      <p:nvGrpSpPr>
+        <p:cNvPr id="1" name=""/>
+        <p:cNvGrpSpPr/>
+        <p:nvPr/>
+      </p:nvGrpSpPr>
+      <p:grpSpPr>
+        <a:xfrm>
+          <a:off x="0" y="0"/>
+          <a:ext cx="0" cy="0"/>
+          <a:chOff x="0" y="0"/>
+          <a:chExt cx="0" cy="0"/>
+        </a:xfrm>
+      </p:grpSpPr>
+      <p:sp>
+        <p:nvSpPr>
+          <p:cNvPr id="2" name="Slide Image Placeholder 1"/>
+          <p:cNvSpPr>
+            <a:spLocks noGrp="1" noRot="1" noChangeAspect="1"/>
+          </p:cNvSpPr>
+          <p:nvPr>
+            <p:ph type="sldImg"/>
+          </p:nvPr>
+        </p:nvSpPr>
+        <p:spPr/>
+      </p:sp>
+      <p:sp>
+        <p:nvSpPr>
+          <p:cNvPr id="3" name="Notes Placeholder 2"/>
+          <p:cNvSpPr>
+            <a:spLocks noGrp="1"/>
+          </p:cNvSpPr>
+          <p:nvPr>
+            <p:ph type="body" idx="1"/>
+          </p:nvPr>
+        </p:nvSpPr>
+        <p:spPr/>
+        <p:txBody>
+          <a:bodyPr/>
+          <a:lstStyle/>
+          <a:p>
+            <a:endParaRPr lang="en-US"/>
+          </a:p>
+        </p:txBody>
+      </p:sp>
+      <p:sp>
+        <p:nvSpPr>
+          <p:cNvPr id="4" name="Slide Number Placeholder 3"/>
+          <p:cNvSpPr>
+            <a:spLocks noGrp="1"/>
+          </p:cNvSpPr>
+          <p:nvPr>
+            <p:ph type="sldNum" sz="quarter" idx="5"/>
+          </p:nvPr>
+        </p:nvSpPr>
+        <p:spPr/>
+        <p:txBody>
+          <a:bodyPr/>
+          <a:lstStyle/>
+          <a:p>
+            <a:fld id="{5280EDDE-5A22-6C46-8484-64ED18943D07}" type="slidenum">
+              <a:rPr lang="en-US" smtClean="0"/>
+              <a:t>5</a:t>
+            </a:fld>
+            <a:endParaRPr lang="en-US"/>
+          </a:p>
+        </p:txBody>
+      </p:sp>
+    </p:spTree>
+    <p:extLst>
+      <p:ext uri="{BB962C8B-B14F-4D97-AF65-F5344CB8AC3E}">
+        <p14:creationId xmlns:p14="http://schemas.microsoft.com/office/powerpoint/2010/main" val="2167601417"/>
+      </p:ext>
+    </p:extLst>
+  </p:cSld>
+  <p:clrMapOvr>
+    <a:masterClrMapping/>
+  </p:clrMapOvr>
+</p:notes>
+</file>
+
+<file path=ppt/notesSlides/notesSlide2.xml><?xml version="1.0" encoding="utf-8"?>
+<p:notes xmlns:a="http://schemas.openxmlformats.org/drawingml/2006/main" xmlns:r="http://schemas.openxmlformats.org/officeDocument/2006/relationships" xmlns:p="http://schemas.openxmlformats.org/presentationml/2006/main">
+  <p:cSld>
+    <p:spTree>
+      <p:nvGrpSpPr>
+        <p:cNvPr id="1" name=""/>
+        <p:cNvGrpSpPr/>
+        <p:nvPr/>
+      </p:nvGrpSpPr>
+      <p:grpSpPr>
+        <a:xfrm>
+          <a:off x="0" y="0"/>
+          <a:ext cx="0" cy="0"/>
+          <a:chOff x="0" y="0"/>
+          <a:chExt cx="0" cy="0"/>
+        </a:xfrm>
+      </p:grpSpPr>
+      <p:sp>
+        <p:nvSpPr>
+          <p:cNvPr id="2" name="Slide Image Placeholder 1"/>
+          <p:cNvSpPr>
+            <a:spLocks noGrp="1" noRot="1" noChangeAspect="1"/>
+          </p:cNvSpPr>
+          <p:nvPr>
+            <p:ph type="sldImg"/>
+          </p:nvPr>
+        </p:nvSpPr>
+        <p:spPr/>
+      </p:sp>
+      <p:sp>
+        <p:nvSpPr>
+          <p:cNvPr id="3" name="Notes Placeholder 2"/>
+          <p:cNvSpPr>
+            <a:spLocks noGrp="1"/>
+          </p:cNvSpPr>
+          <p:nvPr>
+            <p:ph type="body" idx="1"/>
+          </p:nvPr>
+        </p:nvSpPr>
+        <p:spPr/>
+        <p:txBody>
+          <a:bodyPr/>
+          <a:lstStyle/>
+          <a:p>
+            <a:r>
+              <a:rPr lang="en-US"/>
+              <a:t>Frequency of __ used to compare the power output of a cylinder buoy with 3 fixed control techniques.</a:t>
+            </a:r>
+          </a:p>
+        </p:txBody>
+      </p:sp>
+      <p:sp>
+        <p:nvSpPr>
+          <p:cNvPr id="4" name="Slide Number Placeholder 3"/>
+          <p:cNvSpPr>
+            <a:spLocks noGrp="1"/>
+          </p:cNvSpPr>
+          <p:nvPr>
+            <p:ph type="sldNum" sz="quarter" idx="5"/>
+          </p:nvPr>
+        </p:nvSpPr>
+        <p:spPr/>
+        <p:txBody>
+          <a:bodyPr/>
+          <a:lstStyle/>
+          <a:p>
+            <a:fld id="{5280EDDE-5A22-6C46-8484-64ED18943D07}" type="slidenum">
+              <a:rPr lang="en-US" smtClean="0"/>
+              <a:t>9</a:t>
+            </a:fld>
+            <a:endParaRPr lang="en-US"/>
+          </a:p>
+        </p:txBody>
+      </p:sp>
+    </p:spTree>
+    <p:extLst>
+      <p:ext uri="{BB962C8B-B14F-4D97-AF65-F5344CB8AC3E}">
+        <p14:creationId xmlns:p14="http://schemas.microsoft.com/office/powerpoint/2010/main" val="3631548149"/>
+      </p:ext>
+    </p:extLst>
+  </p:cSld>
+  <p:clrMapOvr>
+    <a:masterClrMapping/>
+  </p:clrMapOvr>
+</p:notes>
+</file>
+
 <file path=ppt/slideLayouts/slideLayout1.xml><?xml version="1.0" encoding="utf-8"?>
 <p:sldLayout xmlns:a="http://schemas.openxmlformats.org/drawingml/2006/main" xmlns:r="http://schemas.openxmlformats.org/officeDocument/2006/relationships" xmlns:p="http://schemas.openxmlformats.org/presentationml/2006/main" type="title" preserve="1">
   <p:cSld name="Title Slide">
@@ -2958,7 +4183,7 @@
           <a:p>
             <a:fld id="{5BCAD085-E8A6-8845-BD4E-CB4CCA059FC4}" type="datetimeFigureOut">
               <a:rPr lang="en-US" smtClean="0"/>
-              <a:t>4/7/2026</a:t>
+              <a:t>4/15/2026</a:t>
             </a:fld>
             <a:endParaRPr lang="en-US"/>
           </a:p>
@@ -3158,7 +4383,7 @@
           <a:p>
             <a:fld id="{5BCAD085-E8A6-8845-BD4E-CB4CCA059FC4}" type="datetimeFigureOut">
               <a:rPr lang="en-US" smtClean="0"/>
-              <a:t>4/7/2026</a:t>
+              <a:t>4/15/2026</a:t>
             </a:fld>
             <a:endParaRPr lang="en-US"/>
           </a:p>
@@ -3368,7 +4593,7 @@
           <a:p>
             <a:fld id="{5BCAD085-E8A6-8845-BD4E-CB4CCA059FC4}" type="datetimeFigureOut">
               <a:rPr lang="en-US" smtClean="0"/>
-              <a:t>4/7/2026</a:t>
+              <a:t>4/15/2026</a:t>
             </a:fld>
             <a:endParaRPr lang="en-US"/>
           </a:p>
@@ -3568,7 +4793,7 @@
           <a:p>
             <a:fld id="{5BCAD085-E8A6-8845-BD4E-CB4CCA059FC4}" type="datetimeFigureOut">
               <a:rPr lang="en-US" smtClean="0"/>
-              <a:t>4/7/2026</a:t>
+              <a:t>4/15/2026</a:t>
             </a:fld>
             <a:endParaRPr lang="en-US"/>
           </a:p>
@@ -3844,7 +5069,7 @@
           <a:p>
             <a:fld id="{5BCAD085-E8A6-8845-BD4E-CB4CCA059FC4}" type="datetimeFigureOut">
               <a:rPr lang="en-US" smtClean="0"/>
-              <a:t>4/7/2026</a:t>
+              <a:t>4/15/2026</a:t>
             </a:fld>
             <a:endParaRPr lang="en-US"/>
           </a:p>
@@ -4112,7 +5337,7 @@
           <a:p>
             <a:fld id="{5BCAD085-E8A6-8845-BD4E-CB4CCA059FC4}" type="datetimeFigureOut">
               <a:rPr lang="en-US" smtClean="0"/>
-              <a:t>4/7/2026</a:t>
+              <a:t>4/15/2026</a:t>
             </a:fld>
             <a:endParaRPr lang="en-US"/>
           </a:p>
@@ -4527,7 +5752,7 @@
           <a:p>
             <a:fld id="{5BCAD085-E8A6-8845-BD4E-CB4CCA059FC4}" type="datetimeFigureOut">
               <a:rPr lang="en-US" smtClean="0"/>
-              <a:t>4/7/2026</a:t>
+              <a:t>4/15/2026</a:t>
             </a:fld>
             <a:endParaRPr lang="en-US"/>
           </a:p>
@@ -4669,7 +5894,7 @@
           <a:p>
             <a:fld id="{5BCAD085-E8A6-8845-BD4E-CB4CCA059FC4}" type="datetimeFigureOut">
               <a:rPr lang="en-US" smtClean="0"/>
-              <a:t>4/7/2026</a:t>
+              <a:t>4/15/2026</a:t>
             </a:fld>
             <a:endParaRPr lang="en-US"/>
           </a:p>
@@ -4782,7 +6007,7 @@
           <a:p>
             <a:fld id="{5BCAD085-E8A6-8845-BD4E-CB4CCA059FC4}" type="datetimeFigureOut">
               <a:rPr lang="en-US" smtClean="0"/>
-              <a:t>4/7/2026</a:t>
+              <a:t>4/15/2026</a:t>
             </a:fld>
             <a:endParaRPr lang="en-US"/>
           </a:p>
@@ -5095,7 +6320,7 @@
           <a:p>
             <a:fld id="{5BCAD085-E8A6-8845-BD4E-CB4CCA059FC4}" type="datetimeFigureOut">
               <a:rPr lang="en-US" smtClean="0"/>
-              <a:t>4/7/2026</a:t>
+              <a:t>4/15/2026</a:t>
             </a:fld>
             <a:endParaRPr lang="en-US"/>
           </a:p>
@@ -5384,7 +6609,7 @@
           <a:p>
             <a:fld id="{5BCAD085-E8A6-8845-BD4E-CB4CCA059FC4}" type="datetimeFigureOut">
               <a:rPr lang="en-US" smtClean="0"/>
-              <a:t>4/7/2026</a:t>
+              <a:t>4/15/2026</a:t>
             </a:fld>
             <a:endParaRPr lang="en-US"/>
           </a:p>
@@ -5627,7 +6852,7 @@
           <a:p>
             <a:fld id="{5BCAD085-E8A6-8845-BD4E-CB4CCA059FC4}" type="datetimeFigureOut">
               <a:rPr lang="en-US" smtClean="0"/>
-              <a:t>4/7/2026</a:t>
+              <a:t>4/15/2026</a:t>
             </a:fld>
             <a:endParaRPr lang="en-US"/>
           </a:p>
@@ -6082,7 +7307,7 @@
           <a:lstStyle/>
           <a:p>
             <a:r>
-              <a:rPr dirty="0"/>
+              <a:rPr lang="en-GB"/>
               <a:t>Wave Energy Converter Control Strategies</a:t>
             </a:r>
           </a:p>
@@ -6104,16 +7329,19 @@
           <a:lstStyle/>
           <a:p>
             <a:r>
+              <a:rPr lang="en-GB"/>
               <a:t>Point Absorber Buoy Model</a:t>
             </a:r>
           </a:p>
           <a:p>
             <a:r>
+              <a:rPr lang="en-GB"/>
               <a:t>Group 15</a:t>
             </a:r>
           </a:p>
           <a:p>
             <a:r>
+              <a:rPr lang="en-GB"/>
               <a:t>Wave Energy Project</a:t>
             </a:r>
           </a:p>
@@ -6128,6 +7356,264 @@
 </file>
 
 <file path=ppt/slides/slide10.xml><?xml version="1.0" encoding="utf-8"?>
+<p:sld xmlns:a="http://schemas.openxmlformats.org/drawingml/2006/main" xmlns:r="http://schemas.openxmlformats.org/officeDocument/2006/relationships" xmlns:p="http://schemas.openxmlformats.org/presentationml/2006/main">
+  <p:cSld>
+    <p:spTree>
+      <p:nvGrpSpPr>
+        <p:cNvPr id="1" name=""/>
+        <p:cNvGrpSpPr/>
+        <p:nvPr/>
+      </p:nvGrpSpPr>
+      <p:grpSpPr>
+        <a:xfrm>
+          <a:off x="0" y="0"/>
+          <a:ext cx="0" cy="0"/>
+          <a:chOff x="0" y="0"/>
+          <a:chExt cx="0" cy="0"/>
+        </a:xfrm>
+      </p:grpSpPr>
+      <p:sp>
+        <p:nvSpPr>
+          <p:cNvPr id="2" name="Title 1">
+            <a:extLst>
+              <a:ext uri="{FF2B5EF4-FFF2-40B4-BE49-F238E27FC236}">
+                <a16:creationId xmlns:a16="http://schemas.microsoft.com/office/drawing/2014/main" id="{05120DE7-21BA-4CE9-1242-89875301FF2C}"/>
+              </a:ext>
+            </a:extLst>
+          </p:cNvPr>
+          <p:cNvSpPr>
+            <a:spLocks noGrp="1"/>
+          </p:cNvSpPr>
+          <p:nvPr>
+            <p:ph type="title"/>
+          </p:nvPr>
+        </p:nvSpPr>
+        <p:spPr/>
+        <p:txBody>
+          <a:bodyPr/>
+          <a:lstStyle/>
+          <a:p>
+            <a:r>
+              <a:rPr lang="en-GB"/>
+              <a:t>Prerequisite for Control</a:t>
+            </a:r>
+          </a:p>
+        </p:txBody>
+      </p:sp>
+      <mc:AlternateContent xmlns:mc="http://schemas.openxmlformats.org/markup-compatibility/2006">
+        <mc:Choice xmlns:a14="http://schemas.microsoft.com/office/drawing/2010/main" Requires="a14">
+          <p:sp>
+            <p:nvSpPr>
+              <p:cNvPr id="3" name="Content Placeholder 2">
+                <a:extLst>
+                  <a:ext uri="{FF2B5EF4-FFF2-40B4-BE49-F238E27FC236}">
+                    <a16:creationId xmlns:a16="http://schemas.microsoft.com/office/drawing/2014/main" id="{58711827-53E6-D470-9DB2-DD5BC63D6AA5}"/>
+                  </a:ext>
+                </a:extLst>
+              </p:cNvPr>
+              <p:cNvSpPr>
+                <a:spLocks noGrp="1"/>
+              </p:cNvSpPr>
+              <p:nvPr>
+                <p:ph idx="1"/>
+              </p:nvPr>
+            </p:nvSpPr>
+            <p:spPr/>
+            <p:txBody>
+              <a:bodyPr/>
+              <a:lstStyle/>
+              <a:p>
+                <a:r>
+                  <a:rPr lang="en-GB"/>
+                  <a:t>Kalman Filter</a:t>
+                </a:r>
+              </a:p>
+              <a:p>
+                <a:r>
+                  <a:rPr lang="en-GB"/>
+                  <a:t>Autoregressive Model </a:t>
+                </a:r>
+              </a:p>
+              <a:p>
+                <a:r>
+                  <a:rPr lang="en-GB"/>
+                  <a:t>Prony’s Method</a:t>
+                </a:r>
+              </a:p>
+              <a:p>
+                <a14:m>
+                  <m:oMath xmlns:m="http://schemas.openxmlformats.org/officeDocument/2006/math">
+                    <a:fld id="{825F15A7-03F4-43D7-82C5-3E23DA2F108C}" type="mathplaceholder">
+                      <a:rPr lang="en-GB" i="1" smtClean="0">
+                        <a:latin typeface="Cambria Math" panose="02040503050406030204" pitchFamily="18" charset="0"/>
+                      </a:rPr>
+                      <a:t>Type equation here.</a:t>
+                    </a:fld>
+                  </m:oMath>
+                </a14:m>
+                <a:endParaRPr lang="en-GB"/>
+              </a:p>
+            </p:txBody>
+          </p:sp>
+        </mc:Choice>
+        <mc:Fallback>
+          <p:sp>
+            <p:nvSpPr>
+              <p:cNvPr id="3" name="Content Placeholder 2">
+                <a:extLst>
+                  <a:ext uri="{FF2B5EF4-FFF2-40B4-BE49-F238E27FC236}">
+                    <a16:creationId xmlns:a16="http://schemas.microsoft.com/office/drawing/2014/main" id="{58711827-53E6-D470-9DB2-DD5BC63D6AA5}"/>
+                  </a:ext>
+                </a:extLst>
+              </p:cNvPr>
+              <p:cNvSpPr>
+                <a:spLocks noGrp="1" noRot="1" noChangeAspect="1" noMove="1" noResize="1" noEditPoints="1" noAdjustHandles="1" noChangeArrowheads="1" noChangeShapeType="1" noTextEdit="1"/>
+              </p:cNvSpPr>
+              <p:nvPr>
+                <p:ph idx="1"/>
+              </p:nvPr>
+            </p:nvSpPr>
+            <p:spPr>
+              <a:blipFill>
+                <a:blip r:embed="rId2"/>
+                <a:stretch>
+                  <a:fillRect l="-1043" t="-2241"/>
+                </a:stretch>
+              </a:blipFill>
+            </p:spPr>
+            <p:txBody>
+              <a:bodyPr/>
+              <a:lstStyle/>
+              <a:p>
+                <a:r>
+                  <a:rPr lang="en-US">
+                    <a:noFill/>
+                  </a:rPr>
+                  <a:t> </a:t>
+                </a:r>
+              </a:p>
+            </p:txBody>
+          </p:sp>
+        </mc:Fallback>
+      </mc:AlternateContent>
+    </p:spTree>
+    <p:extLst>
+      <p:ext uri="{BB962C8B-B14F-4D97-AF65-F5344CB8AC3E}">
+        <p14:creationId xmlns:p14="http://schemas.microsoft.com/office/powerpoint/2010/main" val="1666967590"/>
+      </p:ext>
+    </p:extLst>
+  </p:cSld>
+  <p:clrMapOvr>
+    <a:masterClrMapping/>
+  </p:clrMapOvr>
+</p:sld>
+</file>
+
+<file path=ppt/slides/slide11.xml><?xml version="1.0" encoding="utf-8"?>
+<p:sld xmlns:a="http://schemas.openxmlformats.org/drawingml/2006/main" xmlns:r="http://schemas.openxmlformats.org/officeDocument/2006/relationships" xmlns:p="http://schemas.openxmlformats.org/presentationml/2006/main">
+  <p:cSld>
+    <p:spTree>
+      <p:nvGrpSpPr>
+        <p:cNvPr id="1" name=""/>
+        <p:cNvGrpSpPr/>
+        <p:nvPr/>
+      </p:nvGrpSpPr>
+      <p:grpSpPr>
+        <a:xfrm>
+          <a:off x="0" y="0"/>
+          <a:ext cx="0" cy="0"/>
+          <a:chOff x="0" y="0"/>
+          <a:chExt cx="0" cy="0"/>
+        </a:xfrm>
+      </p:grpSpPr>
+      <p:sp>
+        <p:nvSpPr>
+          <p:cNvPr id="2" name="Title 1">
+            <a:extLst>
+              <a:ext uri="{FF2B5EF4-FFF2-40B4-BE49-F238E27FC236}">
+                <a16:creationId xmlns:a16="http://schemas.microsoft.com/office/drawing/2014/main" id="{D72B11F3-AF95-B70D-0B83-93619F437DFB}"/>
+              </a:ext>
+            </a:extLst>
+          </p:cNvPr>
+          <p:cNvSpPr>
+            <a:spLocks noGrp="1"/>
+          </p:cNvSpPr>
+          <p:nvPr>
+            <p:ph type="title"/>
+          </p:nvPr>
+        </p:nvSpPr>
+        <p:spPr/>
+        <p:txBody>
+          <a:bodyPr/>
+          <a:lstStyle/>
+          <a:p>
+            <a:r>
+              <a:rPr lang="en-GB"/>
+              <a:t>Passive Damping</a:t>
+            </a:r>
+          </a:p>
+        </p:txBody>
+      </p:sp>
+      <p:sp>
+        <p:nvSpPr>
+          <p:cNvPr id="3" name="Content Placeholder 2">
+            <a:extLst>
+              <a:ext uri="{FF2B5EF4-FFF2-40B4-BE49-F238E27FC236}">
+                <a16:creationId xmlns:a16="http://schemas.microsoft.com/office/drawing/2014/main" id="{E4D6E862-163B-64B7-DEA0-D7B9B279B701}"/>
+              </a:ext>
+            </a:extLst>
+          </p:cNvPr>
+          <p:cNvSpPr>
+            <a:spLocks noGrp="1"/>
+          </p:cNvSpPr>
+          <p:nvPr>
+            <p:ph idx="1"/>
+          </p:nvPr>
+        </p:nvSpPr>
+        <p:spPr/>
+        <p:txBody>
+          <a:bodyPr/>
+          <a:lstStyle/>
+          <a:p>
+            <a:r>
+              <a:rPr lang="en-GB"/>
+              <a:t>What it is?</a:t>
+            </a:r>
+          </a:p>
+          <a:p>
+            <a:r>
+              <a:rPr lang="en-GB"/>
+              <a:t>Analytical tuning</a:t>
+            </a:r>
+          </a:p>
+          <a:p>
+            <a:r>
+              <a:rPr lang="en-GB"/>
+              <a:t>Grid search tuning</a:t>
+            </a:r>
+          </a:p>
+          <a:p>
+            <a:r>
+              <a:rPr lang="en-GB"/>
+              <a:t>Results</a:t>
+            </a:r>
+          </a:p>
+        </p:txBody>
+      </p:sp>
+    </p:spTree>
+    <p:extLst>
+      <p:ext uri="{BB962C8B-B14F-4D97-AF65-F5344CB8AC3E}">
+        <p14:creationId xmlns:p14="http://schemas.microsoft.com/office/powerpoint/2010/main" val="240379788"/>
+      </p:ext>
+    </p:extLst>
+  </p:cSld>
+  <p:clrMapOvr>
+    <a:masterClrMapping/>
+  </p:clrMapOvr>
+</p:sld>
+</file>
+
+<file path=ppt/slides/slide12.xml><?xml version="1.0" encoding="utf-8"?>
 <p:sld xmlns:a="http://schemas.openxmlformats.org/drawingml/2006/main" xmlns:r="http://schemas.openxmlformats.org/officeDocument/2006/relationships" xmlns:p="http://schemas.openxmlformats.org/presentationml/2006/main">
   <p:cSld>
     <p:spTree>
@@ -6166,7 +7652,7 @@
           <a:lstStyle/>
           <a:p>
             <a:r>
-              <a:rPr lang="en-GB" dirty="0"/>
+              <a:rPr lang="en-GB"/>
               <a:t>Latching Control</a:t>
             </a:r>
           </a:p>
@@ -6194,32 +7680,32 @@
           <a:lstStyle/>
           <a:p>
             <a:r>
-              <a:rPr lang="en-GB" dirty="0"/>
+              <a:rPr lang="en-GB"/>
               <a:t>What it is?</a:t>
             </a:r>
           </a:p>
           <a:p>
             <a:r>
-              <a:rPr lang="en-GB" dirty="0"/>
+              <a:rPr lang="en-GB"/>
               <a:t>Aim to keep excitation force and buoy in phase.</a:t>
             </a:r>
           </a:p>
           <a:p>
             <a:r>
-              <a:rPr lang="en-GB" dirty="0"/>
+              <a:rPr lang="en-GB"/>
               <a:t>Results.</a:t>
             </a:r>
           </a:p>
           <a:p>
             <a:r>
-              <a:rPr lang="en-GB" dirty="0"/>
+              <a:rPr lang="en-GB"/>
               <a:t>Comparison via Optimal Command Theory</a:t>
             </a:r>
           </a:p>
           <a:p>
             <a:r>
-              <a:rPr lang="en-GB" dirty="0"/>
-              <a:t>How Optimal Command Theory can be used with neural networks to be used as a real-time control.</a:t>
+              <a:rPr lang="en-GB"/>
+              <a:t>How Optimal Command Theory can be used with neural networks to be used as a real-time control</a:t>
             </a:r>
           </a:p>
         </p:txBody>
@@ -6237,7 +7723,7 @@
 </p:sld>
 </file>
 
-<file path=ppt/slides/slide11.xml><?xml version="1.0" encoding="utf-8"?>
+<file path=ppt/slides/slide13.xml><?xml version="1.0" encoding="utf-8"?>
 <p:sld xmlns:a="http://schemas.openxmlformats.org/drawingml/2006/main" xmlns:r="http://schemas.openxmlformats.org/officeDocument/2006/relationships" xmlns:p="http://schemas.openxmlformats.org/presentationml/2006/main">
   <p:cSld>
     <p:spTree>
@@ -6276,7 +7762,7 @@
           <a:lstStyle/>
           <a:p>
             <a:r>
-              <a:rPr lang="en-GB" dirty="0"/>
+              <a:rPr lang="en-GB"/>
               <a:t>Model Predictive Control</a:t>
             </a:r>
           </a:p>
@@ -6300,17 +7786,28 @@
         </p:nvSpPr>
         <p:spPr/>
         <p:txBody>
-          <a:bodyPr/>
+          <a:bodyPr vert="horz" lIns="91440" tIns="45720" rIns="91440" bIns="45720" rtlCol="0" anchor="t">
+            <a:normAutofit/>
+          </a:bodyPr>
           <a:lstStyle/>
           <a:p>
             <a:r>
-              <a:rPr lang="en-GB" dirty="0"/>
-              <a:t>What it is?</a:t>
-            </a:r>
-          </a:p>
-          <a:p>
-            <a:r>
-              <a:rPr lang="en-GB" dirty="0"/>
+              <a:rPr lang="en-GB"/>
+              <a:t>MPC is a control strategy which involves predicting behaviour over a time horizon and then optimising the control to maximise the power output.</a:t>
+            </a:r>
+          </a:p>
+          <a:p>
+            <a:r>
+              <a:rPr lang="en-GB"/>
+              <a:t>Kalman Filter Implementation</a:t>
+            </a:r>
+          </a:p>
+          <a:p>
+            <a:endParaRPr lang="en-GB"/>
+          </a:p>
+          <a:p>
+            <a:r>
+              <a:rPr lang="en-GB"/>
               <a:t>Results</a:t>
             </a:r>
           </a:p>
@@ -6329,7 +7826,104 @@
 </p:sld>
 </file>
 
-<file path=ppt/slides/slide12.xml><?xml version="1.0" encoding="utf-8"?>
+<file path=ppt/slides/slide14.xml><?xml version="1.0" encoding="utf-8"?>
+<p:sld xmlns:a="http://schemas.openxmlformats.org/drawingml/2006/main" xmlns:r="http://schemas.openxmlformats.org/officeDocument/2006/relationships" xmlns:p="http://schemas.openxmlformats.org/presentationml/2006/main">
+  <p:cSld>
+    <p:spTree>
+      <p:nvGrpSpPr>
+        <p:cNvPr id="1" name=""/>
+        <p:cNvGrpSpPr/>
+        <p:nvPr/>
+      </p:nvGrpSpPr>
+      <p:grpSpPr>
+        <a:xfrm>
+          <a:off x="0" y="0"/>
+          <a:ext cx="0" cy="0"/>
+          <a:chOff x="0" y="0"/>
+          <a:chExt cx="0" cy="0"/>
+        </a:xfrm>
+      </p:grpSpPr>
+      <p:sp>
+        <p:nvSpPr>
+          <p:cNvPr id="4" name="TextBox 3">
+            <a:extLst>
+              <a:ext uri="{FF2B5EF4-FFF2-40B4-BE49-F238E27FC236}">
+                <a16:creationId xmlns:a16="http://schemas.microsoft.com/office/drawing/2014/main" id="{ED064F4B-DC88-C716-87CB-96D582994A94}"/>
+              </a:ext>
+            </a:extLst>
+          </p:cNvPr>
+          <p:cNvSpPr txBox="1"/>
+          <p:nvPr/>
+        </p:nvSpPr>
+        <p:spPr>
+          <a:xfrm>
+            <a:off x="842228" y="361366"/>
+            <a:ext cx="4017524" cy="3785652"/>
+          </a:xfrm>
+          <a:prstGeom prst="rect">
+            <a:avLst/>
+          </a:prstGeom>
+          <a:noFill/>
+        </p:spPr>
+        <p:txBody>
+          <a:bodyPr rot="0" spcFirstLastPara="0" vertOverflow="overflow" horzOverflow="overflow" vert="horz" wrap="square" lIns="91440" tIns="45720" rIns="91440" bIns="45720" numCol="1" spcCol="0" rtlCol="0" fromWordArt="0" anchor="t" anchorCtr="0" forceAA="0" compatLnSpc="1">
+            <a:prstTxWarp prst="textNoShape">
+              <a:avLst/>
+            </a:prstTxWarp>
+            <a:spAutoFit/>
+          </a:bodyPr>
+          <a:lstStyle/>
+          <a:p>
+            <a:r>
+              <a:rPr lang="en-GB" sz="2400"/>
+              <a:t>The latch state is determined from a Hamiltonian, </a:t>
+            </a:r>
+            <a:r>
+              <a:rPr lang="en-GB" sz="2400">
+                <a:latin typeface="Cambria Math"/>
+                <a:ea typeface="Cambria Math"/>
+              </a:rPr>
+              <a:t>H</a:t>
+            </a:r>
+            <a:r>
+              <a:rPr lang="en-GB" sz="2400"/>
+              <a:t>. </a:t>
+            </a:r>
+            <a:endParaRPr lang="en-US" sz="2400"/>
+          </a:p>
+          <a:p>
+            <a:r>
+              <a:rPr lang="en-GB" sz="2400">
+                <a:latin typeface="Cambria Math"/>
+                <a:ea typeface="Cambria Math"/>
+              </a:rPr>
+              <a:t>H</a:t>
+            </a:r>
+            <a:r>
+              <a:rPr lang="en-GB" sz="2400"/>
+              <a:t> can be thought of as an instantaneous score, measuring both the power currently being captured, and how current trajectory is affecting future energy capture.</a:t>
+            </a:r>
+          </a:p>
+          <a:p>
+            <a:pPr algn="l"/>
+            <a:endParaRPr lang="en-GB" sz="2400"/>
+          </a:p>
+        </p:txBody>
+      </p:sp>
+    </p:spTree>
+    <p:extLst>
+      <p:ext uri="{BB962C8B-B14F-4D97-AF65-F5344CB8AC3E}">
+        <p14:creationId xmlns:p14="http://schemas.microsoft.com/office/powerpoint/2010/main" val="2638567684"/>
+      </p:ext>
+    </p:extLst>
+  </p:cSld>
+  <p:clrMapOvr>
+    <a:masterClrMapping/>
+  </p:clrMapOvr>
+</p:sld>
+</file>
+
+<file path=ppt/slides/slide15.xml><?xml version="1.0" encoding="utf-8"?>
 <p:sld xmlns:a="http://schemas.openxmlformats.org/drawingml/2006/main" xmlns:r="http://schemas.openxmlformats.org/officeDocument/2006/relationships" xmlns:p="http://schemas.openxmlformats.org/presentationml/2006/main">
   <p:cSld>
     <p:spTree>
@@ -6406,7 +8000,7 @@
 </p:sld>
 </file>
 
-<file path=ppt/slides/slide13.xml><?xml version="1.0" encoding="utf-8"?>
+<file path=ppt/slides/slide16.xml><?xml version="1.0" encoding="utf-8"?>
 <p:sld xmlns:a="http://schemas.openxmlformats.org/drawingml/2006/main" xmlns:r="http://schemas.openxmlformats.org/officeDocument/2006/relationships" xmlns:p="http://schemas.openxmlformats.org/presentationml/2006/main">
   <p:cSld>
     <p:spTree>
@@ -6488,7 +8082,7 @@
 </p:sld>
 </file>
 
-<file path=ppt/slides/slide14.xml><?xml version="1.0" encoding="utf-8"?>
+<file path=ppt/slides/slide17.xml><?xml version="1.0" encoding="utf-8"?>
 <p:sld xmlns:a="http://schemas.openxmlformats.org/drawingml/2006/main" xmlns:r="http://schemas.openxmlformats.org/officeDocument/2006/relationships" xmlns:p="http://schemas.openxmlformats.org/presentationml/2006/main">
   <p:cSld>
     <p:spTree>
@@ -6542,23 +8136,20 @@
           <a:lstStyle/>
           <a:p>
             <a:r>
-              <a:rPr dirty="0"/>
               <a:t>Extend to multi-degree motion</a:t>
             </a:r>
           </a:p>
           <a:p>
             <a:r>
-              <a:rPr dirty="0"/>
               <a:t>Nonlinear modelling</a:t>
             </a:r>
           </a:p>
           <a:p>
             <a:r>
-              <a:rPr lang="en-GB" dirty="0"/>
+              <a:rPr lang="en-GB"/>
               <a:t>Further </a:t>
             </a:r>
             <a:r>
-              <a:rPr dirty="0"/>
               <a:t>Adaptive control strategies</a:t>
             </a:r>
           </a:p>
@@ -6896,18 +8487,17 @@
           <a:lstStyle/>
           <a:p>
             <a:r>
-              <a:rPr lang="en-GB" dirty="0"/>
+              <a:rPr lang="en-GB"/>
               <a:t>Comparable </a:t>
             </a:r>
             <a:r>
-              <a:rPr dirty="0"/>
               <a:t>Mathematical Model</a:t>
             </a:r>
             <a:r>
-              <a:rPr lang="en-GB" dirty="0"/>
+              <a:rPr lang="en-GB"/>
               <a:t>ling</a:t>
             </a:r>
-            <a:endParaRPr dirty="0"/>
+            <a:endParaRPr/>
           </a:p>
         </p:txBody>
       </p:sp>
@@ -6927,19 +8517,16 @@
           <a:lstStyle/>
           <a:p>
             <a:r>
-              <a:rPr dirty="0"/>
               <a:t>Modelled as a forced damped oscillator</a:t>
             </a:r>
           </a:p>
           <a:p>
             <a:r>
-              <a:rPr dirty="0"/>
               <a:t>Includes added mass and hydrostatic stiffness</a:t>
             </a:r>
           </a:p>
           <a:p>
             <a:r>
-              <a:rPr dirty="0"/>
               <a:t>Cummins equation introduces memory effects</a:t>
             </a:r>
           </a:p>
@@ -6972,7 +8559,13 @@
       </p:grpSpPr>
       <p:sp>
         <p:nvSpPr>
-          <p:cNvPr id="2" name="Title 1"/>
+          <p:cNvPr id="2" name="Title 1">
+            <a:extLst>
+              <a:ext uri="{FF2B5EF4-FFF2-40B4-BE49-F238E27FC236}">
+                <a16:creationId xmlns:a16="http://schemas.microsoft.com/office/drawing/2014/main" id="{3C8CAC2E-D5A4-E351-1066-B4F8249862B8}"/>
+              </a:ext>
+            </a:extLst>
+          </p:cNvPr>
           <p:cNvSpPr>
             <a:spLocks noGrp="1"/>
           </p:cNvSpPr>
@@ -6986,51 +8579,394 @@
           <a:lstStyle/>
           <a:p>
             <a:r>
-              <a:rPr dirty="0"/>
-              <a:t>Hydrodynamic Model</a:t>
+              <a:rPr lang="en-GB"/>
+              <a:t>Finding resonant mass of buoy</a:t>
             </a:r>
           </a:p>
         </p:txBody>
       </p:sp>
-      <p:sp>
-        <p:nvSpPr>
-          <p:cNvPr id="3" name="Content Placeholder 2"/>
-          <p:cNvSpPr>
-            <a:spLocks noGrp="1"/>
-          </p:cNvSpPr>
-          <p:nvPr>
-            <p:ph idx="1"/>
-          </p:nvPr>
-        </p:nvSpPr>
-        <p:spPr/>
-        <p:txBody>
-          <a:bodyPr/>
-          <a:lstStyle/>
-          <a:p>
-            <a:r>
-              <a:rPr dirty="0" err="1"/>
-              <a:t>Capytaine</a:t>
-            </a:r>
-            <a:r>
-              <a:rPr dirty="0"/>
-              <a:t> BEM solver used</a:t>
-            </a:r>
-          </a:p>
-          <a:p>
-            <a:r>
-              <a:rPr dirty="0"/>
-              <a:t>Computes added mass and damping</a:t>
-            </a:r>
-          </a:p>
-          <a:p>
-            <a:r>
-              <a:rPr dirty="0"/>
-              <a:t>Provides excitation forces</a:t>
-            </a:r>
-          </a:p>
-        </p:txBody>
-      </p:sp>
+      <mc:AlternateContent xmlns:mc="http://schemas.openxmlformats.org/markup-compatibility/2006">
+        <mc:Choice xmlns:a14="http://schemas.microsoft.com/office/drawing/2010/main" Requires="a14">
+          <p:sp>
+            <p:nvSpPr>
+              <p:cNvPr id="3" name="Content Placeholder 2">
+                <a:extLst>
+                  <a:ext uri="{FF2B5EF4-FFF2-40B4-BE49-F238E27FC236}">
+                    <a16:creationId xmlns:a16="http://schemas.microsoft.com/office/drawing/2014/main" id="{BB244909-EFB2-E390-DF7C-016465B37DEA}"/>
+                  </a:ext>
+                </a:extLst>
+              </p:cNvPr>
+              <p:cNvSpPr>
+                <a:spLocks noGrp="1"/>
+              </p:cNvSpPr>
+              <p:nvPr>
+                <p:ph idx="1"/>
+              </p:nvPr>
+            </p:nvSpPr>
+            <p:spPr/>
+            <p:txBody>
+              <a:bodyPr/>
+              <a:lstStyle/>
+              <a:p>
+                <a:r>
+                  <a:rPr lang="en-GB"/>
+                  <a:t>Point absorber is designed such that heave amplitude and energy capture is maximised</a:t>
+                </a:r>
+              </a:p>
+              <a:p>
+                <a:r>
+                  <a:rPr lang="en-GB"/>
+                  <a:t>This occurs when the buoy is oscillating in resonance with incoming waves</a:t>
+                </a:r>
+              </a:p>
+              <a:p>
+                <a:r>
+                  <a:rPr lang="en-GB"/>
+                  <a:t>Heave amplitude </a:t>
+                </a:r>
+                <a14:m>
+                  <m:oMath xmlns:m="http://schemas.openxmlformats.org/officeDocument/2006/math">
+                    <m:d>
+                      <m:dPr>
+                        <m:begChr m:val="|"/>
+                        <m:endChr m:val="|"/>
+                        <m:ctrlPr>
+                          <a:rPr lang="en-GB" i="1" dirty="0" smtClean="0">
+                            <a:latin typeface="Cambria Math" panose="02040503050406030204" pitchFamily="18" charset="0"/>
+                          </a:rPr>
+                        </m:ctrlPr>
+                      </m:dPr>
+                      <m:e>
+                        <m:sSub>
+                          <m:sSubPr>
+                            <m:ctrlPr>
+                              <a:rPr lang="en-GB" i="1" dirty="0" smtClean="0">
+                                <a:latin typeface="Cambria Math" panose="02040503050406030204" pitchFamily="18" charset="0"/>
+                              </a:rPr>
+                            </m:ctrlPr>
+                          </m:sSubPr>
+                          <m:e>
+                            <m:r>
+                              <a:rPr lang="en-GB" i="1" dirty="0" smtClean="0">
+                                <a:latin typeface="Cambria Math" panose="02040503050406030204" pitchFamily="18" charset="0"/>
+                              </a:rPr>
+                              <m:t>𝜁</m:t>
+                            </m:r>
+                          </m:e>
+                          <m:sub>
+                            <m:r>
+                              <a:rPr lang="en-GB" i="1" dirty="0">
+                                <a:latin typeface="Cambria Math" panose="02040503050406030204" pitchFamily="18" charset="0"/>
+                              </a:rPr>
+                              <m:t>0</m:t>
+                            </m:r>
+                          </m:sub>
+                        </m:sSub>
+                      </m:e>
+                    </m:d>
+                    <m:r>
+                      <a:rPr lang="en-GB" i="1" dirty="0">
+                        <a:latin typeface="Cambria Math" panose="02040503050406030204" pitchFamily="18" charset="0"/>
+                      </a:rPr>
+                      <m:t>=</m:t>
+                    </m:r>
+                    <m:f>
+                      <m:fPr>
+                        <m:ctrlPr>
+                          <a:rPr lang="en-GB" i="1" dirty="0">
+                            <a:latin typeface="Cambria Math" panose="02040503050406030204" pitchFamily="18" charset="0"/>
+                          </a:rPr>
+                        </m:ctrlPr>
+                      </m:fPr>
+                      <m:num>
+                        <m:r>
+                          <a:rPr lang="en-GB" i="1" dirty="0">
+                            <a:latin typeface="Cambria Math" panose="02040503050406030204" pitchFamily="18" charset="0"/>
+                          </a:rPr>
+                          <m:t>𝑎</m:t>
+                        </m:r>
+                      </m:num>
+                      <m:den>
+                        <m:rad>
+                          <m:radPr>
+                            <m:degHide m:val="on"/>
+                            <m:ctrlPr>
+                              <a:rPr lang="en-GB" i="1" dirty="0">
+                                <a:latin typeface="Cambria Math" panose="02040503050406030204" pitchFamily="18" charset="0"/>
+                              </a:rPr>
+                            </m:ctrlPr>
+                          </m:radPr>
+                          <m:deg/>
+                          <m:e>
+                            <m:sSup>
+                              <m:sSupPr>
+                                <m:ctrlPr>
+                                  <a:rPr lang="en-GB" i="1" dirty="0">
+                                    <a:latin typeface="Cambria Math" panose="02040503050406030204" pitchFamily="18" charset="0"/>
+                                  </a:rPr>
+                                </m:ctrlPr>
+                              </m:sSupPr>
+                              <m:e>
+                                <m:d>
+                                  <m:dPr>
+                                    <m:ctrlPr>
+                                      <a:rPr lang="en-GB" i="1" dirty="0">
+                                        <a:latin typeface="Cambria Math" panose="02040503050406030204" pitchFamily="18" charset="0"/>
+                                      </a:rPr>
+                                    </m:ctrlPr>
+                                  </m:dPr>
+                                  <m:e>
+                                    <m:r>
+                                      <a:rPr lang="en-GB" i="1" dirty="0">
+                                        <a:latin typeface="Cambria Math" panose="02040503050406030204" pitchFamily="18" charset="0"/>
+                                      </a:rPr>
+                                      <m:t>1−</m:t>
+                                    </m:r>
+                                    <m:r>
+                                      <a:rPr lang="en-GB" i="1" dirty="0">
+                                        <a:latin typeface="Cambria Math" panose="02040503050406030204" pitchFamily="18" charset="0"/>
+                                      </a:rPr>
+                                      <m:t>𝑚</m:t>
+                                    </m:r>
+                                  </m:e>
+                                </m:d>
+                              </m:e>
+                              <m:sup>
+                                <m:r>
+                                  <a:rPr lang="en-GB" i="1" dirty="0">
+                                    <a:latin typeface="Cambria Math" panose="02040503050406030204" pitchFamily="18" charset="0"/>
+                                  </a:rPr>
+                                  <m:t>2</m:t>
+                                </m:r>
+                              </m:sup>
+                            </m:sSup>
+                            <m:r>
+                              <a:rPr lang="en-GB" i="1" dirty="0">
+                                <a:latin typeface="Cambria Math" panose="02040503050406030204" pitchFamily="18" charset="0"/>
+                              </a:rPr>
+                              <m:t>+</m:t>
+                            </m:r>
+                            <m:sSup>
+                              <m:sSupPr>
+                                <m:ctrlPr>
+                                  <a:rPr lang="en-GB" i="1" dirty="0">
+                                    <a:latin typeface="Cambria Math" panose="02040503050406030204" pitchFamily="18" charset="0"/>
+                                  </a:rPr>
+                                </m:ctrlPr>
+                              </m:sSupPr>
+                              <m:e>
+                                <m:r>
+                                  <a:rPr lang="en-GB" i="1" dirty="0">
+                                    <a:latin typeface="Cambria Math" panose="02040503050406030204" pitchFamily="18" charset="0"/>
+                                  </a:rPr>
+                                  <m:t>𝑚</m:t>
+                                </m:r>
+                              </m:e>
+                              <m:sup>
+                                <m:r>
+                                  <a:rPr lang="en-GB" i="1" dirty="0">
+                                    <a:latin typeface="Cambria Math" panose="02040503050406030204" pitchFamily="18" charset="0"/>
+                                  </a:rPr>
+                                  <m:t>2</m:t>
+                                </m:r>
+                              </m:sup>
+                            </m:sSup>
+                            <m:sSup>
+                              <m:sSupPr>
+                                <m:ctrlPr>
+                                  <a:rPr lang="en-GB" i="1" dirty="0">
+                                    <a:latin typeface="Cambria Math" panose="02040503050406030204" pitchFamily="18" charset="0"/>
+                                  </a:rPr>
+                                </m:ctrlPr>
+                              </m:sSupPr>
+                              <m:e>
+                                <m:r>
+                                  <a:rPr lang="en-GB" i="1" dirty="0" err="1">
+                                    <a:latin typeface="Cambria Math" panose="02040503050406030204" pitchFamily="18" charset="0"/>
+                                  </a:rPr>
+                                  <m:t>𝑏</m:t>
+                                </m:r>
+                              </m:e>
+                              <m:sup>
+                                <m:r>
+                                  <a:rPr lang="en-GB" i="1" dirty="0">
+                                    <a:latin typeface="Cambria Math" panose="02040503050406030204" pitchFamily="18" charset="0"/>
+                                  </a:rPr>
+                                  <m:t>2</m:t>
+                                </m:r>
+                              </m:sup>
+                            </m:sSup>
+                          </m:e>
+                        </m:rad>
+                      </m:den>
+                    </m:f>
+                  </m:oMath>
+                </a14:m>
+                <a:r>
+                  <a:rPr lang="en-GB"/>
+                  <a:t> where  </a:t>
+                </a:r>
+                <a14:m>
+                  <m:oMath xmlns:m="http://schemas.openxmlformats.org/officeDocument/2006/math">
+                    <m:r>
+                      <a:rPr lang="en-GB" i="1" dirty="0" smtClean="0">
+                        <a:latin typeface="Cambria Math" panose="02040503050406030204" pitchFamily="18" charset="0"/>
+                      </a:rPr>
+                      <m:t>𝑚</m:t>
+                    </m:r>
+                    <m:r>
+                      <a:rPr lang="en-GB" i="1" dirty="0" smtClean="0">
+                        <a:latin typeface="Cambria Math" panose="02040503050406030204" pitchFamily="18" charset="0"/>
+                      </a:rPr>
+                      <m:t>=</m:t>
+                    </m:r>
+                    <m:f>
+                      <m:fPr>
+                        <m:ctrlPr>
+                          <a:rPr lang="en-GB" i="1" dirty="0" smtClean="0">
+                            <a:latin typeface="Cambria Math" panose="02040503050406030204" pitchFamily="18" charset="0"/>
+                          </a:rPr>
+                        </m:ctrlPr>
+                      </m:fPr>
+                      <m:num>
+                        <m:r>
+                          <a:rPr lang="en-GB" i="1" dirty="0" smtClean="0">
+                            <a:latin typeface="Cambria Math" panose="02040503050406030204" pitchFamily="18" charset="0"/>
+                          </a:rPr>
+                          <m:t>𝑀</m:t>
+                        </m:r>
+                        <m:sSup>
+                          <m:sSupPr>
+                            <m:ctrlPr>
+                              <a:rPr lang="en-GB" i="1" dirty="0" smtClean="0">
+                                <a:latin typeface="Cambria Math" panose="02040503050406030204" pitchFamily="18" charset="0"/>
+                              </a:rPr>
+                            </m:ctrlPr>
+                          </m:sSupPr>
+                          <m:e>
+                            <m:r>
+                              <a:rPr lang="en-GB" i="1" dirty="0" smtClean="0">
+                                <a:latin typeface="Cambria Math" panose="02040503050406030204" pitchFamily="18" charset="0"/>
+                              </a:rPr>
+                              <m:t>𝜔</m:t>
+                            </m:r>
+                          </m:e>
+                          <m:sup>
+                            <m:r>
+                              <a:rPr lang="en-GB" i="1" dirty="0" smtClean="0">
+                                <a:latin typeface="Cambria Math" panose="02040503050406030204" pitchFamily="18" charset="0"/>
+                              </a:rPr>
+                              <m:t>2</m:t>
+                            </m:r>
+                          </m:sup>
+                        </m:sSup>
+                      </m:num>
+                      <m:den>
+                        <m:r>
+                          <a:rPr lang="en-GB" i="1" dirty="0" smtClean="0">
+                            <a:latin typeface="Cambria Math" panose="02040503050406030204" pitchFamily="18" charset="0"/>
+                          </a:rPr>
+                          <m:t>𝜌</m:t>
+                        </m:r>
+                        <m:r>
+                          <a:rPr lang="en-GB" i="1" dirty="0" smtClean="0">
+                            <a:latin typeface="Cambria Math" panose="02040503050406030204" pitchFamily="18" charset="0"/>
+                          </a:rPr>
+                          <m:t>𝑔𝐴</m:t>
+                        </m:r>
+                      </m:den>
+                    </m:f>
+                  </m:oMath>
+                </a14:m>
+                <a:r>
+                  <a:rPr lang="en-GB"/>
+                  <a:t>  [REF:OCEAN WIKI]</a:t>
+                </a:r>
+              </a:p>
+              <a:p>
+                <a:r>
+                  <a:rPr lang="en-GB"/>
+                  <a:t>Target wave frequency is f = 0.25 </a:t>
+                </a:r>
+                <a:r>
+                  <a:rPr lang="en-GB" err="1"/>
+                  <a:t>hz</a:t>
+                </a:r>
+                <a:endParaRPr lang="en-GB"/>
+              </a:p>
+              <a:p>
+                <a:endParaRPr lang="en-GB"/>
+              </a:p>
+              <a:p>
+                <a:endParaRPr lang="en-GB"/>
+              </a:p>
+              <a:p>
+                <a:endParaRPr lang="en-GB"/>
+              </a:p>
+              <a:p>
+                <a:endParaRPr lang="en-GB"/>
+              </a:p>
+              <a:p>
+                <a:endParaRPr lang="en-GB"/>
+              </a:p>
+              <a:p>
+                <a:endParaRPr lang="en-GB"/>
+              </a:p>
+              <a:p>
+                <a:pPr marL="0" indent="0">
+                  <a:buNone/>
+                </a:pPr>
+                <a:endParaRPr lang="en-GB"/>
+              </a:p>
+            </p:txBody>
+          </p:sp>
+        </mc:Choice>
+        <mc:Fallback>
+          <p:sp>
+            <p:nvSpPr>
+              <p:cNvPr id="3" name="Content Placeholder 2">
+                <a:extLst>
+                  <a:ext uri="{FF2B5EF4-FFF2-40B4-BE49-F238E27FC236}">
+                    <a16:creationId xmlns:a16="http://schemas.microsoft.com/office/drawing/2014/main" id="{BB244909-EFB2-E390-DF7C-016465B37DEA}"/>
+                  </a:ext>
+                </a:extLst>
+              </p:cNvPr>
+              <p:cNvSpPr>
+                <a:spLocks noGrp="1" noRot="1" noChangeAspect="1" noMove="1" noResize="1" noEditPoints="1" noAdjustHandles="1" noChangeArrowheads="1" noChangeShapeType="1" noTextEdit="1"/>
+              </p:cNvSpPr>
+              <p:nvPr>
+                <p:ph idx="1"/>
+              </p:nvPr>
+            </p:nvSpPr>
+            <p:spPr>
+              <a:blipFill>
+                <a:blip r:embed="rId3"/>
+                <a:stretch>
+                  <a:fillRect l="-1043" t="-2241" r="-812"/>
+                </a:stretch>
+              </a:blipFill>
+            </p:spPr>
+            <p:txBody>
+              <a:bodyPr/>
+              <a:lstStyle/>
+              <a:p>
+                <a:r>
+                  <a:rPr lang="en-US">
+                    <a:noFill/>
+                  </a:rPr>
+                  <a:t> </a:t>
+                </a:r>
+              </a:p>
+            </p:txBody>
+          </p:sp>
+        </mc:Fallback>
+      </mc:AlternateContent>
     </p:spTree>
+    <p:extLst>
+      <p:ext uri="{BB962C8B-B14F-4D97-AF65-F5344CB8AC3E}">
+        <p14:creationId xmlns:p14="http://schemas.microsoft.com/office/powerpoint/2010/main" val="772203802"/>
+      </p:ext>
+    </p:extLst>
   </p:cSld>
   <p:clrMapOvr>
     <a:masterClrMapping/>
@@ -7071,14 +9007,8 @@
           <a:lstStyle/>
           <a:p>
             <a:r>
-              <a:rPr dirty="0"/>
-              <a:t>Modelling</a:t>
-            </a:r>
-            <a:r>
-              <a:rPr lang="en-GB" dirty="0"/>
-              <a:t> Sea States</a:t>
-            </a:r>
-            <a:endParaRPr dirty="0"/>
+              <a:t>Hydrodynamic Model</a:t>
+            </a:r>
           </a:p>
         </p:txBody>
       </p:sp>
@@ -7098,20 +9028,24 @@
           <a:lstStyle/>
           <a:p>
             <a:r>
-              <a:rPr dirty="0"/>
-              <a:t>Real waves are irregular</a:t>
-            </a:r>
-          </a:p>
-          <a:p>
-            <a:r>
-              <a:rPr dirty="0"/>
-              <a:t>JONSWAP spectrum used</a:t>
-            </a:r>
-          </a:p>
-          <a:p>
-            <a:r>
-              <a:rPr dirty="0"/>
-              <a:t>Multiple frequencies with random phases</a:t>
+              <a:rPr lang="en-GB" err="1"/>
+              <a:t>Capytaine</a:t>
+            </a:r>
+            <a:r>
+              <a:rPr lang="en-GB"/>
+              <a:t> BEM solver used</a:t>
+            </a:r>
+          </a:p>
+          <a:p>
+            <a:r>
+              <a:rPr lang="en-GB"/>
+              <a:t>Computes added mass and damping</a:t>
+            </a:r>
+          </a:p>
+          <a:p>
+            <a:r>
+              <a:rPr lang="en-GB"/>
+              <a:t>Provides excitation forces</a:t>
             </a:r>
           </a:p>
         </p:txBody>
@@ -7125,6 +9059,88 @@
 </file>
 
 <file path=ppt/slides/slide7.xml><?xml version="1.0" encoding="utf-8"?>
+<p:sld xmlns:a="http://schemas.openxmlformats.org/drawingml/2006/main" xmlns:r="http://schemas.openxmlformats.org/officeDocument/2006/relationships" xmlns:p="http://schemas.openxmlformats.org/presentationml/2006/main">
+  <p:cSld>
+    <p:spTree>
+      <p:nvGrpSpPr>
+        <p:cNvPr id="1" name=""/>
+        <p:cNvGrpSpPr/>
+        <p:nvPr/>
+      </p:nvGrpSpPr>
+      <p:grpSpPr>
+        <a:xfrm>
+          <a:off x="0" y="0"/>
+          <a:ext cx="0" cy="0"/>
+          <a:chOff x="0" y="0"/>
+          <a:chExt cx="0" cy="0"/>
+        </a:xfrm>
+      </p:grpSpPr>
+      <p:sp>
+        <p:nvSpPr>
+          <p:cNvPr id="2" name="Title 1"/>
+          <p:cNvSpPr>
+            <a:spLocks noGrp="1"/>
+          </p:cNvSpPr>
+          <p:nvPr>
+            <p:ph type="title"/>
+          </p:nvPr>
+        </p:nvSpPr>
+        <p:spPr/>
+        <p:txBody>
+          <a:bodyPr/>
+          <a:lstStyle/>
+          <a:p>
+            <a:r>
+              <a:t>Modelling</a:t>
+            </a:r>
+            <a:r>
+              <a:rPr lang="en-GB"/>
+              <a:t> Sea States</a:t>
+            </a:r>
+            <a:endParaRPr/>
+          </a:p>
+        </p:txBody>
+      </p:sp>
+      <p:sp>
+        <p:nvSpPr>
+          <p:cNvPr id="3" name="Content Placeholder 2"/>
+          <p:cNvSpPr>
+            <a:spLocks noGrp="1"/>
+          </p:cNvSpPr>
+          <p:nvPr>
+            <p:ph idx="1"/>
+          </p:nvPr>
+        </p:nvSpPr>
+        <p:spPr/>
+        <p:txBody>
+          <a:bodyPr/>
+          <a:lstStyle/>
+          <a:p>
+            <a:r>
+              <a:t>Real waves are irregular</a:t>
+            </a:r>
+          </a:p>
+          <a:p>
+            <a:r>
+              <a:t>JONSWAP spectrum used</a:t>
+            </a:r>
+          </a:p>
+          <a:p>
+            <a:r>
+              <a:t>Multiple frequencies with random phases</a:t>
+            </a:r>
+          </a:p>
+        </p:txBody>
+      </p:sp>
+    </p:spTree>
+  </p:cSld>
+  <p:clrMapOvr>
+    <a:masterClrMapping/>
+  </p:clrMapOvr>
+</p:sld>
+</file>
+
+<file path=ppt/slides/slide8.xml><?xml version="1.0" encoding="utf-8"?>
 <p:sld xmlns:a="http://schemas.openxmlformats.org/drawingml/2006/main" xmlns:r="http://schemas.openxmlformats.org/officeDocument/2006/relationships" xmlns:p="http://schemas.openxmlformats.org/presentationml/2006/main">
   <p:cSld>
     <p:spTree>
@@ -7163,7 +9179,7 @@
           <a:lstStyle/>
           <a:p>
             <a:r>
-              <a:rPr lang="en-GB" dirty="0"/>
+              <a:rPr lang="en-GB"/>
               <a:t>Control Strategies</a:t>
             </a:r>
           </a:p>
@@ -7187,29 +9203,37 @@
         </p:nvSpPr>
         <p:spPr/>
         <p:txBody>
-          <a:bodyPr/>
+          <a:bodyPr vert="horz" lIns="91440" tIns="45720" rIns="91440" bIns="45720" rtlCol="0" anchor="t">
+            <a:normAutofit/>
+          </a:bodyPr>
           <a:lstStyle/>
           <a:p>
             <a:r>
-              <a:rPr lang="en-GB" dirty="0"/>
+              <a:rPr lang="en-GB"/>
+              <a:t>Fixed controls</a:t>
+            </a:r>
+          </a:p>
+          <a:p>
+            <a:r>
+              <a:rPr lang="en-GB"/>
               <a:t>Passive Damping</a:t>
             </a:r>
           </a:p>
           <a:p>
             <a:r>
-              <a:rPr lang="en-GB" dirty="0"/>
+              <a:rPr lang="en-GB"/>
               <a:t>Predictive Damping</a:t>
             </a:r>
           </a:p>
           <a:p>
             <a:r>
-              <a:rPr lang="en-GB" dirty="0"/>
+              <a:rPr lang="en-GB"/>
               <a:t>Latch Control</a:t>
             </a:r>
           </a:p>
           <a:p>
             <a:r>
-              <a:rPr lang="en-GB" dirty="0"/>
+              <a:rPr lang="en-GB"/>
               <a:t>RL Control</a:t>
             </a:r>
           </a:p>
@@ -7219,98 +9243,6 @@
     <p:extLst>
       <p:ext uri="{BB962C8B-B14F-4D97-AF65-F5344CB8AC3E}">
         <p14:creationId xmlns:p14="http://schemas.microsoft.com/office/powerpoint/2010/main" val="1816702450"/>
-      </p:ext>
-    </p:extLst>
-  </p:cSld>
-  <p:clrMapOvr>
-    <a:masterClrMapping/>
-  </p:clrMapOvr>
-</p:sld>
-</file>
-
-<file path=ppt/slides/slide8.xml><?xml version="1.0" encoding="utf-8"?>
-<p:sld xmlns:a="http://schemas.openxmlformats.org/drawingml/2006/main" xmlns:r="http://schemas.openxmlformats.org/officeDocument/2006/relationships" xmlns:p="http://schemas.openxmlformats.org/presentationml/2006/main">
-  <p:cSld>
-    <p:spTree>
-      <p:nvGrpSpPr>
-        <p:cNvPr id="1" name=""/>
-        <p:cNvGrpSpPr/>
-        <p:nvPr/>
-      </p:nvGrpSpPr>
-      <p:grpSpPr>
-        <a:xfrm>
-          <a:off x="0" y="0"/>
-          <a:ext cx="0" cy="0"/>
-          <a:chOff x="0" y="0"/>
-          <a:chExt cx="0" cy="0"/>
-        </a:xfrm>
-      </p:grpSpPr>
-      <p:sp>
-        <p:nvSpPr>
-          <p:cNvPr id="2" name="Title 1">
-            <a:extLst>
-              <a:ext uri="{FF2B5EF4-FFF2-40B4-BE49-F238E27FC236}">
-                <a16:creationId xmlns:a16="http://schemas.microsoft.com/office/drawing/2014/main" id="{05120DE7-21BA-4CE9-1242-89875301FF2C}"/>
-              </a:ext>
-            </a:extLst>
-          </p:cNvPr>
-          <p:cNvSpPr>
-            <a:spLocks noGrp="1"/>
-          </p:cNvSpPr>
-          <p:nvPr>
-            <p:ph type="title"/>
-          </p:nvPr>
-        </p:nvSpPr>
-        <p:spPr/>
-        <p:txBody>
-          <a:bodyPr/>
-          <a:lstStyle/>
-          <a:p>
-            <a:r>
-              <a:rPr lang="en-GB" dirty="0"/>
-              <a:t>Prerequisite for Control</a:t>
-            </a:r>
-          </a:p>
-        </p:txBody>
-      </p:sp>
-      <p:sp>
-        <p:nvSpPr>
-          <p:cNvPr id="3" name="Content Placeholder 2">
-            <a:extLst>
-              <a:ext uri="{FF2B5EF4-FFF2-40B4-BE49-F238E27FC236}">
-                <a16:creationId xmlns:a16="http://schemas.microsoft.com/office/drawing/2014/main" id="{58711827-53E6-D470-9DB2-DD5BC63D6AA5}"/>
-              </a:ext>
-            </a:extLst>
-          </p:cNvPr>
-          <p:cNvSpPr>
-            <a:spLocks noGrp="1"/>
-          </p:cNvSpPr>
-          <p:nvPr>
-            <p:ph idx="1"/>
-          </p:nvPr>
-        </p:nvSpPr>
-        <p:spPr/>
-        <p:txBody>
-          <a:bodyPr/>
-          <a:lstStyle/>
-          <a:p>
-            <a:r>
-              <a:rPr lang="en-GB" dirty="0"/>
-              <a:t>Kalman Filter</a:t>
-            </a:r>
-          </a:p>
-          <a:p>
-            <a:r>
-              <a:rPr lang="en-GB" dirty="0"/>
-              <a:t>Autoregressive Model </a:t>
-            </a:r>
-          </a:p>
-        </p:txBody>
-      </p:sp>
-    </p:spTree>
-    <p:extLst>
-      <p:ext uri="{BB962C8B-B14F-4D97-AF65-F5344CB8AC3E}">
-        <p14:creationId xmlns:p14="http://schemas.microsoft.com/office/powerpoint/2010/main" val="1666967590"/>
       </p:ext>
     </p:extLst>
   </p:cSld>
@@ -7342,7 +9274,7 @@
           <p:cNvPr id="2" name="Title 1">
             <a:extLst>
               <a:ext uri="{FF2B5EF4-FFF2-40B4-BE49-F238E27FC236}">
-                <a16:creationId xmlns:a16="http://schemas.microsoft.com/office/drawing/2014/main" id="{D72B11F3-AF95-B70D-0B83-93619F437DFB}"/>
+                <a16:creationId xmlns:a16="http://schemas.microsoft.com/office/drawing/2014/main" id="{85A3875A-E3A2-19F7-F16F-24C2AB831E1C}"/>
               </a:ext>
             </a:extLst>
           </p:cNvPr>
@@ -7353,24 +9285,29 @@
             <p:ph type="title"/>
           </p:nvPr>
         </p:nvSpPr>
-        <p:spPr/>
+        <p:spPr>
+          <a:xfrm>
+            <a:off x="839788" y="365125"/>
+            <a:ext cx="10515600" cy="933097"/>
+          </a:xfrm>
+        </p:spPr>
         <p:txBody>
           <a:bodyPr/>
           <a:lstStyle/>
           <a:p>
             <a:r>
-              <a:rPr lang="en-GB" dirty="0"/>
-              <a:t>Passive Damping</a:t>
+              <a:rPr lang="en-GB"/>
+              <a:t>Fixed Controls</a:t>
             </a:r>
           </a:p>
         </p:txBody>
       </p:sp>
       <p:sp>
         <p:nvSpPr>
-          <p:cNvPr id="3" name="Content Placeholder 2">
+          <p:cNvPr id="4" name="Text Placeholder 3">
             <a:extLst>
               <a:ext uri="{FF2B5EF4-FFF2-40B4-BE49-F238E27FC236}">
-                <a16:creationId xmlns:a16="http://schemas.microsoft.com/office/drawing/2014/main" id="{E4D6E862-163B-64B7-DEA0-D7B9B279B701}"/>
+                <a16:creationId xmlns:a16="http://schemas.microsoft.com/office/drawing/2014/main" id="{1DAC204E-F5D6-0C39-43C7-D92A65662698}"/>
               </a:ext>
             </a:extLst>
           </p:cNvPr>
@@ -7378,35 +9315,1395 @@
             <a:spLocks noGrp="1"/>
           </p:cNvSpPr>
           <p:nvPr>
-            <p:ph idx="1"/>
+            <p:ph type="body" idx="1"/>
           </p:nvPr>
         </p:nvSpPr>
-        <p:spPr/>
+        <p:spPr>
+          <a:xfrm>
+            <a:off x="715609" y="1292001"/>
+            <a:ext cx="3419475" cy="817959"/>
+          </a:xfrm>
+        </p:spPr>
         <p:txBody>
           <a:bodyPr/>
           <a:lstStyle/>
           <a:p>
             <a:r>
-              <a:rPr lang="en-GB" dirty="0"/>
-              <a:t>What it is?</a:t>
-            </a:r>
-          </a:p>
-          <a:p>
-            <a:r>
-              <a:rPr lang="en-GB" dirty="0"/>
-              <a:t>Analytical tuning</a:t>
-            </a:r>
-          </a:p>
-          <a:p>
-            <a:r>
-              <a:rPr lang="en-GB" dirty="0"/>
-              <a:t>Grid search tuning</a:t>
-            </a:r>
-          </a:p>
-          <a:p>
-            <a:r>
-              <a:rPr lang="en-GB" dirty="0"/>
-              <a:t>Results</a:t>
+              <a:rPr lang="en-GB"/>
+              <a:t>Coulomb</a:t>
+            </a:r>
+          </a:p>
+        </p:txBody>
+      </p:sp>
+      <mc:AlternateContent xmlns:mc="http://schemas.openxmlformats.org/markup-compatibility/2006">
+        <mc:Choice xmlns:a14="http://schemas.microsoft.com/office/drawing/2010/main" Requires="a14">
+          <p:sp>
+            <p:nvSpPr>
+              <p:cNvPr id="3" name="Content Placeholder 2">
+                <a:extLst>
+                  <a:ext uri="{FF2B5EF4-FFF2-40B4-BE49-F238E27FC236}">
+                    <a16:creationId xmlns:a16="http://schemas.microsoft.com/office/drawing/2014/main" id="{B797F24D-CDB9-F700-E7E1-F9FA956E9D86}"/>
+                  </a:ext>
+                </a:extLst>
+              </p:cNvPr>
+              <p:cNvSpPr>
+                <a:spLocks noGrp="1"/>
+              </p:cNvSpPr>
+              <p:nvPr>
+                <p:ph sz="half" idx="2"/>
+              </p:nvPr>
+            </p:nvSpPr>
+            <p:spPr>
+              <a:xfrm>
+                <a:off x="715609" y="2109960"/>
+                <a:ext cx="3437334" cy="3684588"/>
+              </a:xfrm>
+            </p:spPr>
+            <p:txBody>
+              <a:bodyPr vert="horz" lIns="91440" tIns="45720" rIns="91440" bIns="45720" rtlCol="0" anchor="t">
+                <a:normAutofit/>
+              </a:bodyPr>
+              <a:lstStyle/>
+              <a:p>
+                <a:pPr>
+                  <a:buNone/>
+                </a:pPr>
+                <a14:m>
+                  <m:oMathPara xmlns:m="http://schemas.openxmlformats.org/officeDocument/2006/math">
+                    <m:oMathParaPr>
+                      <m:jc m:val="centerGroup"/>
+                    </m:oMathParaPr>
+                    <m:oMath xmlns:m="http://schemas.openxmlformats.org/officeDocument/2006/math">
+                      <m:sSub>
+                        <m:sSubPr>
+                          <m:ctrlPr>
+                            <a:rPr lang="en-US" i="1" smtClean="0">
+                              <a:latin typeface="Cambria Math" panose="02040503050406030204" pitchFamily="18" charset="0"/>
+                            </a:rPr>
+                          </m:ctrlPr>
+                        </m:sSubPr>
+                        <m:e>
+                          <m:r>
+                            <a:rPr lang="en-US" i="1">
+                              <a:latin typeface="Cambria Math" panose="02040503050406030204" pitchFamily="18" charset="0"/>
+                            </a:rPr>
+                            <m:t>𝐹</m:t>
+                          </m:r>
+                        </m:e>
+                        <m:sub>
+                          <m:r>
+                            <a:rPr lang="en-US" i="1">
+                              <a:latin typeface="Cambria Math" panose="02040503050406030204" pitchFamily="18" charset="0"/>
+                            </a:rPr>
+                            <m:t>𝑃𝑇𝑂</m:t>
+                          </m:r>
+                        </m:sub>
+                      </m:sSub>
+                      <m:r>
+                        <a:rPr lang="en-US" i="1">
+                          <a:latin typeface="Cambria Math" panose="02040503050406030204" pitchFamily="18" charset="0"/>
+                        </a:rPr>
+                        <m:t>=</m:t>
+                      </m:r>
+                      <m:sSub>
+                        <m:sSubPr>
+                          <m:ctrlPr>
+                            <a:rPr lang="en-US" i="1">
+                              <a:latin typeface="Cambria Math" panose="02040503050406030204" pitchFamily="18" charset="0"/>
+                            </a:rPr>
+                          </m:ctrlPr>
+                        </m:sSubPr>
+                        <m:e>
+                          <m:r>
+                            <a:rPr lang="en-US" i="1">
+                              <a:latin typeface="Cambria Math" panose="02040503050406030204" pitchFamily="18" charset="0"/>
+                            </a:rPr>
+                            <m:t>𝐹</m:t>
+                          </m:r>
+                        </m:e>
+                        <m:sub>
+                          <m:r>
+                            <a:rPr lang="en-US" i="1">
+                              <a:latin typeface="Cambria Math" panose="02040503050406030204" pitchFamily="18" charset="0"/>
+                            </a:rPr>
+                            <m:t>𝐶</m:t>
+                          </m:r>
+                        </m:sub>
+                      </m:sSub>
+                      <m:r>
+                        <a:rPr lang="en-US" i="1">
+                          <a:latin typeface="Cambria Math" panose="02040503050406030204" pitchFamily="18" charset="0"/>
+                        </a:rPr>
+                        <m:t>⋅</m:t>
+                      </m:r>
+                      <m:r>
+                        <m:rPr>
+                          <m:nor/>
+                        </m:rPr>
+                        <a:rPr lang="en-US" i="0">
+                          <a:latin typeface="Cambria Math" panose="02040503050406030204" pitchFamily="18" charset="0"/>
+                        </a:rPr>
+                        <m:t>sign</m:t>
+                      </m:r>
+                      <m:d>
+                        <m:dPr>
+                          <m:ctrlPr>
+                            <a:rPr lang="en-US" i="1">
+                              <a:latin typeface="Cambria Math" panose="02040503050406030204" pitchFamily="18" charset="0"/>
+                            </a:rPr>
+                          </m:ctrlPr>
+                        </m:dPr>
+                        <m:e>
+                          <m:acc>
+                            <m:accPr>
+                              <m:chr m:val="̇"/>
+                              <m:ctrlPr>
+                                <a:rPr lang="en-US" i="1">
+                                  <a:latin typeface="Cambria Math" panose="02040503050406030204" pitchFamily="18" charset="0"/>
+                                </a:rPr>
+                              </m:ctrlPr>
+                            </m:accPr>
+                            <m:e>
+                              <m:r>
+                                <a:rPr lang="en-US" i="1">
+                                  <a:latin typeface="Cambria Math" panose="02040503050406030204" pitchFamily="18" charset="0"/>
+                                </a:rPr>
+                                <m:t>𝑦</m:t>
+                              </m:r>
+                            </m:e>
+                          </m:acc>
+                        </m:e>
+                      </m:d>
+                    </m:oMath>
+                  </m:oMathPara>
+                </a14:m>
+                <a:endParaRPr lang="en-US"/>
+              </a:p>
+              <a:p>
+                <a:r>
+                  <a:rPr lang="en-US" sz="2000"/>
+                  <a:t>Absorbs kinetic energy with sliding friction</a:t>
+                </a:r>
+              </a:p>
+              <a:p>
+                <a:r>
+                  <a:rPr lang="en-US" sz="2000"/>
+                  <a:t>Force magnitude is constant. Only direction switches with velocity.</a:t>
+                </a:r>
+              </a:p>
+            </p:txBody>
+          </p:sp>
+        </mc:Choice>
+        <mc:Fallback>
+          <p:sp>
+            <p:nvSpPr>
+              <p:cNvPr id="3" name="Content Placeholder 2">
+                <a:extLst>
+                  <a:ext uri="{FF2B5EF4-FFF2-40B4-BE49-F238E27FC236}">
+                    <a16:creationId xmlns:a16="http://schemas.microsoft.com/office/drawing/2014/main" id="{B797F24D-CDB9-F700-E7E1-F9FA956E9D86}"/>
+                  </a:ext>
+                </a:extLst>
+              </p:cNvPr>
+              <p:cNvSpPr>
+                <a:spLocks noGrp="1" noRot="1" noChangeAspect="1" noMove="1" noResize="1" noEditPoints="1" noAdjustHandles="1" noChangeArrowheads="1" noChangeShapeType="1" noTextEdit="1"/>
+              </p:cNvSpPr>
+              <p:nvPr>
+                <p:ph sz="half" idx="2"/>
+              </p:nvPr>
+            </p:nvSpPr>
+            <p:spPr>
+              <a:xfrm>
+                <a:off x="715609" y="2109960"/>
+                <a:ext cx="3437334" cy="3684588"/>
+              </a:xfrm>
+              <a:blipFill>
+                <a:blip r:embed="rId3"/>
+                <a:stretch>
+                  <a:fillRect l="-1596" t="-165" r="-1950"/>
+                </a:stretch>
+              </a:blipFill>
+            </p:spPr>
+            <p:txBody>
+              <a:bodyPr/>
+              <a:lstStyle/>
+              <a:p>
+                <a:r>
+                  <a:rPr lang="en-US">
+                    <a:noFill/>
+                  </a:rPr>
+                  <a:t> </a:t>
+                </a:r>
+              </a:p>
+            </p:txBody>
+          </p:sp>
+        </mc:Fallback>
+      </mc:AlternateContent>
+      <p:sp>
+        <p:nvSpPr>
+          <p:cNvPr id="8" name="Text Placeholder 3">
+            <a:extLst>
+              <a:ext uri="{FF2B5EF4-FFF2-40B4-BE49-F238E27FC236}">
+                <a16:creationId xmlns:a16="http://schemas.microsoft.com/office/drawing/2014/main" id="{58985922-472D-B16A-7835-A1E728AFC3E8}"/>
+              </a:ext>
+            </a:extLst>
+          </p:cNvPr>
+          <p:cNvSpPr txBox="1">
+            <a:spLocks/>
+          </p:cNvSpPr>
+          <p:nvPr/>
+        </p:nvSpPr>
+        <p:spPr>
+          <a:xfrm>
+            <a:off x="4261290" y="1289620"/>
+            <a:ext cx="3419475" cy="817959"/>
+          </a:xfrm>
+          <a:prstGeom prst="rect">
+            <a:avLst/>
+          </a:prstGeom>
+        </p:spPr>
+        <p:txBody>
+          <a:bodyPr vert="horz" lIns="91440" tIns="45720" rIns="91440" bIns="45720" rtlCol="0" anchor="b">
+            <a:normAutofit/>
+          </a:bodyPr>
+          <a:lstStyle>
+            <a:lvl1pPr marL="0" indent="0" algn="l" defTabSz="914400" rtl="0" eaLnBrk="1" latinLnBrk="0" hangingPunct="1">
+              <a:lnSpc>
+                <a:spcPct val="90000"/>
+              </a:lnSpc>
+              <a:spcBef>
+                <a:spcPts val="1000"/>
+              </a:spcBef>
+              <a:buFont typeface="Arial" panose="020B0604020202020204" pitchFamily="34" charset="0"/>
+              <a:buNone/>
+              <a:defRPr sz="2400" b="1" kern="1200">
+                <a:solidFill>
+                  <a:schemeClr val="tx1"/>
+                </a:solidFill>
+                <a:latin typeface="+mn-lt"/>
+                <a:ea typeface="+mn-ea"/>
+                <a:cs typeface="+mn-cs"/>
+              </a:defRPr>
+            </a:lvl1pPr>
+            <a:lvl2pPr marL="457200" indent="0" algn="l" defTabSz="914400" rtl="0" eaLnBrk="1" latinLnBrk="0" hangingPunct="1">
+              <a:lnSpc>
+                <a:spcPct val="90000"/>
+              </a:lnSpc>
+              <a:spcBef>
+                <a:spcPts val="500"/>
+              </a:spcBef>
+              <a:buFont typeface="Arial" panose="020B0604020202020204" pitchFamily="34" charset="0"/>
+              <a:buNone/>
+              <a:defRPr sz="2000" b="1" kern="1200">
+                <a:solidFill>
+                  <a:schemeClr val="tx1"/>
+                </a:solidFill>
+                <a:latin typeface="+mn-lt"/>
+                <a:ea typeface="+mn-ea"/>
+                <a:cs typeface="+mn-cs"/>
+              </a:defRPr>
+            </a:lvl2pPr>
+            <a:lvl3pPr marL="914400" indent="0" algn="l" defTabSz="914400" rtl="0" eaLnBrk="1" latinLnBrk="0" hangingPunct="1">
+              <a:lnSpc>
+                <a:spcPct val="90000"/>
+              </a:lnSpc>
+              <a:spcBef>
+                <a:spcPts val="500"/>
+              </a:spcBef>
+              <a:buFont typeface="Arial" panose="020B0604020202020204" pitchFamily="34" charset="0"/>
+              <a:buNone/>
+              <a:defRPr sz="1800" b="1" kern="1200">
+                <a:solidFill>
+                  <a:schemeClr val="tx1"/>
+                </a:solidFill>
+                <a:latin typeface="+mn-lt"/>
+                <a:ea typeface="+mn-ea"/>
+                <a:cs typeface="+mn-cs"/>
+              </a:defRPr>
+            </a:lvl3pPr>
+            <a:lvl4pPr marL="1371600" indent="0" algn="l" defTabSz="914400" rtl="0" eaLnBrk="1" latinLnBrk="0" hangingPunct="1">
+              <a:lnSpc>
+                <a:spcPct val="90000"/>
+              </a:lnSpc>
+              <a:spcBef>
+                <a:spcPts val="500"/>
+              </a:spcBef>
+              <a:buFont typeface="Arial" panose="020B0604020202020204" pitchFamily="34" charset="0"/>
+              <a:buNone/>
+              <a:defRPr sz="1600" b="1" kern="1200">
+                <a:solidFill>
+                  <a:schemeClr val="tx1"/>
+                </a:solidFill>
+                <a:latin typeface="+mn-lt"/>
+                <a:ea typeface="+mn-ea"/>
+                <a:cs typeface="+mn-cs"/>
+              </a:defRPr>
+            </a:lvl4pPr>
+            <a:lvl5pPr marL="1828800" indent="0" algn="l" defTabSz="914400" rtl="0" eaLnBrk="1" latinLnBrk="0" hangingPunct="1">
+              <a:lnSpc>
+                <a:spcPct val="90000"/>
+              </a:lnSpc>
+              <a:spcBef>
+                <a:spcPts val="500"/>
+              </a:spcBef>
+              <a:buFont typeface="Arial" panose="020B0604020202020204" pitchFamily="34" charset="0"/>
+              <a:buNone/>
+              <a:defRPr sz="1600" b="1" kern="1200">
+                <a:solidFill>
+                  <a:schemeClr val="tx1"/>
+                </a:solidFill>
+                <a:latin typeface="+mn-lt"/>
+                <a:ea typeface="+mn-ea"/>
+                <a:cs typeface="+mn-cs"/>
+              </a:defRPr>
+            </a:lvl5pPr>
+            <a:lvl6pPr marL="2286000" indent="0" algn="l" defTabSz="914400" rtl="0" eaLnBrk="1" latinLnBrk="0" hangingPunct="1">
+              <a:lnSpc>
+                <a:spcPct val="90000"/>
+              </a:lnSpc>
+              <a:spcBef>
+                <a:spcPts val="500"/>
+              </a:spcBef>
+              <a:buFont typeface="Arial" panose="020B0604020202020204" pitchFamily="34" charset="0"/>
+              <a:buNone/>
+              <a:defRPr sz="1600" b="1" kern="1200">
+                <a:solidFill>
+                  <a:schemeClr val="tx1"/>
+                </a:solidFill>
+                <a:latin typeface="+mn-lt"/>
+                <a:ea typeface="+mn-ea"/>
+                <a:cs typeface="+mn-cs"/>
+              </a:defRPr>
+            </a:lvl6pPr>
+            <a:lvl7pPr marL="2743200" indent="0" algn="l" defTabSz="914400" rtl="0" eaLnBrk="1" latinLnBrk="0" hangingPunct="1">
+              <a:lnSpc>
+                <a:spcPct val="90000"/>
+              </a:lnSpc>
+              <a:spcBef>
+                <a:spcPts val="500"/>
+              </a:spcBef>
+              <a:buFont typeface="Arial" panose="020B0604020202020204" pitchFamily="34" charset="0"/>
+              <a:buNone/>
+              <a:defRPr sz="1600" b="1" kern="1200">
+                <a:solidFill>
+                  <a:schemeClr val="tx1"/>
+                </a:solidFill>
+                <a:latin typeface="+mn-lt"/>
+                <a:ea typeface="+mn-ea"/>
+                <a:cs typeface="+mn-cs"/>
+              </a:defRPr>
+            </a:lvl7pPr>
+            <a:lvl8pPr marL="3200400" indent="0" algn="l" defTabSz="914400" rtl="0" eaLnBrk="1" latinLnBrk="0" hangingPunct="1">
+              <a:lnSpc>
+                <a:spcPct val="90000"/>
+              </a:lnSpc>
+              <a:spcBef>
+                <a:spcPts val="500"/>
+              </a:spcBef>
+              <a:buFont typeface="Arial" panose="020B0604020202020204" pitchFamily="34" charset="0"/>
+              <a:buNone/>
+              <a:defRPr sz="1600" b="1" kern="1200">
+                <a:solidFill>
+                  <a:schemeClr val="tx1"/>
+                </a:solidFill>
+                <a:latin typeface="+mn-lt"/>
+                <a:ea typeface="+mn-ea"/>
+                <a:cs typeface="+mn-cs"/>
+              </a:defRPr>
+            </a:lvl8pPr>
+            <a:lvl9pPr marL="3657600" indent="0" algn="l" defTabSz="914400" rtl="0" eaLnBrk="1" latinLnBrk="0" hangingPunct="1">
+              <a:lnSpc>
+                <a:spcPct val="90000"/>
+              </a:lnSpc>
+              <a:spcBef>
+                <a:spcPts val="500"/>
+              </a:spcBef>
+              <a:buFont typeface="Arial" panose="020B0604020202020204" pitchFamily="34" charset="0"/>
+              <a:buNone/>
+              <a:defRPr sz="1600" b="1" kern="1200">
+                <a:solidFill>
+                  <a:schemeClr val="tx1"/>
+                </a:solidFill>
+                <a:latin typeface="+mn-lt"/>
+                <a:ea typeface="+mn-ea"/>
+                <a:cs typeface="+mn-cs"/>
+              </a:defRPr>
+            </a:lvl9pPr>
+          </a:lstStyle>
+          <a:p>
+            <a:r>
+              <a:rPr lang="en-GB"/>
+              <a:t>Displacement</a:t>
+            </a:r>
+          </a:p>
+        </p:txBody>
+      </p:sp>
+      <mc:AlternateContent xmlns:mc="http://schemas.openxmlformats.org/markup-compatibility/2006">
+        <mc:Choice xmlns:a14="http://schemas.microsoft.com/office/drawing/2010/main" Requires="a14">
+          <p:sp>
+            <p:nvSpPr>
+              <p:cNvPr id="10" name="Content Placeholder 2">
+                <a:extLst>
+                  <a:ext uri="{FF2B5EF4-FFF2-40B4-BE49-F238E27FC236}">
+                    <a16:creationId xmlns:a16="http://schemas.microsoft.com/office/drawing/2014/main" id="{A306D060-8843-8859-9D15-CA50FFDA67DE}"/>
+                  </a:ext>
+                </a:extLst>
+              </p:cNvPr>
+              <p:cNvSpPr txBox="1">
+                <a:spLocks/>
+              </p:cNvSpPr>
+              <p:nvPr/>
+            </p:nvSpPr>
+            <p:spPr>
+              <a:xfrm>
+                <a:off x="4261290" y="2107579"/>
+                <a:ext cx="3437334" cy="3684588"/>
+              </a:xfrm>
+              <a:prstGeom prst="rect">
+                <a:avLst/>
+              </a:prstGeom>
+            </p:spPr>
+            <p:txBody>
+              <a:bodyPr vert="horz" lIns="91440" tIns="45720" rIns="91440" bIns="45720" rtlCol="0" anchor="t">
+                <a:normAutofit/>
+              </a:bodyPr>
+              <a:lstStyle>
+                <a:lvl1pPr marL="228600" indent="-228600" algn="l" defTabSz="914400" rtl="0" eaLnBrk="1" latinLnBrk="0" hangingPunct="1">
+                  <a:lnSpc>
+                    <a:spcPct val="90000"/>
+                  </a:lnSpc>
+                  <a:spcBef>
+                    <a:spcPts val="1000"/>
+                  </a:spcBef>
+                  <a:buFont typeface="Arial" panose="020B0604020202020204" pitchFamily="34" charset="0"/>
+                  <a:buChar char="•"/>
+                  <a:defRPr sz="2800" kern="1200">
+                    <a:solidFill>
+                      <a:schemeClr val="tx1"/>
+                    </a:solidFill>
+                    <a:latin typeface="+mn-lt"/>
+                    <a:ea typeface="+mn-ea"/>
+                    <a:cs typeface="+mn-cs"/>
+                  </a:defRPr>
+                </a:lvl1pPr>
+                <a:lvl2pPr marL="685800" indent="-228600" algn="l" defTabSz="914400" rtl="0" eaLnBrk="1" latinLnBrk="0" hangingPunct="1">
+                  <a:lnSpc>
+                    <a:spcPct val="90000"/>
+                  </a:lnSpc>
+                  <a:spcBef>
+                    <a:spcPts val="500"/>
+                  </a:spcBef>
+                  <a:buFont typeface="Arial" panose="020B0604020202020204" pitchFamily="34" charset="0"/>
+                  <a:buChar char="•"/>
+                  <a:defRPr sz="2400" kern="1200">
+                    <a:solidFill>
+                      <a:schemeClr val="tx1"/>
+                    </a:solidFill>
+                    <a:latin typeface="+mn-lt"/>
+                    <a:ea typeface="+mn-ea"/>
+                    <a:cs typeface="+mn-cs"/>
+                  </a:defRPr>
+                </a:lvl2pPr>
+                <a:lvl3pPr marL="1143000" indent="-228600" algn="l" defTabSz="914400" rtl="0" eaLnBrk="1" latinLnBrk="0" hangingPunct="1">
+                  <a:lnSpc>
+                    <a:spcPct val="90000"/>
+                  </a:lnSpc>
+                  <a:spcBef>
+                    <a:spcPts val="500"/>
+                  </a:spcBef>
+                  <a:buFont typeface="Arial" panose="020B0604020202020204" pitchFamily="34" charset="0"/>
+                  <a:buChar char="•"/>
+                  <a:defRPr sz="2000" kern="1200">
+                    <a:solidFill>
+                      <a:schemeClr val="tx1"/>
+                    </a:solidFill>
+                    <a:latin typeface="+mn-lt"/>
+                    <a:ea typeface="+mn-ea"/>
+                    <a:cs typeface="+mn-cs"/>
+                  </a:defRPr>
+                </a:lvl3pPr>
+                <a:lvl4pPr marL="1600200" indent="-228600" algn="l" defTabSz="914400" rtl="0" eaLnBrk="1" latinLnBrk="0" hangingPunct="1">
+                  <a:lnSpc>
+                    <a:spcPct val="90000"/>
+                  </a:lnSpc>
+                  <a:spcBef>
+                    <a:spcPts val="500"/>
+                  </a:spcBef>
+                  <a:buFont typeface="Arial" panose="020B0604020202020204" pitchFamily="34" charset="0"/>
+                  <a:buChar char="•"/>
+                  <a:defRPr sz="1800" kern="1200">
+                    <a:solidFill>
+                      <a:schemeClr val="tx1"/>
+                    </a:solidFill>
+                    <a:latin typeface="+mn-lt"/>
+                    <a:ea typeface="+mn-ea"/>
+                    <a:cs typeface="+mn-cs"/>
+                  </a:defRPr>
+                </a:lvl4pPr>
+                <a:lvl5pPr marL="2057400" indent="-228600" algn="l" defTabSz="914400" rtl="0" eaLnBrk="1" latinLnBrk="0" hangingPunct="1">
+                  <a:lnSpc>
+                    <a:spcPct val="90000"/>
+                  </a:lnSpc>
+                  <a:spcBef>
+                    <a:spcPts val="500"/>
+                  </a:spcBef>
+                  <a:buFont typeface="Arial" panose="020B0604020202020204" pitchFamily="34" charset="0"/>
+                  <a:buChar char="•"/>
+                  <a:defRPr sz="1800" kern="1200">
+                    <a:solidFill>
+                      <a:schemeClr val="tx1"/>
+                    </a:solidFill>
+                    <a:latin typeface="+mn-lt"/>
+                    <a:ea typeface="+mn-ea"/>
+                    <a:cs typeface="+mn-cs"/>
+                  </a:defRPr>
+                </a:lvl5pPr>
+                <a:lvl6pPr marL="2514600" indent="-228600" algn="l" defTabSz="914400" rtl="0" eaLnBrk="1" latinLnBrk="0" hangingPunct="1">
+                  <a:lnSpc>
+                    <a:spcPct val="90000"/>
+                  </a:lnSpc>
+                  <a:spcBef>
+                    <a:spcPts val="500"/>
+                  </a:spcBef>
+                  <a:buFont typeface="Arial" panose="020B0604020202020204" pitchFamily="34" charset="0"/>
+                  <a:buChar char="•"/>
+                  <a:defRPr sz="1800" kern="1200">
+                    <a:solidFill>
+                      <a:schemeClr val="tx1"/>
+                    </a:solidFill>
+                    <a:latin typeface="+mn-lt"/>
+                    <a:ea typeface="+mn-ea"/>
+                    <a:cs typeface="+mn-cs"/>
+                  </a:defRPr>
+                </a:lvl6pPr>
+                <a:lvl7pPr marL="2971800" indent="-228600" algn="l" defTabSz="914400" rtl="0" eaLnBrk="1" latinLnBrk="0" hangingPunct="1">
+                  <a:lnSpc>
+                    <a:spcPct val="90000"/>
+                  </a:lnSpc>
+                  <a:spcBef>
+                    <a:spcPts val="500"/>
+                  </a:spcBef>
+                  <a:buFont typeface="Arial" panose="020B0604020202020204" pitchFamily="34" charset="0"/>
+                  <a:buChar char="•"/>
+                  <a:defRPr sz="1800" kern="1200">
+                    <a:solidFill>
+                      <a:schemeClr val="tx1"/>
+                    </a:solidFill>
+                    <a:latin typeface="+mn-lt"/>
+                    <a:ea typeface="+mn-ea"/>
+                    <a:cs typeface="+mn-cs"/>
+                  </a:defRPr>
+                </a:lvl7pPr>
+                <a:lvl8pPr marL="3429000" indent="-228600" algn="l" defTabSz="914400" rtl="0" eaLnBrk="1" latinLnBrk="0" hangingPunct="1">
+                  <a:lnSpc>
+                    <a:spcPct val="90000"/>
+                  </a:lnSpc>
+                  <a:spcBef>
+                    <a:spcPts val="500"/>
+                  </a:spcBef>
+                  <a:buFont typeface="Arial" panose="020B0604020202020204" pitchFamily="34" charset="0"/>
+                  <a:buChar char="•"/>
+                  <a:defRPr sz="1800" kern="1200">
+                    <a:solidFill>
+                      <a:schemeClr val="tx1"/>
+                    </a:solidFill>
+                    <a:latin typeface="+mn-lt"/>
+                    <a:ea typeface="+mn-ea"/>
+                    <a:cs typeface="+mn-cs"/>
+                  </a:defRPr>
+                </a:lvl8pPr>
+                <a:lvl9pPr marL="3886200" indent="-228600" algn="l" defTabSz="914400" rtl="0" eaLnBrk="1" latinLnBrk="0" hangingPunct="1">
+                  <a:lnSpc>
+                    <a:spcPct val="90000"/>
+                  </a:lnSpc>
+                  <a:spcBef>
+                    <a:spcPts val="500"/>
+                  </a:spcBef>
+                  <a:buFont typeface="Arial" panose="020B0604020202020204" pitchFamily="34" charset="0"/>
+                  <a:buChar char="•"/>
+                  <a:defRPr sz="1800" kern="1200">
+                    <a:solidFill>
+                      <a:schemeClr val="tx1"/>
+                    </a:solidFill>
+                    <a:latin typeface="+mn-lt"/>
+                    <a:ea typeface="+mn-ea"/>
+                    <a:cs typeface="+mn-cs"/>
+                  </a:defRPr>
+                </a:lvl9pPr>
+              </a:lstStyle>
+              <a:p>
+                <a:pPr marL="0" indent="0">
+                  <a:buNone/>
+                </a:pPr>
+                <a14:m>
+                  <m:oMathPara xmlns:m="http://schemas.openxmlformats.org/officeDocument/2006/math">
+                    <m:oMathParaPr>
+                      <m:jc m:val="centerGroup"/>
+                    </m:oMathParaPr>
+                    <m:oMath xmlns:m="http://schemas.openxmlformats.org/officeDocument/2006/math">
+                      <m:sSub>
+                        <m:sSubPr>
+                          <m:ctrlPr>
+                            <a:rPr lang="en-GB" i="1" smtClean="0">
+                              <a:latin typeface="Cambria Math" panose="02040503050406030204" pitchFamily="18" charset="0"/>
+                            </a:rPr>
+                          </m:ctrlPr>
+                        </m:sSubPr>
+                        <m:e>
+                          <m:r>
+                            <a:rPr lang="en-GB" i="1">
+                              <a:latin typeface="Cambria Math" panose="02040503050406030204" pitchFamily="18" charset="0"/>
+                            </a:rPr>
+                            <m:t>𝐹</m:t>
+                          </m:r>
+                        </m:e>
+                        <m:sub>
+                          <m:r>
+                            <a:rPr lang="en-GB" i="1">
+                              <a:latin typeface="Cambria Math" panose="02040503050406030204" pitchFamily="18" charset="0"/>
+                            </a:rPr>
+                            <m:t>𝑃𝑇𝑂</m:t>
+                          </m:r>
+                        </m:sub>
+                      </m:sSub>
+                      <m:r>
+                        <a:rPr lang="en-GB" i="1">
+                          <a:latin typeface="Cambria Math" panose="02040503050406030204" pitchFamily="18" charset="0"/>
+                        </a:rPr>
+                        <m:t>=</m:t>
+                      </m:r>
+                      <m:sSub>
+                        <m:sSubPr>
+                          <m:ctrlPr>
+                            <a:rPr lang="en-GB" i="1">
+                              <a:latin typeface="Cambria Math" panose="02040503050406030204" pitchFamily="18" charset="0"/>
+                            </a:rPr>
+                          </m:ctrlPr>
+                        </m:sSubPr>
+                        <m:e>
+                          <m:r>
+                            <a:rPr lang="en-GB" i="1">
+                              <a:latin typeface="Cambria Math" panose="02040503050406030204" pitchFamily="18" charset="0"/>
+                            </a:rPr>
+                            <m:t>𝑏</m:t>
+                          </m:r>
+                        </m:e>
+                        <m:sub>
+                          <m:r>
+                            <a:rPr lang="en-GB" i="1">
+                              <a:latin typeface="Cambria Math" panose="02040503050406030204" pitchFamily="18" charset="0"/>
+                            </a:rPr>
+                            <m:t>𝑃𝑇𝑂</m:t>
+                          </m:r>
+                        </m:sub>
+                      </m:sSub>
+                      <m:r>
+                        <a:rPr lang="en-GB" i="1">
+                          <a:latin typeface="Cambria Math" panose="02040503050406030204" pitchFamily="18" charset="0"/>
+                        </a:rPr>
+                        <m:t>·</m:t>
+                      </m:r>
+                      <m:r>
+                        <a:rPr lang="en-GB" i="1">
+                          <a:latin typeface="Cambria Math" panose="02040503050406030204" pitchFamily="18" charset="0"/>
+                        </a:rPr>
+                        <m:t>𝑀</m:t>
+                      </m:r>
+                      <m:r>
+                        <a:rPr lang="el-GR" i="1">
+                          <a:latin typeface="Cambria Math" panose="02040503050406030204" pitchFamily="18" charset="0"/>
+                        </a:rPr>
+                        <m:t>𝜔</m:t>
+                      </m:r>
+                      <m:r>
+                        <a:rPr lang="el-GR" i="1">
+                          <a:latin typeface="Cambria Math" panose="02040503050406030204" pitchFamily="18" charset="0"/>
+                        </a:rPr>
+                        <m:t>·</m:t>
+                      </m:r>
+                      <m:acc>
+                        <m:accPr>
+                          <m:chr m:val="̇"/>
+                          <m:ctrlPr>
+                            <a:rPr lang="el-GR" i="1">
+                              <a:latin typeface="Cambria Math" panose="02040503050406030204" pitchFamily="18" charset="0"/>
+                            </a:rPr>
+                          </m:ctrlPr>
+                        </m:accPr>
+                        <m:e>
+                          <m:r>
+                            <a:rPr lang="en-GB" i="1">
+                              <a:latin typeface="Cambria Math" panose="02040503050406030204" pitchFamily="18" charset="0"/>
+                            </a:rPr>
+                            <m:t>𝑦</m:t>
+                          </m:r>
+                        </m:e>
+                      </m:acc>
+                    </m:oMath>
+                  </m:oMathPara>
+                </a14:m>
+                <a:endParaRPr lang="en-GB"/>
+              </a:p>
+              <a:p>
+                <a:r>
+                  <a:rPr lang="en-GB" sz="2000"/>
+                  <a:t>PTO force is proportional to the displacement of the buoy</a:t>
+                </a:r>
+              </a:p>
+            </p:txBody>
+          </p:sp>
+        </mc:Choice>
+        <mc:Fallback>
+          <p:sp>
+            <p:nvSpPr>
+              <p:cNvPr id="10" name="Content Placeholder 2">
+                <a:extLst>
+                  <a:ext uri="{FF2B5EF4-FFF2-40B4-BE49-F238E27FC236}">
+                    <a16:creationId xmlns:a16="http://schemas.microsoft.com/office/drawing/2014/main" id="{A306D060-8843-8859-9D15-CA50FFDA67DE}"/>
+                  </a:ext>
+                </a:extLst>
+              </p:cNvPr>
+              <p:cNvSpPr txBox="1">
+                <a:spLocks noRot="1" noChangeAspect="1" noMove="1" noResize="1" noEditPoints="1" noAdjustHandles="1" noChangeArrowheads="1" noChangeShapeType="1" noTextEdit="1"/>
+              </p:cNvSpPr>
+              <p:nvPr/>
+            </p:nvSpPr>
+            <p:spPr>
+              <a:xfrm>
+                <a:off x="4261290" y="2107579"/>
+                <a:ext cx="3437334" cy="3684588"/>
+              </a:xfrm>
+              <a:prstGeom prst="rect">
+                <a:avLst/>
+              </a:prstGeom>
+              <a:blipFill>
+                <a:blip r:embed="rId4"/>
+                <a:stretch>
+                  <a:fillRect l="-1596" t="-166" r="-1773"/>
+                </a:stretch>
+              </a:blipFill>
+            </p:spPr>
+            <p:txBody>
+              <a:bodyPr/>
+              <a:lstStyle/>
+              <a:p>
+                <a:r>
+                  <a:rPr lang="en-US">
+                    <a:noFill/>
+                  </a:rPr>
+                  <a:t> </a:t>
+                </a:r>
+              </a:p>
+            </p:txBody>
+          </p:sp>
+        </mc:Fallback>
+      </mc:AlternateContent>
+      <mc:AlternateContent xmlns:mc="http://schemas.openxmlformats.org/markup-compatibility/2006">
+        <mc:Choice xmlns:a14="http://schemas.microsoft.com/office/drawing/2010/main" Requires="a14">
+          <p:sp>
+            <p:nvSpPr>
+              <p:cNvPr id="14" name="Content Placeholder 2">
+                <a:extLst>
+                  <a:ext uri="{FF2B5EF4-FFF2-40B4-BE49-F238E27FC236}">
+                    <a16:creationId xmlns:a16="http://schemas.microsoft.com/office/drawing/2014/main" id="{937B966B-77AE-B788-C527-146DBD98B8AC}"/>
+                  </a:ext>
+                </a:extLst>
+              </p:cNvPr>
+              <p:cNvSpPr txBox="1">
+                <a:spLocks/>
+              </p:cNvSpPr>
+              <p:nvPr/>
+            </p:nvSpPr>
+            <p:spPr>
+              <a:xfrm>
+                <a:off x="7898650" y="2212617"/>
+                <a:ext cx="3437334" cy="3579549"/>
+              </a:xfrm>
+              <a:prstGeom prst="rect">
+                <a:avLst/>
+              </a:prstGeom>
+            </p:spPr>
+            <p:txBody>
+              <a:bodyPr vert="horz" lIns="91440" tIns="45720" rIns="91440" bIns="45720" rtlCol="0" anchor="t">
+                <a:normAutofit/>
+              </a:bodyPr>
+              <a:lstStyle>
+                <a:lvl1pPr marL="228600" indent="-228600" algn="l" defTabSz="914400" rtl="0" eaLnBrk="1" latinLnBrk="0" hangingPunct="1">
+                  <a:lnSpc>
+                    <a:spcPct val="90000"/>
+                  </a:lnSpc>
+                  <a:spcBef>
+                    <a:spcPts val="1000"/>
+                  </a:spcBef>
+                  <a:buFont typeface="Arial" panose="020B0604020202020204" pitchFamily="34" charset="0"/>
+                  <a:buChar char="•"/>
+                  <a:defRPr sz="2800" kern="1200">
+                    <a:solidFill>
+                      <a:schemeClr val="tx1"/>
+                    </a:solidFill>
+                    <a:latin typeface="+mn-lt"/>
+                    <a:ea typeface="+mn-ea"/>
+                    <a:cs typeface="+mn-cs"/>
+                  </a:defRPr>
+                </a:lvl1pPr>
+                <a:lvl2pPr marL="685800" indent="-228600" algn="l" defTabSz="914400" rtl="0" eaLnBrk="1" latinLnBrk="0" hangingPunct="1">
+                  <a:lnSpc>
+                    <a:spcPct val="90000"/>
+                  </a:lnSpc>
+                  <a:spcBef>
+                    <a:spcPts val="500"/>
+                  </a:spcBef>
+                  <a:buFont typeface="Arial" panose="020B0604020202020204" pitchFamily="34" charset="0"/>
+                  <a:buChar char="•"/>
+                  <a:defRPr sz="2400" kern="1200">
+                    <a:solidFill>
+                      <a:schemeClr val="tx1"/>
+                    </a:solidFill>
+                    <a:latin typeface="+mn-lt"/>
+                    <a:ea typeface="+mn-ea"/>
+                    <a:cs typeface="+mn-cs"/>
+                  </a:defRPr>
+                </a:lvl2pPr>
+                <a:lvl3pPr marL="1143000" indent="-228600" algn="l" defTabSz="914400" rtl="0" eaLnBrk="1" latinLnBrk="0" hangingPunct="1">
+                  <a:lnSpc>
+                    <a:spcPct val="90000"/>
+                  </a:lnSpc>
+                  <a:spcBef>
+                    <a:spcPts val="500"/>
+                  </a:spcBef>
+                  <a:buFont typeface="Arial" panose="020B0604020202020204" pitchFamily="34" charset="0"/>
+                  <a:buChar char="•"/>
+                  <a:defRPr sz="2000" kern="1200">
+                    <a:solidFill>
+                      <a:schemeClr val="tx1"/>
+                    </a:solidFill>
+                    <a:latin typeface="+mn-lt"/>
+                    <a:ea typeface="+mn-ea"/>
+                    <a:cs typeface="+mn-cs"/>
+                  </a:defRPr>
+                </a:lvl3pPr>
+                <a:lvl4pPr marL="1600200" indent="-228600" algn="l" defTabSz="914400" rtl="0" eaLnBrk="1" latinLnBrk="0" hangingPunct="1">
+                  <a:lnSpc>
+                    <a:spcPct val="90000"/>
+                  </a:lnSpc>
+                  <a:spcBef>
+                    <a:spcPts val="500"/>
+                  </a:spcBef>
+                  <a:buFont typeface="Arial" panose="020B0604020202020204" pitchFamily="34" charset="0"/>
+                  <a:buChar char="•"/>
+                  <a:defRPr sz="1800" kern="1200">
+                    <a:solidFill>
+                      <a:schemeClr val="tx1"/>
+                    </a:solidFill>
+                    <a:latin typeface="+mn-lt"/>
+                    <a:ea typeface="+mn-ea"/>
+                    <a:cs typeface="+mn-cs"/>
+                  </a:defRPr>
+                </a:lvl4pPr>
+                <a:lvl5pPr marL="2057400" indent="-228600" algn="l" defTabSz="914400" rtl="0" eaLnBrk="1" latinLnBrk="0" hangingPunct="1">
+                  <a:lnSpc>
+                    <a:spcPct val="90000"/>
+                  </a:lnSpc>
+                  <a:spcBef>
+                    <a:spcPts val="500"/>
+                  </a:spcBef>
+                  <a:buFont typeface="Arial" panose="020B0604020202020204" pitchFamily="34" charset="0"/>
+                  <a:buChar char="•"/>
+                  <a:defRPr sz="1800" kern="1200">
+                    <a:solidFill>
+                      <a:schemeClr val="tx1"/>
+                    </a:solidFill>
+                    <a:latin typeface="+mn-lt"/>
+                    <a:ea typeface="+mn-ea"/>
+                    <a:cs typeface="+mn-cs"/>
+                  </a:defRPr>
+                </a:lvl5pPr>
+                <a:lvl6pPr marL="2514600" indent="-228600" algn="l" defTabSz="914400" rtl="0" eaLnBrk="1" latinLnBrk="0" hangingPunct="1">
+                  <a:lnSpc>
+                    <a:spcPct val="90000"/>
+                  </a:lnSpc>
+                  <a:spcBef>
+                    <a:spcPts val="500"/>
+                  </a:spcBef>
+                  <a:buFont typeface="Arial" panose="020B0604020202020204" pitchFamily="34" charset="0"/>
+                  <a:buChar char="•"/>
+                  <a:defRPr sz="1800" kern="1200">
+                    <a:solidFill>
+                      <a:schemeClr val="tx1"/>
+                    </a:solidFill>
+                    <a:latin typeface="+mn-lt"/>
+                    <a:ea typeface="+mn-ea"/>
+                    <a:cs typeface="+mn-cs"/>
+                  </a:defRPr>
+                </a:lvl6pPr>
+                <a:lvl7pPr marL="2971800" indent="-228600" algn="l" defTabSz="914400" rtl="0" eaLnBrk="1" latinLnBrk="0" hangingPunct="1">
+                  <a:lnSpc>
+                    <a:spcPct val="90000"/>
+                  </a:lnSpc>
+                  <a:spcBef>
+                    <a:spcPts val="500"/>
+                  </a:spcBef>
+                  <a:buFont typeface="Arial" panose="020B0604020202020204" pitchFamily="34" charset="0"/>
+                  <a:buChar char="•"/>
+                  <a:defRPr sz="1800" kern="1200">
+                    <a:solidFill>
+                      <a:schemeClr val="tx1"/>
+                    </a:solidFill>
+                    <a:latin typeface="+mn-lt"/>
+                    <a:ea typeface="+mn-ea"/>
+                    <a:cs typeface="+mn-cs"/>
+                  </a:defRPr>
+                </a:lvl7pPr>
+                <a:lvl8pPr marL="3429000" indent="-228600" algn="l" defTabSz="914400" rtl="0" eaLnBrk="1" latinLnBrk="0" hangingPunct="1">
+                  <a:lnSpc>
+                    <a:spcPct val="90000"/>
+                  </a:lnSpc>
+                  <a:spcBef>
+                    <a:spcPts val="500"/>
+                  </a:spcBef>
+                  <a:buFont typeface="Arial" panose="020B0604020202020204" pitchFamily="34" charset="0"/>
+                  <a:buChar char="•"/>
+                  <a:defRPr sz="1800" kern="1200">
+                    <a:solidFill>
+                      <a:schemeClr val="tx1"/>
+                    </a:solidFill>
+                    <a:latin typeface="+mn-lt"/>
+                    <a:ea typeface="+mn-ea"/>
+                    <a:cs typeface="+mn-cs"/>
+                  </a:defRPr>
+                </a:lvl8pPr>
+                <a:lvl9pPr marL="3886200" indent="-228600" algn="l" defTabSz="914400" rtl="0" eaLnBrk="1" latinLnBrk="0" hangingPunct="1">
+                  <a:lnSpc>
+                    <a:spcPct val="90000"/>
+                  </a:lnSpc>
+                  <a:spcBef>
+                    <a:spcPts val="500"/>
+                  </a:spcBef>
+                  <a:buFont typeface="Arial" panose="020B0604020202020204" pitchFamily="34" charset="0"/>
+                  <a:buChar char="•"/>
+                  <a:defRPr sz="1800" kern="1200">
+                    <a:solidFill>
+                      <a:schemeClr val="tx1"/>
+                    </a:solidFill>
+                    <a:latin typeface="+mn-lt"/>
+                    <a:ea typeface="+mn-ea"/>
+                    <a:cs typeface="+mn-cs"/>
+                  </a:defRPr>
+                </a:lvl9pPr>
+              </a:lstStyle>
+              <a:p>
+                <a:pPr marL="0" indent="0">
+                  <a:buNone/>
+                </a:pPr>
+                <a14:m>
+                  <m:oMathPara xmlns:m="http://schemas.openxmlformats.org/officeDocument/2006/math">
+                    <m:oMathParaPr>
+                      <m:jc m:val="centerGroup"/>
+                    </m:oMathParaPr>
+                    <m:oMath xmlns:m="http://schemas.openxmlformats.org/officeDocument/2006/math">
+                      <m:sSub>
+                        <m:sSubPr>
+                          <m:ctrlPr>
+                            <a:rPr lang="en-GB" sz="2000" i="1" smtClean="0">
+                              <a:latin typeface="Cambria Math" panose="02040503050406030204" pitchFamily="18" charset="0"/>
+                            </a:rPr>
+                          </m:ctrlPr>
+                        </m:sSubPr>
+                        <m:e>
+                          <m:r>
+                            <m:rPr>
+                              <m:sty m:val="p"/>
+                            </m:rPr>
+                            <a:rPr lang="en-GB" sz="2000" b="0" i="1" smtClean="0">
+                              <a:latin typeface="Cambria Math" panose="02040503050406030204" pitchFamily="18" charset="0"/>
+                            </a:rPr>
+                            <m:t>F</m:t>
+                          </m:r>
+                        </m:e>
+                        <m:sub>
+                          <m:r>
+                            <a:rPr lang="en-GB" sz="2000" i="1">
+                              <a:latin typeface="Cambria Math" panose="02040503050406030204" pitchFamily="18" charset="0"/>
+                            </a:rPr>
+                            <m:t>𝑃𝑇𝑂</m:t>
+                          </m:r>
+                        </m:sub>
+                      </m:sSub>
+                      <m:r>
+                        <a:rPr lang="en-GB" sz="2000" i="1">
+                          <a:latin typeface="Cambria Math" panose="02040503050406030204" pitchFamily="18" charset="0"/>
+                        </a:rPr>
+                        <m:t>=</m:t>
+                      </m:r>
+                      <m:sSub>
+                        <m:sSubPr>
+                          <m:ctrlPr>
+                            <a:rPr lang="en-GB" sz="2000" i="1">
+                              <a:latin typeface="Cambria Math" panose="02040503050406030204" pitchFamily="18" charset="0"/>
+                            </a:rPr>
+                          </m:ctrlPr>
+                        </m:sSubPr>
+                        <m:e>
+                          <m:r>
+                            <a:rPr lang="en-GB" sz="2000" i="1">
+                              <a:latin typeface="Cambria Math" panose="02040503050406030204" pitchFamily="18" charset="0"/>
+                            </a:rPr>
+                            <m:t>𝑏</m:t>
+                          </m:r>
+                        </m:e>
+                        <m:sub>
+                          <m:r>
+                            <a:rPr lang="en-GB" sz="2000" i="1">
+                              <a:latin typeface="Cambria Math" panose="02040503050406030204" pitchFamily="18" charset="0"/>
+                            </a:rPr>
+                            <m:t>𝑃𝑇𝑂</m:t>
+                          </m:r>
+                        </m:sub>
+                      </m:sSub>
+                      <m:r>
+                        <a:rPr lang="en-GB" sz="2000" i="1">
+                          <a:latin typeface="Cambria Math" panose="02040503050406030204" pitchFamily="18" charset="0"/>
+                        </a:rPr>
+                        <m:t>·</m:t>
+                      </m:r>
+                      <m:r>
+                        <a:rPr lang="en-GB" sz="2000" i="1">
+                          <a:latin typeface="Cambria Math" panose="02040503050406030204" pitchFamily="18" charset="0"/>
+                        </a:rPr>
+                        <m:t>𝑀</m:t>
+                      </m:r>
+                      <m:r>
+                        <a:rPr lang="el-GR" sz="2000" i="1">
+                          <a:latin typeface="Cambria Math" panose="02040503050406030204" pitchFamily="18" charset="0"/>
+                        </a:rPr>
+                        <m:t>𝜔</m:t>
+                      </m:r>
+                      <m:r>
+                        <a:rPr lang="el-GR" sz="2000" i="1">
+                          <a:latin typeface="Cambria Math" panose="02040503050406030204" pitchFamily="18" charset="0"/>
+                        </a:rPr>
+                        <m:t>·</m:t>
+                      </m:r>
+                      <m:acc>
+                        <m:accPr>
+                          <m:chr m:val="̇"/>
+                          <m:ctrlPr>
+                            <a:rPr lang="el-GR" sz="2000" i="1">
+                              <a:latin typeface="Cambria Math" panose="02040503050406030204" pitchFamily="18" charset="0"/>
+                            </a:rPr>
+                          </m:ctrlPr>
+                        </m:accPr>
+                        <m:e>
+                          <m:r>
+                            <a:rPr lang="en-GB" sz="2000" i="1">
+                              <a:latin typeface="Cambria Math" panose="02040503050406030204" pitchFamily="18" charset="0"/>
+                            </a:rPr>
+                            <m:t>𝑦</m:t>
+                          </m:r>
+                        </m:e>
+                      </m:acc>
+                      <m:r>
+                        <a:rPr lang="en-GB" sz="2000" i="1">
+                          <a:latin typeface="Cambria Math" panose="02040503050406030204" pitchFamily="18" charset="0"/>
+                        </a:rPr>
+                        <m:t>−</m:t>
+                      </m:r>
+                      <m:sSub>
+                        <m:sSubPr>
+                          <m:ctrlPr>
+                            <a:rPr lang="en-GB" sz="2000" i="1">
+                              <a:latin typeface="Cambria Math" panose="02040503050406030204" pitchFamily="18" charset="0"/>
+                            </a:rPr>
+                          </m:ctrlPr>
+                        </m:sSubPr>
+                        <m:e>
+                          <m:r>
+                            <a:rPr lang="en-GB" sz="2000" i="1">
+                              <a:latin typeface="Cambria Math" panose="02040503050406030204" pitchFamily="18" charset="0"/>
+                            </a:rPr>
+                            <m:t>𝑘</m:t>
+                          </m:r>
+                        </m:e>
+                        <m:sub>
+                          <m:r>
+                            <a:rPr lang="en-GB" sz="2000" i="1">
+                              <a:latin typeface="Cambria Math" panose="02040503050406030204" pitchFamily="18" charset="0"/>
+                            </a:rPr>
+                            <m:t>𝑠</m:t>
+                          </m:r>
+                        </m:sub>
+                      </m:sSub>
+                      <m:r>
+                        <a:rPr lang="en-GB" sz="2000" i="1">
+                          <a:latin typeface="Cambria Math" panose="02040503050406030204" pitchFamily="18" charset="0"/>
+                        </a:rPr>
+                        <m:t>·</m:t>
+                      </m:r>
+                      <m:r>
+                        <a:rPr lang="en-GB" sz="2000" i="1">
+                          <a:latin typeface="Cambria Math" panose="02040503050406030204" pitchFamily="18" charset="0"/>
+                        </a:rPr>
+                        <m:t>𝑦</m:t>
+                      </m:r>
+                    </m:oMath>
+                  </m:oMathPara>
+                </a14:m>
+                <a:endParaRPr lang="en-GB"/>
+              </a:p>
+              <a:p>
+                <a:r>
+                  <a:rPr lang="en-GB" sz="2000"/>
+                  <a:t>Velocity component is added to displacement</a:t>
+                </a:r>
+              </a:p>
+              <a:p>
+                <a:r>
+                  <a:rPr lang="en-GB" sz="2000"/>
+                  <a:t>Brings buoy closer to resonance</a:t>
+                </a:r>
+              </a:p>
+            </p:txBody>
+          </p:sp>
+        </mc:Choice>
+        <mc:Fallback>
+          <p:sp>
+            <p:nvSpPr>
+              <p:cNvPr id="14" name="Content Placeholder 2">
+                <a:extLst>
+                  <a:ext uri="{FF2B5EF4-FFF2-40B4-BE49-F238E27FC236}">
+                    <a16:creationId xmlns:a16="http://schemas.microsoft.com/office/drawing/2014/main" id="{937B966B-77AE-B788-C527-146DBD98B8AC}"/>
+                  </a:ext>
+                </a:extLst>
+              </p:cNvPr>
+              <p:cNvSpPr txBox="1">
+                <a:spLocks noRot="1" noChangeAspect="1" noMove="1" noResize="1" noEditPoints="1" noAdjustHandles="1" noChangeArrowheads="1" noChangeShapeType="1" noTextEdit="1"/>
+              </p:cNvSpPr>
+              <p:nvPr/>
+            </p:nvSpPr>
+            <p:spPr>
+              <a:xfrm>
+                <a:off x="7898650" y="2212617"/>
+                <a:ext cx="3437334" cy="3579549"/>
+              </a:xfrm>
+              <a:prstGeom prst="rect">
+                <a:avLst/>
+              </a:prstGeom>
+              <a:blipFill>
+                <a:blip r:embed="rId5"/>
+                <a:stretch>
+                  <a:fillRect l="-1596" r="-2305"/>
+                </a:stretch>
+              </a:blipFill>
+            </p:spPr>
+            <p:txBody>
+              <a:bodyPr/>
+              <a:lstStyle/>
+              <a:p>
+                <a:r>
+                  <a:rPr lang="en-US">
+                    <a:noFill/>
+                  </a:rPr>
+                  <a:t> </a:t>
+                </a:r>
+              </a:p>
+            </p:txBody>
+          </p:sp>
+        </mc:Fallback>
+      </mc:AlternateContent>
+      <p:sp>
+        <p:nvSpPr>
+          <p:cNvPr id="19" name="Text Placeholder 3">
+            <a:extLst>
+              <a:ext uri="{FF2B5EF4-FFF2-40B4-BE49-F238E27FC236}">
+                <a16:creationId xmlns:a16="http://schemas.microsoft.com/office/drawing/2014/main" id="{5256D2AB-7736-2765-FD19-892AE06456E0}"/>
+              </a:ext>
+            </a:extLst>
+          </p:cNvPr>
+          <p:cNvSpPr txBox="1">
+            <a:spLocks/>
+          </p:cNvSpPr>
+          <p:nvPr/>
+        </p:nvSpPr>
+        <p:spPr>
+          <a:xfrm>
+            <a:off x="7910556" y="1295572"/>
+            <a:ext cx="3419475" cy="817959"/>
+          </a:xfrm>
+          <a:prstGeom prst="rect">
+            <a:avLst/>
+          </a:prstGeom>
+        </p:spPr>
+        <p:txBody>
+          <a:bodyPr vert="horz" lIns="91440" tIns="45720" rIns="91440" bIns="45720" rtlCol="0" anchor="b">
+            <a:normAutofit/>
+          </a:bodyPr>
+          <a:lstStyle>
+            <a:lvl1pPr marL="0" indent="0" algn="l" defTabSz="914400" rtl="0" eaLnBrk="1" latinLnBrk="0" hangingPunct="1">
+              <a:lnSpc>
+                <a:spcPct val="90000"/>
+              </a:lnSpc>
+              <a:spcBef>
+                <a:spcPts val="1000"/>
+              </a:spcBef>
+              <a:buFont typeface="Arial" panose="020B0604020202020204" pitchFamily="34" charset="0"/>
+              <a:buNone/>
+              <a:defRPr sz="2400" b="1" kern="1200">
+                <a:solidFill>
+                  <a:schemeClr val="tx1"/>
+                </a:solidFill>
+                <a:latin typeface="+mn-lt"/>
+                <a:ea typeface="+mn-ea"/>
+                <a:cs typeface="+mn-cs"/>
+              </a:defRPr>
+            </a:lvl1pPr>
+            <a:lvl2pPr marL="457200" indent="0" algn="l" defTabSz="914400" rtl="0" eaLnBrk="1" latinLnBrk="0" hangingPunct="1">
+              <a:lnSpc>
+                <a:spcPct val="90000"/>
+              </a:lnSpc>
+              <a:spcBef>
+                <a:spcPts val="500"/>
+              </a:spcBef>
+              <a:buFont typeface="Arial" panose="020B0604020202020204" pitchFamily="34" charset="0"/>
+              <a:buNone/>
+              <a:defRPr sz="2000" b="1" kern="1200">
+                <a:solidFill>
+                  <a:schemeClr val="tx1"/>
+                </a:solidFill>
+                <a:latin typeface="+mn-lt"/>
+                <a:ea typeface="+mn-ea"/>
+                <a:cs typeface="+mn-cs"/>
+              </a:defRPr>
+            </a:lvl2pPr>
+            <a:lvl3pPr marL="914400" indent="0" algn="l" defTabSz="914400" rtl="0" eaLnBrk="1" latinLnBrk="0" hangingPunct="1">
+              <a:lnSpc>
+                <a:spcPct val="90000"/>
+              </a:lnSpc>
+              <a:spcBef>
+                <a:spcPts val="500"/>
+              </a:spcBef>
+              <a:buFont typeface="Arial" panose="020B0604020202020204" pitchFamily="34" charset="0"/>
+              <a:buNone/>
+              <a:defRPr sz="1800" b="1" kern="1200">
+                <a:solidFill>
+                  <a:schemeClr val="tx1"/>
+                </a:solidFill>
+                <a:latin typeface="+mn-lt"/>
+                <a:ea typeface="+mn-ea"/>
+                <a:cs typeface="+mn-cs"/>
+              </a:defRPr>
+            </a:lvl3pPr>
+            <a:lvl4pPr marL="1371600" indent="0" algn="l" defTabSz="914400" rtl="0" eaLnBrk="1" latinLnBrk="0" hangingPunct="1">
+              <a:lnSpc>
+                <a:spcPct val="90000"/>
+              </a:lnSpc>
+              <a:spcBef>
+                <a:spcPts val="500"/>
+              </a:spcBef>
+              <a:buFont typeface="Arial" panose="020B0604020202020204" pitchFamily="34" charset="0"/>
+              <a:buNone/>
+              <a:defRPr sz="1600" b="1" kern="1200">
+                <a:solidFill>
+                  <a:schemeClr val="tx1"/>
+                </a:solidFill>
+                <a:latin typeface="+mn-lt"/>
+                <a:ea typeface="+mn-ea"/>
+                <a:cs typeface="+mn-cs"/>
+              </a:defRPr>
+            </a:lvl4pPr>
+            <a:lvl5pPr marL="1828800" indent="0" algn="l" defTabSz="914400" rtl="0" eaLnBrk="1" latinLnBrk="0" hangingPunct="1">
+              <a:lnSpc>
+                <a:spcPct val="90000"/>
+              </a:lnSpc>
+              <a:spcBef>
+                <a:spcPts val="500"/>
+              </a:spcBef>
+              <a:buFont typeface="Arial" panose="020B0604020202020204" pitchFamily="34" charset="0"/>
+              <a:buNone/>
+              <a:defRPr sz="1600" b="1" kern="1200">
+                <a:solidFill>
+                  <a:schemeClr val="tx1"/>
+                </a:solidFill>
+                <a:latin typeface="+mn-lt"/>
+                <a:ea typeface="+mn-ea"/>
+                <a:cs typeface="+mn-cs"/>
+              </a:defRPr>
+            </a:lvl5pPr>
+            <a:lvl6pPr marL="2286000" indent="0" algn="l" defTabSz="914400" rtl="0" eaLnBrk="1" latinLnBrk="0" hangingPunct="1">
+              <a:lnSpc>
+                <a:spcPct val="90000"/>
+              </a:lnSpc>
+              <a:spcBef>
+                <a:spcPts val="500"/>
+              </a:spcBef>
+              <a:buFont typeface="Arial" panose="020B0604020202020204" pitchFamily="34" charset="0"/>
+              <a:buNone/>
+              <a:defRPr sz="1600" b="1" kern="1200">
+                <a:solidFill>
+                  <a:schemeClr val="tx1"/>
+                </a:solidFill>
+                <a:latin typeface="+mn-lt"/>
+                <a:ea typeface="+mn-ea"/>
+                <a:cs typeface="+mn-cs"/>
+              </a:defRPr>
+            </a:lvl6pPr>
+            <a:lvl7pPr marL="2743200" indent="0" algn="l" defTabSz="914400" rtl="0" eaLnBrk="1" latinLnBrk="0" hangingPunct="1">
+              <a:lnSpc>
+                <a:spcPct val="90000"/>
+              </a:lnSpc>
+              <a:spcBef>
+                <a:spcPts val="500"/>
+              </a:spcBef>
+              <a:buFont typeface="Arial" panose="020B0604020202020204" pitchFamily="34" charset="0"/>
+              <a:buNone/>
+              <a:defRPr sz="1600" b="1" kern="1200">
+                <a:solidFill>
+                  <a:schemeClr val="tx1"/>
+                </a:solidFill>
+                <a:latin typeface="+mn-lt"/>
+                <a:ea typeface="+mn-ea"/>
+                <a:cs typeface="+mn-cs"/>
+              </a:defRPr>
+            </a:lvl7pPr>
+            <a:lvl8pPr marL="3200400" indent="0" algn="l" defTabSz="914400" rtl="0" eaLnBrk="1" latinLnBrk="0" hangingPunct="1">
+              <a:lnSpc>
+                <a:spcPct val="90000"/>
+              </a:lnSpc>
+              <a:spcBef>
+                <a:spcPts val="500"/>
+              </a:spcBef>
+              <a:buFont typeface="Arial" panose="020B0604020202020204" pitchFamily="34" charset="0"/>
+              <a:buNone/>
+              <a:defRPr sz="1600" b="1" kern="1200">
+                <a:solidFill>
+                  <a:schemeClr val="tx1"/>
+                </a:solidFill>
+                <a:latin typeface="+mn-lt"/>
+                <a:ea typeface="+mn-ea"/>
+                <a:cs typeface="+mn-cs"/>
+              </a:defRPr>
+            </a:lvl8pPr>
+            <a:lvl9pPr marL="3657600" indent="0" algn="l" defTabSz="914400" rtl="0" eaLnBrk="1" latinLnBrk="0" hangingPunct="1">
+              <a:lnSpc>
+                <a:spcPct val="90000"/>
+              </a:lnSpc>
+              <a:spcBef>
+                <a:spcPts val="500"/>
+              </a:spcBef>
+              <a:buFont typeface="Arial" panose="020B0604020202020204" pitchFamily="34" charset="0"/>
+              <a:buNone/>
+              <a:defRPr sz="1600" b="1" kern="1200">
+                <a:solidFill>
+                  <a:schemeClr val="tx1"/>
+                </a:solidFill>
+                <a:latin typeface="+mn-lt"/>
+                <a:ea typeface="+mn-ea"/>
+                <a:cs typeface="+mn-cs"/>
+              </a:defRPr>
+            </a:lvl9pPr>
+          </a:lstStyle>
+          <a:p>
+            <a:r>
+              <a:rPr lang="en-GB"/>
+              <a:t>Velocity</a:t>
             </a:r>
           </a:p>
         </p:txBody>
@@ -7414,7 +10711,7 @@
     </p:spTree>
     <p:extLst>
       <p:ext uri="{BB962C8B-B14F-4D97-AF65-F5344CB8AC3E}">
-        <p14:creationId xmlns:p14="http://schemas.microsoft.com/office/powerpoint/2010/main" val="240379788"/>
+        <p14:creationId xmlns:p14="http://schemas.microsoft.com/office/powerpoint/2010/main" val="2286299515"/>
       </p:ext>
     </p:extLst>
   </p:cSld>
@@ -7737,4 +11034,319 @@
     </a:ext>
   </a:extLst>
 </a:theme>
+</file>
+
+<file path=ppt/theme/theme2.xml><?xml version="1.0" encoding="utf-8"?>
+<a:theme xmlns:a="http://schemas.openxmlformats.org/drawingml/2006/main" name="Office Theme">
+  <a:themeElements>
+    <a:clrScheme name="Office">
+      <a:dk1>
+        <a:sysClr val="windowText" lastClr="000000"/>
+      </a:dk1>
+      <a:lt1>
+        <a:sysClr val="window" lastClr="FFFFFF"/>
+      </a:lt1>
+      <a:dk2>
+        <a:srgbClr val="0E2841"/>
+      </a:dk2>
+      <a:lt2>
+        <a:srgbClr val="E8E8E8"/>
+      </a:lt2>
+      <a:accent1>
+        <a:srgbClr val="156082"/>
+      </a:accent1>
+      <a:accent2>
+        <a:srgbClr val="E97132"/>
+      </a:accent2>
+      <a:accent3>
+        <a:srgbClr val="196B24"/>
+      </a:accent3>
+      <a:accent4>
+        <a:srgbClr val="0F9ED5"/>
+      </a:accent4>
+      <a:accent5>
+        <a:srgbClr val="A02B93"/>
+      </a:accent5>
+      <a:accent6>
+        <a:srgbClr val="4EA72E"/>
+      </a:accent6>
+      <a:hlink>
+        <a:srgbClr val="467886"/>
+      </a:hlink>
+      <a:folHlink>
+        <a:srgbClr val="96607D"/>
+      </a:folHlink>
+    </a:clrScheme>
+    <a:fontScheme name="Office">
+      <a:majorFont>
+        <a:latin typeface="Aptos Display" panose="02110004020202020204"/>
+        <a:ea typeface=""/>
+        <a:cs typeface=""/>
+        <a:font script="Jpan" typeface="游ゴシック Light"/>
+        <a:font script="Hang" typeface="맑은 고딕"/>
+        <a:font script="Hans" typeface="等线 Light"/>
+        <a:font script="Hant" typeface="新細明體"/>
+        <a:font script="Arab" typeface="Times New Roman"/>
+        <a:font script="Hebr" typeface="Times New Roman"/>
+        <a:font script="Thai" typeface="Angsana New"/>
+        <a:font script="Ethi" typeface="Nyala"/>
+        <a:font script="Beng" typeface="Vrinda"/>
+        <a:font script="Gujr" typeface="Shruti"/>
+        <a:font script="Khmr" typeface="MoolBoran"/>
+        <a:font script="Knda" typeface="Tunga"/>
+        <a:font script="Guru" typeface="Raavi"/>
+        <a:font script="Cans" typeface="Euphemia"/>
+        <a:font script="Cher" typeface="Plantagenet Cherokee"/>
+        <a:font script="Yiii" typeface="Microsoft Yi Baiti"/>
+        <a:font script="Tibt" typeface="Microsoft Himalaya"/>
+        <a:font script="Thaa" typeface="MV Boli"/>
+        <a:font script="Deva" typeface="Mangal"/>
+        <a:font script="Telu" typeface="Gautami"/>
+        <a:font script="Taml" typeface="Latha"/>
+        <a:font script="Syrc" typeface="Estrangelo Edessa"/>
+        <a:font script="Orya" typeface="Kalinga"/>
+        <a:font script="Mlym" typeface="Kartika"/>
+        <a:font script="Laoo" typeface="DokChampa"/>
+        <a:font script="Sinh" typeface="Iskoola Pota"/>
+        <a:font script="Mong" typeface="Mongolian Baiti"/>
+        <a:font script="Viet" typeface="Times New Roman"/>
+        <a:font script="Uigh" typeface="Microsoft Uighur"/>
+        <a:font script="Geor" typeface="Sylfaen"/>
+        <a:font script="Armn" typeface="Arial"/>
+        <a:font script="Bugi" typeface="Leelawadee UI"/>
+        <a:font script="Bopo" typeface="Microsoft JhengHei"/>
+        <a:font script="Java" typeface="Javanese Text"/>
+        <a:font script="Lisu" typeface="Segoe UI"/>
+        <a:font script="Mymr" typeface="Myanmar Text"/>
+        <a:font script="Nkoo" typeface="Ebrima"/>
+        <a:font script="Olck" typeface="Nirmala UI"/>
+        <a:font script="Osma" typeface="Ebrima"/>
+        <a:font script="Phag" typeface="Phagspa"/>
+        <a:font script="Syrn" typeface="Estrangelo Edessa"/>
+        <a:font script="Syrj" typeface="Estrangelo Edessa"/>
+        <a:font script="Syre" typeface="Estrangelo Edessa"/>
+        <a:font script="Sora" typeface="Nirmala UI"/>
+        <a:font script="Tale" typeface="Microsoft Tai Le"/>
+        <a:font script="Talu" typeface="Microsoft New Tai Lue"/>
+        <a:font script="Tfng" typeface="Ebrima"/>
+      </a:majorFont>
+      <a:minorFont>
+        <a:latin typeface="Aptos" panose="02110004020202020204"/>
+        <a:ea typeface=""/>
+        <a:cs typeface=""/>
+        <a:font script="Jpan" typeface="游ゴシック"/>
+        <a:font script="Hang" typeface="맑은 고딕"/>
+        <a:font script="Hans" typeface="等线"/>
+        <a:font script="Hant" typeface="新細明體"/>
+        <a:font script="Arab" typeface="Arial"/>
+        <a:font script="Hebr" typeface="Arial"/>
+        <a:font script="Thai" typeface="Cordia New"/>
+        <a:font script="Ethi" typeface="Nyala"/>
+        <a:font script="Beng" typeface="Vrinda"/>
+        <a:font script="Gujr" typeface="Shruti"/>
+        <a:font script="Khmr" typeface="DaunPenh"/>
+        <a:font script="Knda" typeface="Tunga"/>
+        <a:font script="Guru" typeface="Raavi"/>
+        <a:font script="Cans" typeface="Euphemia"/>
+        <a:font script="Cher" typeface="Plantagenet Cherokee"/>
+        <a:font script="Yiii" typeface="Microsoft Yi Baiti"/>
+        <a:font script="Tibt" typeface="Microsoft Himalaya"/>
+        <a:font script="Thaa" typeface="MV Boli"/>
+        <a:font script="Deva" typeface="Mangal"/>
+        <a:font script="Telu" typeface="Gautami"/>
+        <a:font script="Taml" typeface="Latha"/>
+        <a:font script="Syrc" typeface="Estrangelo Edessa"/>
+        <a:font script="Orya" typeface="Kalinga"/>
+        <a:font script="Mlym" typeface="Kartika"/>
+        <a:font script="Laoo" typeface="DokChampa"/>
+        <a:font script="Sinh" typeface="Iskoola Pota"/>
+        <a:font script="Mong" typeface="Mongolian Baiti"/>
+        <a:font script="Viet" typeface="Arial"/>
+        <a:font script="Uigh" typeface="Microsoft Uighur"/>
+        <a:font script="Geor" typeface="Sylfaen"/>
+        <a:font script="Armn" typeface="Arial"/>
+        <a:font script="Bugi" typeface="Leelawadee UI"/>
+        <a:font script="Bopo" typeface="Microsoft JhengHei"/>
+        <a:font script="Java" typeface="Javanese Text"/>
+        <a:font script="Lisu" typeface="Segoe UI"/>
+        <a:font script="Mymr" typeface="Myanmar Text"/>
+        <a:font script="Nkoo" typeface="Ebrima"/>
+        <a:font script="Olck" typeface="Nirmala UI"/>
+        <a:font script="Osma" typeface="Ebrima"/>
+        <a:font script="Phag" typeface="Phagspa"/>
+        <a:font script="Syrn" typeface="Estrangelo Edessa"/>
+        <a:font script="Syrj" typeface="Estrangelo Edessa"/>
+        <a:font script="Syre" typeface="Estrangelo Edessa"/>
+        <a:font script="Sora" typeface="Nirmala UI"/>
+        <a:font script="Tale" typeface="Microsoft Tai Le"/>
+        <a:font script="Talu" typeface="Microsoft New Tai Lue"/>
+        <a:font script="Tfng" typeface="Ebrima"/>
+      </a:minorFont>
+    </a:fontScheme>
+    <a:fmtScheme name="Office">
+      <a:fillStyleLst>
+        <a:solidFill>
+          <a:schemeClr val="phClr"/>
+        </a:solidFill>
+        <a:gradFill rotWithShape="1">
+          <a:gsLst>
+            <a:gs pos="0">
+              <a:schemeClr val="phClr">
+                <a:lumMod val="110000"/>
+                <a:satMod val="105000"/>
+                <a:tint val="67000"/>
+              </a:schemeClr>
+            </a:gs>
+            <a:gs pos="50000">
+              <a:schemeClr val="phClr">
+                <a:lumMod val="105000"/>
+                <a:satMod val="103000"/>
+                <a:tint val="73000"/>
+              </a:schemeClr>
+            </a:gs>
+            <a:gs pos="100000">
+              <a:schemeClr val="phClr">
+                <a:lumMod val="105000"/>
+                <a:satMod val="109000"/>
+                <a:tint val="81000"/>
+              </a:schemeClr>
+            </a:gs>
+          </a:gsLst>
+          <a:lin ang="5400000" scaled="0"/>
+        </a:gradFill>
+        <a:gradFill rotWithShape="1">
+          <a:gsLst>
+            <a:gs pos="0">
+              <a:schemeClr val="phClr">
+                <a:satMod val="103000"/>
+                <a:lumMod val="102000"/>
+                <a:tint val="94000"/>
+              </a:schemeClr>
+            </a:gs>
+            <a:gs pos="50000">
+              <a:schemeClr val="phClr">
+                <a:satMod val="110000"/>
+                <a:lumMod val="100000"/>
+                <a:shade val="100000"/>
+              </a:schemeClr>
+            </a:gs>
+            <a:gs pos="100000">
+              <a:schemeClr val="phClr">
+                <a:lumMod val="99000"/>
+                <a:satMod val="120000"/>
+                <a:shade val="78000"/>
+              </a:schemeClr>
+            </a:gs>
+          </a:gsLst>
+          <a:lin ang="5400000" scaled="0"/>
+        </a:gradFill>
+      </a:fillStyleLst>
+      <a:lnStyleLst>
+        <a:ln w="12700" cap="flat" cmpd="sng" algn="ctr">
+          <a:solidFill>
+            <a:schemeClr val="phClr"/>
+          </a:solidFill>
+          <a:prstDash val="solid"/>
+          <a:miter lim="800000"/>
+        </a:ln>
+        <a:ln w="19050" cap="flat" cmpd="sng" algn="ctr">
+          <a:solidFill>
+            <a:schemeClr val="phClr"/>
+          </a:solidFill>
+          <a:prstDash val="solid"/>
+          <a:miter lim="800000"/>
+        </a:ln>
+        <a:ln w="25400" cap="flat" cmpd="sng" algn="ctr">
+          <a:solidFill>
+            <a:schemeClr val="phClr"/>
+          </a:solidFill>
+          <a:prstDash val="solid"/>
+          <a:miter lim="800000"/>
+        </a:ln>
+      </a:lnStyleLst>
+      <a:effectStyleLst>
+        <a:effectStyle>
+          <a:effectLst/>
+        </a:effectStyle>
+        <a:effectStyle>
+          <a:effectLst/>
+        </a:effectStyle>
+        <a:effectStyle>
+          <a:effectLst>
+            <a:outerShdw blurRad="57150" dist="19050" dir="5400000" algn="ctr" rotWithShape="0">
+              <a:srgbClr val="000000">
+                <a:alpha val="63000"/>
+              </a:srgbClr>
+            </a:outerShdw>
+          </a:effectLst>
+        </a:effectStyle>
+      </a:effectStyleLst>
+      <a:bgFillStyleLst>
+        <a:solidFill>
+          <a:schemeClr val="phClr"/>
+        </a:solidFill>
+        <a:solidFill>
+          <a:schemeClr val="phClr">
+            <a:tint val="95000"/>
+            <a:satMod val="170000"/>
+          </a:schemeClr>
+        </a:solidFill>
+        <a:gradFill rotWithShape="1">
+          <a:gsLst>
+            <a:gs pos="0">
+              <a:schemeClr val="phClr">
+                <a:tint val="93000"/>
+                <a:satMod val="150000"/>
+                <a:shade val="98000"/>
+                <a:lumMod val="102000"/>
+              </a:schemeClr>
+            </a:gs>
+            <a:gs pos="50000">
+              <a:schemeClr val="phClr">
+                <a:tint val="98000"/>
+                <a:satMod val="130000"/>
+                <a:shade val="90000"/>
+                <a:lumMod val="103000"/>
+              </a:schemeClr>
+            </a:gs>
+            <a:gs pos="100000">
+              <a:schemeClr val="phClr">
+                <a:shade val="63000"/>
+                <a:satMod val="120000"/>
+              </a:schemeClr>
+            </a:gs>
+          </a:gsLst>
+          <a:lin ang="5400000" scaled="0"/>
+        </a:gradFill>
+      </a:bgFillStyleLst>
+    </a:fmtScheme>
+  </a:themeElements>
+  <a:objectDefaults>
+    <a:lnDef>
+      <a:spPr/>
+      <a:bodyPr/>
+      <a:lstStyle/>
+      <a:style>
+        <a:lnRef idx="2">
+          <a:schemeClr val="accent1"/>
+        </a:lnRef>
+        <a:fillRef idx="0">
+          <a:schemeClr val="accent1"/>
+        </a:fillRef>
+        <a:effectRef idx="1">
+          <a:schemeClr val="accent1"/>
+        </a:effectRef>
+        <a:fontRef idx="minor">
+          <a:schemeClr val="tx1"/>
+        </a:fontRef>
+      </a:style>
+    </a:lnDef>
+  </a:objectDefaults>
+  <a:extraClrSchemeLst/>
+  <a:extLst>
+    <a:ext uri="{05A4C25C-085E-4340-85A3-A5531E510DB2}">
+      <thm15:themeFamily xmlns:thm15="http://schemas.microsoft.com/office/thememl/2012/main" name="Office Theme" id="{2E142A2C-CD16-42D6-873A-C26D2A0506FA}" vid="{1BDDFF52-6CD6-40A5-AB3C-68EB2F1E4D0A}"/>
+    </a:ext>
+  </a:extLst>
+</a:theme>
 </file>
</xml_diff>